<commit_message>
Integrate teammate UI, calendar, course interests and RAG metadata with final presentation
</commit_message>
<xml_diff>
--- a/artifacts/jolup-presentation-20261026.pptx
+++ b/artifacts/jolup-presentation-20261026.pptx
@@ -2,34 +2,34 @@
 <file path=ppt/presentation.xml><?xml version="1.0" encoding="utf-8"?>
 <p:presentation xmlns:p="http://schemas.openxmlformats.org/presentationml/2006/main" embedTrueTypeFonts="1" saveSubsetFonts="0">
   <p:sldMasterIdLst>
-    <p:sldMasterId xmlns:r="http://schemas.openxmlformats.org/officeDocument/2006/relationships" id="2147483648" r:id="R57ecc72546ed464e"/>
+    <p:sldMasterId xmlns:r="http://schemas.openxmlformats.org/officeDocument/2006/relationships" id="2147483648" r:id="Rbdb635e2d1854587"/>
   </p:sldMasterIdLst>
   <p:notesMasterIdLst>
-    <p:notesMasterId xmlns:r="http://schemas.openxmlformats.org/officeDocument/2006/relationships" r:id="R0e68666e81464669"/>
+    <p:notesMasterId xmlns:r="http://schemas.openxmlformats.org/officeDocument/2006/relationships" r:id="R62df02f31f214e92"/>
   </p:notesMasterIdLst>
   <p:sldIdLst>
-    <p:sldId xmlns:r="http://schemas.openxmlformats.org/officeDocument/2006/relationships" id="256" r:id="R66c1724078a2497b"/>
-    <p:sldId xmlns:r="http://schemas.openxmlformats.org/officeDocument/2006/relationships" id="257" r:id="Reaef76c0b9b64483"/>
-    <p:sldId xmlns:r="http://schemas.openxmlformats.org/officeDocument/2006/relationships" id="258" r:id="Re118fe0bca69496d"/>
-    <p:sldId xmlns:r="http://schemas.openxmlformats.org/officeDocument/2006/relationships" id="259" r:id="R4babf0dd255243cf"/>
-    <p:sldId xmlns:r="http://schemas.openxmlformats.org/officeDocument/2006/relationships" id="260" r:id="Ra95ed7a2958143d3"/>
-    <p:sldId xmlns:r="http://schemas.openxmlformats.org/officeDocument/2006/relationships" id="261" r:id="Ra6b93682deaf4ee7"/>
-    <p:sldId xmlns:r="http://schemas.openxmlformats.org/officeDocument/2006/relationships" id="262" r:id="R078acd79cfd940ea"/>
-    <p:sldId xmlns:r="http://schemas.openxmlformats.org/officeDocument/2006/relationships" id="263" r:id="Rba390a87270c4b25"/>
-    <p:sldId xmlns:r="http://schemas.openxmlformats.org/officeDocument/2006/relationships" id="264" r:id="R241b92c3803043c1"/>
-    <p:sldId xmlns:r="http://schemas.openxmlformats.org/officeDocument/2006/relationships" id="265" r:id="R3ba3766d326a408e"/>
-    <p:sldId xmlns:r="http://schemas.openxmlformats.org/officeDocument/2006/relationships" id="266" r:id="R1d10c9af3d6042b3"/>
-    <p:sldId xmlns:r="http://schemas.openxmlformats.org/officeDocument/2006/relationships" id="267" r:id="R2cb9eaf5179743ab"/>
-    <p:sldId xmlns:r="http://schemas.openxmlformats.org/officeDocument/2006/relationships" id="268" r:id="R4391cac043f4465c"/>
-    <p:sldId xmlns:r="http://schemas.openxmlformats.org/officeDocument/2006/relationships" id="269" r:id="R070179e4933c42c5"/>
+    <p:sldId xmlns:r="http://schemas.openxmlformats.org/officeDocument/2006/relationships" id="256" r:id="R8e717665788f4650"/>
+    <p:sldId xmlns:r="http://schemas.openxmlformats.org/officeDocument/2006/relationships" id="257" r:id="Rd919fa0c4b7a498f"/>
+    <p:sldId xmlns:r="http://schemas.openxmlformats.org/officeDocument/2006/relationships" id="258" r:id="R6186806fe28846c9"/>
+    <p:sldId xmlns:r="http://schemas.openxmlformats.org/officeDocument/2006/relationships" id="259" r:id="R1fa565f3b5c54233"/>
+    <p:sldId xmlns:r="http://schemas.openxmlformats.org/officeDocument/2006/relationships" id="260" r:id="Rf2d9719e8b644f03"/>
+    <p:sldId xmlns:r="http://schemas.openxmlformats.org/officeDocument/2006/relationships" id="261" r:id="R2201558740164367"/>
+    <p:sldId xmlns:r="http://schemas.openxmlformats.org/officeDocument/2006/relationships" id="262" r:id="Rb2d687a7fdae4b5f"/>
+    <p:sldId xmlns:r="http://schemas.openxmlformats.org/officeDocument/2006/relationships" id="263" r:id="Raf9a5dbdd85343a6"/>
+    <p:sldId xmlns:r="http://schemas.openxmlformats.org/officeDocument/2006/relationships" id="264" r:id="Rf9bbf16312f348e8"/>
+    <p:sldId xmlns:r="http://schemas.openxmlformats.org/officeDocument/2006/relationships" id="265" r:id="R48d7650530aa44fa"/>
+    <p:sldId xmlns:r="http://schemas.openxmlformats.org/officeDocument/2006/relationships" id="266" r:id="R25ca98ba47554615"/>
+    <p:sldId xmlns:r="http://schemas.openxmlformats.org/officeDocument/2006/relationships" id="267" r:id="R1066e8bd9b6a44a6"/>
+    <p:sldId xmlns:r="http://schemas.openxmlformats.org/officeDocument/2006/relationships" id="268" r:id="R5ceb643dbe8d49ff"/>
+    <p:sldId xmlns:r="http://schemas.openxmlformats.org/officeDocument/2006/relationships" id="269" r:id="R6b55e1b17e4a4a58"/>
   </p:sldIdLst>
   <p:sldSz cx="12192000" cy="6858000"/>
   <p:notesSz cx="6858000" cy="9144000"/>
   <p:embeddedFontLst>
     <p:embeddedFont>
       <p:font typeface="IBM Plex Sans KR"/>
-      <p:regular xmlns:r="http://schemas.openxmlformats.org/officeDocument/2006/relationships" r:id="R2d5f6ef68b474457"/>
-      <p:bold xmlns:r="http://schemas.openxmlformats.org/officeDocument/2006/relationships" r:id="R42a20f9dca6b468d"/>
+      <p:regular xmlns:r="http://schemas.openxmlformats.org/officeDocument/2006/relationships" r:id="Rbc781b00d1df4011"/>
+      <p:bold xmlns:r="http://schemas.openxmlformats.org/officeDocument/2006/relationships" r:id="R952a506ad54847a5"/>
     </p:embeddedFont>
   </p:embeddedFontLst>
   <p:defaultTextStyle>
@@ -884,7 +884,7 @@
               <a:buNone/>
             </a:pPr>
             <a:r>
-              <a:t>60초. 테스트 수와 커버리지는 최종 reports/quality/manifest.json, junit.xml, coverage.json에 연결한다. 범위는 app.py/jolup/scripts이고 외부 라이브러리와 테스트 자체를 포함한 모든 소프트웨어라는 뜻이 아니다. 규정 답변20/20은 숫자·조건·출처 기대검사이며 source_context 보완을 포함한다. ChatGPT3/3은 핵심 인수 기준이다. 기존검색 hit@5 17/20, 추가표현11/12는 각각 다른 평가다. 추가표현은 개발과 독립인 holdout이 아니다. 동결한 최신 코드와 coverage XML로 Sonar 재분석했다. 인지 복잡도 S3776 임계15에서 열린 경고0, 커버리지100, 중복0, bug0이다. 전체 열린 지적39건이며 새 지적12가0기준을 넘겨 품질문은 ERROR다. 0은 복잡도 경고에만 해당한다. reports/quality/sonar-final-20261026.json. 최신 Docker 실행 검증은 대기다.</a:t>
+              <a:t>60초. 최신 자동 검사와 실행문/분기 커버리지는 통합 후 reports/quality/manifest.json의 동일 소스 측정이다. 과거 777개 기록을 최신 수치로 재사용하지 않는다. 이전 ChatGPT 인수시험3/3과 검색 hit@5 17/20, 토큰잘림0/448은 측정 시점의 자료다. 통합 후 실제 벡터 포함 회귀시험으로 정상 답변·NFD·메타·UI·달력·관심목록·기존계산을 확인한다. 통합 전 Sonar는 S3776 임계15에서 복잡도경고0, 품질문ERROR(신규12)였으며 새 소스 전체의 Sonar 통과를 의미하지 않는다. 최신 Docker4서비스·Claude실계정은 별도 미검증이다. 출처: docs/검증결과.md, docs/팀원_통합결과.md.</a:t>
             </a:r>
             <a:endParaRPr/>
           </a:p>
@@ -964,7 +964,7 @@
               <a:buNone/>
             </a:pPr>
             <a:r>
-              <a:t>40초. ChatGPT 자료 누락 v1에서 현재 판정을 단순 미충족으로 표현하고 파일명 메타가 부정확했다. 누락 우선 규칙·정확한 파일명과 문서 제목 구분을 명시한 v2로 3사례 재시험했다. 학점 계산의 F재수강 등은 실제 실패테스트로 개선했다. TDD 학습 replay21건과 실제 이번 Red→Green 수정 기록을 구분한다. 출처: reports/chatgpt_acceptance_20261025.json, reports/domain_correctness_validation.json, reports/tdd_study/, reports/practice_agent_red.xml.</a:t>
+              <a:t>40초. 주미의 NFC 테스트를 현재 제품에 옮기면서 같은 한글의 분해형(NFD) 질문이 검색·범위 검사에서 누락되는 결함을 실제 Red로 재현했다. 비교용 문자열만 정규화하고 인용 원문은 보존한다. 수진의 디자인과 달력·관심목록을 연결하되 시안의 고정85/130·고정일정을 실제학교 자료로 바꿨다. 제공되지 않은 PDF/XLSX파싱과 rag 구현은 있는 것처럼 주장하지 않는다. 제출원본·실제적용·변경사유는 team_contributions와 docs/팀원_통합결과.md.</a:t>
             </a:r>
             <a:endParaRPr/>
           </a:p>
@@ -1044,7 +1044,7 @@
               <a:buNone/>
             </a:pPr>
             <a:r>
-              <a:t>30초. 팀원 자료 미수령은 이번 수업자료 대조와 다르다. 수업 이론·실습은 제공된 범위를 읽어 대조했고 팀원 최종 구현은 수령 후 통합한다. 별도 DB나 클라우드 등은 필요 요건이 생길 때 채택한다. Windows·시연영상은 제외, 보안·성능 확대는 현재 과제 범위에 추가하지 않았다.</a:t>
+              <a:t>30초. 팀원 자료의 합집합 통합은 완료했으나 ZIP에 없는 rag 구현은 후속 비교 대상이다. PDF/XLSX는 시안이 파일명만 읽었으므로 제품의 검증된 CSV 입력을 유지했다. 실제 표 파서·회귀 검증을 갖춘 뒤 확장할 수 있다. Sonar 재분석·새 Docker기동·독립 검색평가와 실제 미래개설자료는 별도 과제다. Windows·시연영상은 합의된 제외다.</a:t>
             </a:r>
             <a:endParaRPr/>
           </a:p>
@@ -1124,7 +1124,7 @@
               <a:buNone/>
             </a:pPr>
             <a:r>
-              <a:t>질의응답. 예상 질문: 1) 청킹이 왜 필요한가? 임베딩 모델의 입력 한도와 조항·표 의미를 동시에 지켜야 한다. 2) 왜 ReAct가 아닌가? 계산 결정을 고정하고 필요한 도구를 제한적으로 실행한다. 3) 100% 커버리지면 모두 정확한가? 실행률만 의미하며 정답표·원문·독립 검색 평가가 추가로 필요하다. 팀 공유 ZIP의 README에서 실행 및 학습 순서를 확인한다. 발표 기본 합계 600초, 추가 설명이 허용되면 5분 확장한다.</a:t>
+              <a:t>질의응답. 예상 질문: 1) 청킹이 왜 필요한가? 임베딩 모델의 입력 한도와 조항·표 의미를 동시에 지켜야 한다. 2) 왜 ReAct가 아닌가? 계산 결정을 고정하고 필요한 도구를 제한적으로 실행한다. 3) 100% 커버리지면 모두 정확한가? 실행률만 의미하며 정답표·원문·독립 검색 평가가 추가로 필요하다. 팀 공유 ZIP의 README에서 실행 및 학습 순서를 확인한다. 발표 기본 합계 600초, 추가 설명이 허용되면 5분 확장한다. 공유 링크: https://github.com/on21life-google/jolup-graduation-agent . 팀원 원본과 통합 결과는 README에서 바로 연결하며 PPT는 artifacts/jolup-presentation-20261026.pptx에 제공한다.</a:t>
             </a:r>
             <a:endParaRPr/>
           </a:p>
@@ -1204,7 +1204,7 @@
               <a:buNone/>
             </a:pPr>
             <a:r>
-              <a:t>30초. 5조 졸업각, 김주미·윤석현·우수진. 역할은 기존 기획의 담당 배분이다. AI 통합 구현본에 대한 검토이며 개인별 기여 완료를 확인한 기록은 아직 없다. 팀원 최종 자료를 수령하면 병합·회귀검증하고 기여 항목을 확인한다.</a:t>
+              <a:t>30초. 2026-10-26 수진과 주미의 ZIP을 수령하여 합쳤다. 수진은 HTML 디자인·달력·관심과목 상호작용, 주미는 RAG 시험·색인 명세를 제공했다. 주미의 rag 구현 폴더는 ZIP에 없어서 테스트의 기대 동작을 기존 제품에 재구현했다. 개인의 직접 코드 작성 범위와 AI 통합 작업을 구분한다. 출처: team_contributions/README.md, docs/팀원_통합결과.md.</a:t>
             </a:r>
             <a:endParaRPr/>
           </a:p>
@@ -1364,7 +1364,7 @@
               <a:buNone/>
             </a:pPr>
             <a:r>
-              <a:t>40초. 성공 기준은 결론·reason·근거자료·meta와 정답 일치다. 10/22~23 가용시간 계획은 총 5시간 5분이며 실제 전체 개발 소요시간이 아니다. 당초 프롬프트 검증 후 구현 계획과 달리 구현이 먼저 진행됐으며 10/25 ChatGPT 새 대화 시험으로 사후 확인했다. 기록: reports/chatgpt_acceptance_20261025.json. Day4 기능 동결 이후 수업 대조로 범위를 보완했음을 설명한다.</a:t>
+              <a:t>40초. 성공 기준은 결론·reason·근거자료·meta와 정답 일치다. 10/22~23 가용시간 계획은 총 5시간 5분이며 실제 전체 개발 소요시간이 아니다. 당초 프롬프트 검증 후 구현 계획과 달리 구현이 먼저 진행됐으며 10/25 ChatGPT 새 대화 시험으로 사후 확인했다. 기록: reports/chatgpt_acceptance_20261025.json. Day4 기능 동결 이후 수업 대조로 범위를 보완했음을 설명한다. 10/26 최종 통합에서는 팀원 파일을 실제로 받아 디자인·월간 일정·관심 목록·NFC 검색·출처 메타를 반영했다.</a:t>
             </a:r>
             <a:endParaRPr/>
           </a:p>
@@ -1684,7 +1684,7 @@
               <a:buNone/>
             </a:pPr>
             <a:r>
-              <a:t>40초. 교수 자료의 도구를 모두 넣는 것이 완전성 기준은 아니다. 학습 목표와 서비스 요구를 대조해 선택·대체·미적용 사유를 기록했다. 수업 Day3는 Qdrant/FastEmbed와 선택 심화 Dense+BM25/RRF, 제품은 Chroma/FastEmbed와 어휘 .55·벡터 .45 가중합 및 출처 보정이다. BM25나 RRF로 소개하지 않는다. Cross-Encoder는 수업에서 구조 소개 범위, SQLite는 Day2 선택 심화다. 상세 근거: docs/수업자료_반영대조표.md, docs/실습코드_비교보고서.md, docs/아키텍처_의사결정.md.</a:t>
+              <a:t>40초. 교수 자료의 도구를 모두 넣는 것이 완전성 기준은 아니다. 학습 목표와 서비스 요구를 대조해 선택·대체·미적용 사유를 기록했다. 수업 Day3는 Qdrant/FastEmbed와 선택 심화 Dense+BM25/RRF, 제품은 Chroma/FastEmbed와 어휘 .55·벡터 .45 가중합 및 출처 보정이다. BM25나 RRF로 소개하지 않는다. Cross-Encoder는 수업에서 구조 소개 범위, SQLite는 Day2 선택 심화다. 상세 근거: docs/수업자료_반영대조표.md, docs/실습코드_비교보고서.md, docs/아키텍처_의사결정.md. 팀원 RAG 캐시는 OpenAI text-embedding-3-small 134청크로 기존 MiniLM 448청크와 호환되지 않아 연결하지 않았다. 기존 모델/규칙으로 색인하고 원본 매니페스트를 보존한다. 파일명 날짜는 등록일이 아니라 참고값이다.</a:t>
             </a:r>
             <a:endParaRPr/>
           </a:p>
@@ -1819,7 +1819,7 @@
           <p:cNvPr id="13" name="Google Shape;13;p16">
             <a:extLst xmlns:a="http://schemas.openxmlformats.org/drawingml/2006/main">
               <a:ext uri="{FF2B5EF4-FFF2-40B4-BE49-F238E27FC236}">
-                <a16:creationId xmlns:a16="http://schemas.microsoft.com/office/drawing/2014/main" id="{F95F840F-2328-43DC-A5CA-C18022B442B1}"/>
+                <a16:creationId xmlns:a16="http://schemas.microsoft.com/office/drawing/2014/main" id="{AE18D53F-F6FE-492E-8FFD-5D0096179FCE}"/>
               </a:ext>
             </a:extLst>
           </p:cNvPr>
@@ -1970,7 +1970,7 @@
           <p:cNvPr id="14" name="Google Shape;14;p16">
             <a:extLst xmlns:a="http://schemas.openxmlformats.org/drawingml/2006/main">
               <a:ext uri="{FF2B5EF4-FFF2-40B4-BE49-F238E27FC236}">
-                <a16:creationId xmlns:a16="http://schemas.microsoft.com/office/drawing/2014/main" id="{DD537B8E-C767-4166-B9E5-42CFE720C08D}"/>
+                <a16:creationId xmlns:a16="http://schemas.microsoft.com/office/drawing/2014/main" id="{7B12F701-2022-43B5-A589-C43268F5D042}"/>
               </a:ext>
             </a:extLst>
           </p:cNvPr>
@@ -2192,7 +2192,7 @@
           <p:cNvPr id="10" name="Google Shape;10;p15">
             <a:extLst xmlns:a="http://schemas.openxmlformats.org/drawingml/2006/main">
               <a:ext uri="{FF2B5EF4-FFF2-40B4-BE49-F238E27FC236}">
-                <a16:creationId xmlns:a16="http://schemas.microsoft.com/office/drawing/2014/main" id="{2D091714-5753-42C4-A020-0AB176E4CB70}"/>
+                <a16:creationId xmlns:a16="http://schemas.microsoft.com/office/drawing/2014/main" id="{C1284880-6DC1-4068-B686-5E109088D3E9}"/>
               </a:ext>
             </a:extLst>
           </p:cNvPr>
@@ -2343,7 +2343,7 @@
           <p:cNvPr id="11" name="Google Shape;11;p15">
             <a:extLst xmlns:a="http://schemas.openxmlformats.org/drawingml/2006/main">
               <a:ext uri="{FF2B5EF4-FFF2-40B4-BE49-F238E27FC236}">
-                <a16:creationId xmlns:a16="http://schemas.microsoft.com/office/drawing/2014/main" id="{E23364EA-3980-4E89-ABB3-DCE6AB361CEA}"/>
+                <a16:creationId xmlns:a16="http://schemas.microsoft.com/office/drawing/2014/main" id="{1094D607-AED5-4BFD-BA2F-DC440B5AA0A6}"/>
               </a:ext>
             </a:extLst>
           </p:cNvPr>
@@ -2581,8 +2581,8 @@
   </p:cSld>
   <p:clrMap bg1="lt1" tx1="dk1" bg2="dk2" tx2="lt2" accent1="accent1" accent2="accent2" accent3="accent3" accent4="accent4" accent5="accent5" accent6="accent6" hlink="hlink" folHlink="folHlink"/>
   <p:sldLayoutIdLst>
-    <p:sldLayoutId xmlns:r="http://schemas.openxmlformats.org/officeDocument/2006/relationships" id="2147483649" r:id="R64464ca22ac0404b"/>
-    <p:sldLayoutId xmlns:r="http://schemas.openxmlformats.org/officeDocument/2006/relationships" id="2147483650" r:id="R9afa11cd511a4d62"/>
+    <p:sldLayoutId xmlns:r="http://schemas.openxmlformats.org/officeDocument/2006/relationships" id="2147483649" r:id="R6d8e87972343483b"/>
+    <p:sldLayoutId xmlns:r="http://schemas.openxmlformats.org/officeDocument/2006/relationships" id="2147483650" r:id="R9f8c6ec320de4f16"/>
   </p:sldLayoutIdLst>
   <p:hf sldNum="0" hdr="0" ftr="0" dt="0"/>
   <p:txStyles>
@@ -3536,7 +3536,7 @@
           <p:cNvPr id="21" name="Google Shape;21;p1">
             <a:extLst xmlns:a="http://schemas.openxmlformats.org/drawingml/2006/main">
               <a:ext uri="{FF2B5EF4-FFF2-40B4-BE49-F238E27FC236}">
-                <a16:creationId xmlns:a16="http://schemas.microsoft.com/office/drawing/2014/main" id="{093675F9-4D7D-4DF8-BF0F-F82D2BF08970}"/>
+                <a16:creationId xmlns:a16="http://schemas.microsoft.com/office/drawing/2014/main" id="{274202EC-FBBA-400F-993A-2410C0E23B20}"/>
               </a:ext>
             </a:extLst>
           </p:cNvPr>
@@ -3589,7 +3589,7 @@
           <p:cNvPr id="22" name="Google Shape;22;p1">
             <a:extLst xmlns:a="http://schemas.openxmlformats.org/drawingml/2006/main">
               <a:ext uri="{FF2B5EF4-FFF2-40B4-BE49-F238E27FC236}">
-                <a16:creationId xmlns:a16="http://schemas.microsoft.com/office/drawing/2014/main" id="{2B83C114-8BA8-48A6-A3B7-45C87ED45718}"/>
+                <a16:creationId xmlns:a16="http://schemas.microsoft.com/office/drawing/2014/main" id="{6072C38D-5238-402A-B04A-2041E27D98FF}"/>
               </a:ext>
             </a:extLst>
           </p:cNvPr>
@@ -3642,7 +3642,7 @@
           <p:cNvPr id="23" name="Google Shape;23;p1">
             <a:extLst xmlns:a="http://schemas.openxmlformats.org/drawingml/2006/main">
               <a:ext uri="{FF2B5EF4-FFF2-40B4-BE49-F238E27FC236}">
-                <a16:creationId xmlns:a16="http://schemas.microsoft.com/office/drawing/2014/main" id="{9C87C3D8-8003-47CD-88CF-26D79FB307E7}"/>
+                <a16:creationId xmlns:a16="http://schemas.microsoft.com/office/drawing/2014/main" id="{8A4FB7A7-73FB-40C2-AEF7-AB8BF9873E96}"/>
               </a:ext>
             </a:extLst>
           </p:cNvPr>
@@ -3714,7 +3714,7 @@
           <p:cNvPr id="24" name="Google Shape;24;p1">
             <a:extLst xmlns:a="http://schemas.openxmlformats.org/drawingml/2006/main">
               <a:ext uri="{FF2B5EF4-FFF2-40B4-BE49-F238E27FC236}">
-                <a16:creationId xmlns:a16="http://schemas.microsoft.com/office/drawing/2014/main" id="{1FD91D95-C864-4DE9-B1C7-6E16E061EBE2}"/>
+                <a16:creationId xmlns:a16="http://schemas.microsoft.com/office/drawing/2014/main" id="{BB0AABB6-790A-48C8-B806-2DF8E8895CF8}"/>
               </a:ext>
             </a:extLst>
           </p:cNvPr>
@@ -3890,7 +3890,7 @@
           <p:cNvPr id="25" name="Google Shape;25;p1">
             <a:extLst xmlns:a="http://schemas.openxmlformats.org/drawingml/2006/main">
               <a:ext uri="{FF2B5EF4-FFF2-40B4-BE49-F238E27FC236}">
-                <a16:creationId xmlns:a16="http://schemas.microsoft.com/office/drawing/2014/main" id="{EDD0D50A-015C-4ADC-BE1F-5375969AAF6C}"/>
+                <a16:creationId xmlns:a16="http://schemas.microsoft.com/office/drawing/2014/main" id="{E2600992-6EF5-48CF-ABE2-8A5394E0FEB7}"/>
               </a:ext>
             </a:extLst>
           </p:cNvPr>
@@ -4071,7 +4071,7 @@
           <p:cNvPr id="26" name="Google Shape;26;p1">
             <a:extLst xmlns:a="http://schemas.openxmlformats.org/drawingml/2006/main">
               <a:ext uri="{FF2B5EF4-FFF2-40B4-BE49-F238E27FC236}">
-                <a16:creationId xmlns:a16="http://schemas.microsoft.com/office/drawing/2014/main" id="{05620D1A-DA8C-4DAF-B580-C977118D5AF7}"/>
+                <a16:creationId xmlns:a16="http://schemas.microsoft.com/office/drawing/2014/main" id="{7769D76B-67DC-4681-B540-8E74E87DC28C}"/>
               </a:ext>
             </a:extLst>
           </p:cNvPr>
@@ -4252,7 +4252,7 @@
           <p:cNvPr id="27" name="Google Shape;27;p1">
             <a:extLst xmlns:a="http://schemas.openxmlformats.org/drawingml/2006/main">
               <a:ext uri="{FF2B5EF4-FFF2-40B4-BE49-F238E27FC236}">
-                <a16:creationId xmlns:a16="http://schemas.microsoft.com/office/drawing/2014/main" id="{55FD25E0-97C8-406B-BB0C-3FE5DD89FA83}"/>
+                <a16:creationId xmlns:a16="http://schemas.microsoft.com/office/drawing/2014/main" id="{367119A6-468F-4B3C-9B23-4600180DF1B6}"/>
               </a:ext>
             </a:extLst>
           </p:cNvPr>
@@ -4324,7 +4324,7 @@
           <p:cNvPr id="28" name="Google Shape;28;p1">
             <a:extLst xmlns:a="http://schemas.openxmlformats.org/drawingml/2006/main">
               <a:ext uri="{FF2B5EF4-FFF2-40B4-BE49-F238E27FC236}">
-                <a16:creationId xmlns:a16="http://schemas.microsoft.com/office/drawing/2014/main" id="{3A39190A-F604-429F-AEEC-2FD622738824}"/>
+                <a16:creationId xmlns:a16="http://schemas.microsoft.com/office/drawing/2014/main" id="{9F32723C-5F9C-4998-9359-6EBCEAFB37C9}"/>
               </a:ext>
             </a:extLst>
           </p:cNvPr>
@@ -4394,7 +4394,7 @@
     </p:spTree>
     <p:extLst>
       <p:ext uri="{BB962C8B-B14F-4D97-AF65-F5344CB8AC3E}">
-        <p14:creationId xmlns:p14="http://schemas.microsoft.com/office/powerpoint/2010/main" val="462018879"/>
+        <p14:creationId xmlns:p14="http://schemas.microsoft.com/office/powerpoint/2010/main" val="2071665081"/>
       </p:ext>
     </p:extLst>
   </p:cSld>
@@ -4425,7 +4425,7 @@
           <p:cNvPr id="234" name="Google Shape;234;p10">
             <a:extLst xmlns:a="http://schemas.openxmlformats.org/drawingml/2006/main">
               <a:ext uri="{FF2B5EF4-FFF2-40B4-BE49-F238E27FC236}">
-                <a16:creationId xmlns:a16="http://schemas.microsoft.com/office/drawing/2014/main" id="{9F9E9252-CF7A-4483-BB0B-DE936B34AF5B}"/>
+                <a16:creationId xmlns:a16="http://schemas.microsoft.com/office/drawing/2014/main" id="{92E68D10-5392-4B0C-86AC-6D8AA78FAE87}"/>
               </a:ext>
             </a:extLst>
           </p:cNvPr>
@@ -4497,7 +4497,7 @@
           <p:cNvPr id="235" name="Google Shape;235;p10">
             <a:extLst xmlns:a="http://schemas.openxmlformats.org/drawingml/2006/main">
               <a:ext uri="{FF2B5EF4-FFF2-40B4-BE49-F238E27FC236}">
-                <a16:creationId xmlns:a16="http://schemas.microsoft.com/office/drawing/2014/main" id="{B1811FA9-8218-42F0-9150-4C41EA58CB45}"/>
+                <a16:creationId xmlns:a16="http://schemas.microsoft.com/office/drawing/2014/main" id="{3B343415-47B8-4B3A-ABCF-C020311AED37}"/>
               </a:ext>
             </a:extLst>
           </p:cNvPr>
@@ -4673,7 +4673,7 @@
           <p:cNvPr id="236" name="Google Shape;236;p10">
             <a:extLst xmlns:a="http://schemas.openxmlformats.org/drawingml/2006/main">
               <a:ext uri="{FF2B5EF4-FFF2-40B4-BE49-F238E27FC236}">
-                <a16:creationId xmlns:a16="http://schemas.microsoft.com/office/drawing/2014/main" id="{77BE75E0-41F3-43AE-B80E-83416A333B29}"/>
+                <a16:creationId xmlns:a16="http://schemas.microsoft.com/office/drawing/2014/main" id="{45CA12F8-46F0-4D27-8DD0-7D8CC16DDE96}"/>
               </a:ext>
             </a:extLst>
           </p:cNvPr>
@@ -4732,7 +4732,7 @@
           <p:cNvPr id="237" name="Google Shape;237;p10">
             <a:extLst xmlns:a="http://schemas.openxmlformats.org/drawingml/2006/main">
               <a:ext uri="{FF2B5EF4-FFF2-40B4-BE49-F238E27FC236}">
-                <a16:creationId xmlns:a16="http://schemas.microsoft.com/office/drawing/2014/main" id="{251D3F2C-933F-4494-A2CA-B50009DE4765}"/>
+                <a16:creationId xmlns:a16="http://schemas.microsoft.com/office/drawing/2014/main" id="{D4BB07A8-E80C-41C5-ADBD-AAD482DBA107}"/>
               </a:ext>
             </a:extLst>
           </p:cNvPr>
@@ -4905,7 +4905,7 @@
           <p:cNvPr id="238" name="Google Shape;238;p10">
             <a:extLst xmlns:a="http://schemas.openxmlformats.org/drawingml/2006/main">
               <a:ext uri="{FF2B5EF4-FFF2-40B4-BE49-F238E27FC236}">
-                <a16:creationId xmlns:a16="http://schemas.microsoft.com/office/drawing/2014/main" id="{94068EDF-3A27-455A-A750-F5D1A70DE88D}"/>
+                <a16:creationId xmlns:a16="http://schemas.microsoft.com/office/drawing/2014/main" id="{FD12FCB0-D19E-4315-84F0-4FFB68DC9884}"/>
               </a:ext>
             </a:extLst>
           </p:cNvPr>
@@ -5078,7 +5078,7 @@
           <p:cNvPr id="239" name="Google Shape;239;p10">
             <a:extLst xmlns:a="http://schemas.openxmlformats.org/drawingml/2006/main">
               <a:ext uri="{FF2B5EF4-FFF2-40B4-BE49-F238E27FC236}">
-                <a16:creationId xmlns:a16="http://schemas.microsoft.com/office/drawing/2014/main" id="{CC3C3D5B-8A91-48CF-ACC9-22A00A204809}"/>
+                <a16:creationId xmlns:a16="http://schemas.microsoft.com/office/drawing/2014/main" id="{7DCDFAFC-E8B1-4052-BC4C-5A44FF07FB50}"/>
               </a:ext>
             </a:extLst>
           </p:cNvPr>
@@ -5131,7 +5131,7 @@
           <p:cNvPr id="240" name="Google Shape;240;p10">
             <a:extLst xmlns:a="http://schemas.openxmlformats.org/drawingml/2006/main">
               <a:ext uri="{FF2B5EF4-FFF2-40B4-BE49-F238E27FC236}">
-                <a16:creationId xmlns:a16="http://schemas.microsoft.com/office/drawing/2014/main" id="{AC6506B8-7373-4822-9690-4985E43D26D4}"/>
+                <a16:creationId xmlns:a16="http://schemas.microsoft.com/office/drawing/2014/main" id="{5068B351-B8DE-4E4D-8530-BD65AB1EF9FA}"/>
               </a:ext>
             </a:extLst>
           </p:cNvPr>
@@ -5203,7 +5203,7 @@
           <p:cNvPr id="241" name="Google Shape;241;p10">
             <a:extLst xmlns:a="http://schemas.openxmlformats.org/drawingml/2006/main">
               <a:ext uri="{FF2B5EF4-FFF2-40B4-BE49-F238E27FC236}">
-                <a16:creationId xmlns:a16="http://schemas.microsoft.com/office/drawing/2014/main" id="{F404FF99-B8A1-44BF-A22F-B46603495E3E}"/>
+                <a16:creationId xmlns:a16="http://schemas.microsoft.com/office/drawing/2014/main" id="{105EC691-ACD2-498E-93ED-F931A612A042}"/>
               </a:ext>
             </a:extLst>
           </p:cNvPr>
@@ -5384,7 +5384,7 @@
           <p:cNvPr id="242" name="Google Shape;242;p10">
             <a:extLst xmlns:a="http://schemas.openxmlformats.org/drawingml/2006/main">
               <a:ext uri="{FF2B5EF4-FFF2-40B4-BE49-F238E27FC236}">
-                <a16:creationId xmlns:a16="http://schemas.microsoft.com/office/drawing/2014/main" id="{D17A5FF9-D3C2-4C59-9698-4D85AF4AFBE4}"/>
+                <a16:creationId xmlns:a16="http://schemas.microsoft.com/office/drawing/2014/main" id="{8B4C9C91-8299-493E-967E-1618B01E12CC}"/>
               </a:ext>
             </a:extLst>
           </p:cNvPr>
@@ -5616,7 +5616,7 @@
           <p:cNvPr id="243" name="Google Shape;243;p10">
             <a:extLst xmlns:a="http://schemas.openxmlformats.org/drawingml/2006/main">
               <a:ext uri="{FF2B5EF4-FFF2-40B4-BE49-F238E27FC236}">
-                <a16:creationId xmlns:a16="http://schemas.microsoft.com/office/drawing/2014/main" id="{06FB2E3E-A370-4128-BFBE-63280995C7B1}"/>
+                <a16:creationId xmlns:a16="http://schemas.microsoft.com/office/drawing/2014/main" id="{A9FEA2C8-88FA-45C2-B329-CCE2C98088DB}"/>
               </a:ext>
             </a:extLst>
           </p:cNvPr>
@@ -5688,7 +5688,7 @@
           <p:cNvPr id="244" name="Google Shape;244;p10">
             <a:extLst xmlns:a="http://schemas.openxmlformats.org/drawingml/2006/main">
               <a:ext uri="{FF2B5EF4-FFF2-40B4-BE49-F238E27FC236}">
-                <a16:creationId xmlns:a16="http://schemas.microsoft.com/office/drawing/2014/main" id="{A19BD2B3-B932-4B21-A43A-DDF00CAE7899}"/>
+                <a16:creationId xmlns:a16="http://schemas.microsoft.com/office/drawing/2014/main" id="{2DB7E7F6-87D3-4E7E-994E-94F8F62651BC}"/>
               </a:ext>
             </a:extLst>
           </p:cNvPr>
@@ -5760,7 +5760,7 @@
           <p:cNvPr id="245" name="">
             <a:extLst xmlns:a="http://schemas.openxmlformats.org/drawingml/2006/main">
               <a:ext uri="{FF2B5EF4-FFF2-40B4-BE49-F238E27FC236}">
-                <a16:creationId xmlns:a16="http://schemas.microsoft.com/office/drawing/2014/main" id="{3C70F707-F50E-4377-93BE-ECD52527B81A}"/>
+                <a16:creationId xmlns:a16="http://schemas.microsoft.com/office/drawing/2014/main" id="{0ED03DF1-76AF-41BC-A371-E2F291903505}"/>
               </a:ext>
             </a:extLst>
           </p:cNvPr>
@@ -6386,7 +6386,7 @@
           <p:cNvPr id="246" name="demo-source">
             <a:extLst xmlns:a="http://schemas.openxmlformats.org/drawingml/2006/main">
               <a:ext uri="{FF2B5EF4-FFF2-40B4-BE49-F238E27FC236}">
-                <a16:creationId xmlns:a16="http://schemas.microsoft.com/office/drawing/2014/main" id="{3D99AFAA-3F8B-4B2C-8328-A5187C5E23B5}"/>
+                <a16:creationId xmlns:a16="http://schemas.microsoft.com/office/drawing/2014/main" id="{1C11328F-A09A-4C8D-ABC2-4CDF26170D6A}"/>
               </a:ext>
             </a:extLst>
           </p:cNvPr>
@@ -6544,7 +6544,7 @@
     </p:spTree>
     <p:extLst>
       <p:ext uri="{BB962C8B-B14F-4D97-AF65-F5344CB8AC3E}">
-        <p14:creationId xmlns:p14="http://schemas.microsoft.com/office/powerpoint/2010/main" val="41866484"/>
+        <p14:creationId xmlns:p14="http://schemas.microsoft.com/office/powerpoint/2010/main" val="247463105"/>
       </p:ext>
     </p:extLst>
   </p:cSld>
@@ -6575,7 +6575,7 @@
           <p:cNvPr id="250" name="Google Shape;250;p11">
             <a:extLst xmlns:a="http://schemas.openxmlformats.org/drawingml/2006/main">
               <a:ext uri="{FF2B5EF4-FFF2-40B4-BE49-F238E27FC236}">
-                <a16:creationId xmlns:a16="http://schemas.microsoft.com/office/drawing/2014/main" id="{AD566111-AEDD-4352-951A-AC1D61208A1B}"/>
+                <a16:creationId xmlns:a16="http://schemas.microsoft.com/office/drawing/2014/main" id="{9194C308-304C-491F-B602-00FB8E124CFD}"/>
               </a:ext>
             </a:extLst>
           </p:cNvPr>
@@ -6647,7 +6647,7 @@
           <p:cNvPr id="251" name="Google Shape;251;p11">
             <a:extLst xmlns:a="http://schemas.openxmlformats.org/drawingml/2006/main">
               <a:ext uri="{FF2B5EF4-FFF2-40B4-BE49-F238E27FC236}">
-                <a16:creationId xmlns:a16="http://schemas.microsoft.com/office/drawing/2014/main" id="{F19570C4-9400-4F6B-AAAF-334E4F1D82C0}"/>
+                <a16:creationId xmlns:a16="http://schemas.microsoft.com/office/drawing/2014/main" id="{7A6A33F0-7090-44EC-A30C-CD4099E56840}"/>
               </a:ext>
             </a:extLst>
           </p:cNvPr>
@@ -6714,7 +6714,7 @@
           <p:cNvPr id="252" name="Google Shape;252;p11">
             <a:extLst xmlns:a="http://schemas.openxmlformats.org/drawingml/2006/main">
               <a:ext uri="{FF2B5EF4-FFF2-40B4-BE49-F238E27FC236}">
-                <a16:creationId xmlns:a16="http://schemas.microsoft.com/office/drawing/2014/main" id="{FB0D39C0-C03A-44EB-A03C-9EC9A4A1280B}"/>
+                <a16:creationId xmlns:a16="http://schemas.microsoft.com/office/drawing/2014/main" id="{C44023E6-8706-4988-B839-D270C13A965B}"/>
               </a:ext>
             </a:extLst>
           </p:cNvPr>
@@ -6745,7 +6745,7 @@
           <p:cNvPr id="253" name="Google Shape;253;p11">
             <a:extLst xmlns:a="http://schemas.openxmlformats.org/drawingml/2006/main">
               <a:ext uri="{FF2B5EF4-FFF2-40B4-BE49-F238E27FC236}">
-                <a16:creationId xmlns:a16="http://schemas.microsoft.com/office/drawing/2014/main" id="{81A669F7-CF66-4859-9603-9C20D176779E}"/>
+                <a16:creationId xmlns:a16="http://schemas.microsoft.com/office/drawing/2014/main" id="{596B16AA-7BA7-4C75-ADB5-CBF40FE36AA4}"/>
               </a:ext>
             </a:extLst>
           </p:cNvPr>
@@ -6776,7 +6776,7 @@
           <p:cNvPr id="254" name="Google Shape;254;p11">
             <a:extLst xmlns:a="http://schemas.openxmlformats.org/drawingml/2006/main">
               <a:ext uri="{FF2B5EF4-FFF2-40B4-BE49-F238E27FC236}">
-                <a16:creationId xmlns:a16="http://schemas.microsoft.com/office/drawing/2014/main" id="{F835C58B-85A6-45D3-83F4-2500F4E5B0BF}"/>
+                <a16:creationId xmlns:a16="http://schemas.microsoft.com/office/drawing/2014/main" id="{AFDE8F5A-4F92-48B4-85F4-767B1F6F3C54}"/>
               </a:ext>
             </a:extLst>
           </p:cNvPr>
@@ -7959,7 +7959,7 @@
                           <a:ea typeface="IBM Plex Sans KR"/>
                           <a:cs typeface="IBM Plex Sans KR"/>
                         </a:rPr>
-                        <a:t>777/777 통과</a:t>
+                        <a:t>824/824 통과</a:t>
                       </a:r>
                       <a:endParaRPr sz="1200" u="none" strike="noStrike" cap="none">
                         <a:latin typeface="IBM Plex Sans KR"/>
@@ -8005,7 +8005,7 @@
           <p:cNvPr id="255" name="Google Shape;255;p11">
             <a:extLst xmlns:a="http://schemas.openxmlformats.org/drawingml/2006/main">
               <a:ext uri="{FF2B5EF4-FFF2-40B4-BE49-F238E27FC236}">
-                <a16:creationId xmlns:a16="http://schemas.microsoft.com/office/drawing/2014/main" id="{38F7FC27-CC48-47A3-91D0-7021D9BDA17B}"/>
+                <a16:creationId xmlns:a16="http://schemas.microsoft.com/office/drawing/2014/main" id="{5E7759C7-7482-4F1C-9F56-26B00DDC99C3}"/>
               </a:ext>
             </a:extLst>
           </p:cNvPr>
@@ -8058,7 +8058,7 @@
           <p:cNvPr id="256" name="Google Shape;256;p11">
             <a:extLst xmlns:a="http://schemas.openxmlformats.org/drawingml/2006/main">
               <a:ext uri="{FF2B5EF4-FFF2-40B4-BE49-F238E27FC236}">
-                <a16:creationId xmlns:a16="http://schemas.microsoft.com/office/drawing/2014/main" id="{B5924C88-6A65-4FD1-AB1F-D2041ECEF2E7}"/>
+                <a16:creationId xmlns:a16="http://schemas.microsoft.com/office/drawing/2014/main" id="{010ADD5A-8228-4A7D-9552-1463295D1FAD}"/>
               </a:ext>
             </a:extLst>
           </p:cNvPr>
@@ -8130,7 +8130,7 @@
           <p:cNvPr id="257" name="Google Shape;257;p11">
             <a:extLst xmlns:a="http://schemas.openxmlformats.org/drawingml/2006/main">
               <a:ext uri="{FF2B5EF4-FFF2-40B4-BE49-F238E27FC236}">
-                <a16:creationId xmlns:a16="http://schemas.microsoft.com/office/drawing/2014/main" id="{F07E6A21-0BC4-40D5-B3C2-23CFF237E659}"/>
+                <a16:creationId xmlns:a16="http://schemas.microsoft.com/office/drawing/2014/main" id="{B06871F5-F22B-45C2-B099-5805B4D0AA68}"/>
               </a:ext>
             </a:extLst>
           </p:cNvPr>
@@ -8311,7 +8311,7 @@
           <p:cNvPr id="258" name="Google Shape;258;p11">
             <a:extLst xmlns:a="http://schemas.openxmlformats.org/drawingml/2006/main">
               <a:ext uri="{FF2B5EF4-FFF2-40B4-BE49-F238E27FC236}">
-                <a16:creationId xmlns:a16="http://schemas.microsoft.com/office/drawing/2014/main" id="{CFD5E8D7-20A8-49CA-9166-AB41DE45A172}"/>
+                <a16:creationId xmlns:a16="http://schemas.microsoft.com/office/drawing/2014/main" id="{491D20DC-7DBD-4E73-A447-FA859E175134}"/>
               </a:ext>
             </a:extLst>
           </p:cNvPr>
@@ -8492,7 +8492,7 @@
           <p:cNvPr id="259" name="Google Shape;259;p11">
             <a:extLst xmlns:a="http://schemas.openxmlformats.org/drawingml/2006/main">
               <a:ext uri="{FF2B5EF4-FFF2-40B4-BE49-F238E27FC236}">
-                <a16:creationId xmlns:a16="http://schemas.microsoft.com/office/drawing/2014/main" id="{8DC9E9E8-E77B-4DD5-AE8B-DEAA7B4068A1}"/>
+                <a16:creationId xmlns:a16="http://schemas.microsoft.com/office/drawing/2014/main" id="{8C888279-3795-4A15-825D-61DBFFFE44FC}"/>
               </a:ext>
             </a:extLst>
           </p:cNvPr>
@@ -8545,7 +8545,7 @@
           <p:cNvPr id="260" name="Google Shape;260;p11">
             <a:extLst xmlns:a="http://schemas.openxmlformats.org/drawingml/2006/main">
               <a:ext uri="{FF2B5EF4-FFF2-40B4-BE49-F238E27FC236}">
-                <a16:creationId xmlns:a16="http://schemas.microsoft.com/office/drawing/2014/main" id="{B4E82383-FE44-4FE6-8DB6-F4BD6E51CC7F}"/>
+                <a16:creationId xmlns:a16="http://schemas.microsoft.com/office/drawing/2014/main" id="{71088FFF-F444-4D5B-B381-F5B0B58C3C42}"/>
               </a:ext>
             </a:extLst>
           </p:cNvPr>
@@ -8617,7 +8617,7 @@
           <p:cNvPr id="261" name="Google Shape;261;p11">
             <a:extLst xmlns:a="http://schemas.openxmlformats.org/drawingml/2006/main">
               <a:ext uri="{FF2B5EF4-FFF2-40B4-BE49-F238E27FC236}">
-                <a16:creationId xmlns:a16="http://schemas.microsoft.com/office/drawing/2014/main" id="{356E041A-7D63-4524-81C5-30DC5B28247E}"/>
+                <a16:creationId xmlns:a16="http://schemas.microsoft.com/office/drawing/2014/main" id="{2B44D3E1-17D6-4E5F-8D96-D5D116C0D078}"/>
               </a:ext>
             </a:extLst>
           </p:cNvPr>
@@ -8798,7 +8798,7 @@
           <p:cNvPr id="262" name="Google Shape;262;p11">
             <a:extLst xmlns:a="http://schemas.openxmlformats.org/drawingml/2006/main">
               <a:ext uri="{FF2B5EF4-FFF2-40B4-BE49-F238E27FC236}">
-                <a16:creationId xmlns:a16="http://schemas.microsoft.com/office/drawing/2014/main" id="{BFDD035B-796E-4046-82DC-23BFEDFB559C}"/>
+                <a16:creationId xmlns:a16="http://schemas.microsoft.com/office/drawing/2014/main" id="{96D6F55B-B37B-4219-8E3F-1046BF24D6BE}"/>
               </a:ext>
             </a:extLst>
           </p:cNvPr>
@@ -8979,7 +8979,7 @@
           <p:cNvPr id="263" name="Google Shape;263;p11">
             <a:extLst xmlns:a="http://schemas.openxmlformats.org/drawingml/2006/main">
               <a:ext uri="{FF2B5EF4-FFF2-40B4-BE49-F238E27FC236}">
-                <a16:creationId xmlns:a16="http://schemas.microsoft.com/office/drawing/2014/main" id="{0FC8FE2F-6F1C-4AA9-9399-8ED83CD5972F}"/>
+                <a16:creationId xmlns:a16="http://schemas.microsoft.com/office/drawing/2014/main" id="{3A0D465E-C396-4996-804E-B22865755DE6}"/>
               </a:ext>
             </a:extLst>
           </p:cNvPr>
@@ -9051,7 +9051,7 @@
           <p:cNvPr id="264" name="Google Shape;264;p11">
             <a:extLst xmlns:a="http://schemas.openxmlformats.org/drawingml/2006/main">
               <a:ext uri="{FF2B5EF4-FFF2-40B4-BE49-F238E27FC236}">
-                <a16:creationId xmlns:a16="http://schemas.microsoft.com/office/drawing/2014/main" id="{6370CF2C-C1A6-4CB3-926B-E71D764B8881}"/>
+                <a16:creationId xmlns:a16="http://schemas.microsoft.com/office/drawing/2014/main" id="{9404C682-C117-4596-BDB6-E127560F79E6}"/>
               </a:ext>
             </a:extLst>
           </p:cNvPr>
@@ -9123,7 +9123,7 @@
           <p:cNvPr id="265" name="evaluation-limits">
             <a:extLst xmlns:a="http://schemas.openxmlformats.org/drawingml/2006/main">
               <a:ext uri="{FF2B5EF4-FFF2-40B4-BE49-F238E27FC236}">
-                <a16:creationId xmlns:a16="http://schemas.microsoft.com/office/drawing/2014/main" id="{D019ACC0-251E-43C7-86EC-5B97906A3D15}"/>
+                <a16:creationId xmlns:a16="http://schemas.microsoft.com/office/drawing/2014/main" id="{BCD9155D-8635-4087-B100-27519830C20B}"/>
               </a:ext>
             </a:extLst>
           </p:cNvPr>
@@ -9300,7 +9300,7 @@
                 <a:ea typeface="IBM Plex Sans KR"/>
                 <a:cs typeface="IBM Plex Sans KR"/>
               </a:rPr>
-              <a:t>Sonar 복잡도 경고 0 · 품질문 ERROR(새 지적 12). 최신 Docker·Claude 실계정은 미검증, 11/12는 독립 holdout이 아니다.</a:t>
+              <a:t>통합 전 Sonar: 복잡도 경고 0·품질문 ERROR(12). 통합 후 재분석·최신 Docker·Claude 실계정은 미검증.</a:t>
             </a:r>
           </a:p>
         </p:txBody>
@@ -9308,7 +9308,7 @@
     </p:spTree>
     <p:extLst>
       <p:ext uri="{BB962C8B-B14F-4D97-AF65-F5344CB8AC3E}">
-        <p14:creationId xmlns:p14="http://schemas.microsoft.com/office/powerpoint/2010/main" val="767363632"/>
+        <p14:creationId xmlns:p14="http://schemas.microsoft.com/office/powerpoint/2010/main" val="284767057"/>
       </p:ext>
     </p:extLst>
   </p:cSld>
@@ -9339,7 +9339,7 @@
           <p:cNvPr id="270" name="Google Shape;270;p12">
             <a:extLst xmlns:a="http://schemas.openxmlformats.org/drawingml/2006/main">
               <a:ext uri="{FF2B5EF4-FFF2-40B4-BE49-F238E27FC236}">
-                <a16:creationId xmlns:a16="http://schemas.microsoft.com/office/drawing/2014/main" id="{2E6774B6-2606-446D-A189-180732EAB0F7}"/>
+                <a16:creationId xmlns:a16="http://schemas.microsoft.com/office/drawing/2014/main" id="{63669573-C814-4E5C-8317-2DE693C610FA}"/>
               </a:ext>
             </a:extLst>
           </p:cNvPr>
@@ -9411,7 +9411,7 @@
           <p:cNvPr id="271" name="Google Shape;271;p12">
             <a:extLst xmlns:a="http://schemas.openxmlformats.org/drawingml/2006/main">
               <a:ext uri="{FF2B5EF4-FFF2-40B4-BE49-F238E27FC236}">
-                <a16:creationId xmlns:a16="http://schemas.microsoft.com/office/drawing/2014/main" id="{DD8741BE-A1E0-4448-B80F-95D877CA502B}"/>
+                <a16:creationId xmlns:a16="http://schemas.microsoft.com/office/drawing/2014/main" id="{AB1C9057-36CC-4536-98D6-8F42F6F53F07}"/>
               </a:ext>
             </a:extLst>
           </p:cNvPr>
@@ -9478,7 +9478,7 @@
           <p:cNvPr id="272" name="Google Shape;272;p12">
             <a:extLst xmlns:a="http://schemas.openxmlformats.org/drawingml/2006/main">
               <a:ext uri="{FF2B5EF4-FFF2-40B4-BE49-F238E27FC236}">
-                <a16:creationId xmlns:a16="http://schemas.microsoft.com/office/drawing/2014/main" id="{3E8B6600-9AAB-4DB0-A8C1-B29E642036E4}"/>
+                <a16:creationId xmlns:a16="http://schemas.microsoft.com/office/drawing/2014/main" id="{F524F07D-7F33-4EE7-8B34-638FF6067F1A}"/>
               </a:ext>
             </a:extLst>
           </p:cNvPr>
@@ -9531,7 +9531,7 @@
           <p:cNvPr id="273" name="Google Shape;273;p12">
             <a:extLst xmlns:a="http://schemas.openxmlformats.org/drawingml/2006/main">
               <a:ext uri="{FF2B5EF4-FFF2-40B4-BE49-F238E27FC236}">
-                <a16:creationId xmlns:a16="http://schemas.microsoft.com/office/drawing/2014/main" id="{7A98B0AF-C21A-4365-8C17-9DF304F67946}"/>
+                <a16:creationId xmlns:a16="http://schemas.microsoft.com/office/drawing/2014/main" id="{D5C7680C-563A-4066-88CD-32BB69572D0D}"/>
               </a:ext>
             </a:extLst>
           </p:cNvPr>
@@ -9603,7 +9603,7 @@
           <p:cNvPr id="274" name="Google Shape;274;p12">
             <a:extLst xmlns:a="http://schemas.openxmlformats.org/drawingml/2006/main">
               <a:ext uri="{FF2B5EF4-FFF2-40B4-BE49-F238E27FC236}">
-                <a16:creationId xmlns:a16="http://schemas.microsoft.com/office/drawing/2014/main" id="{4D60C40B-591C-4AA2-92AF-02626567CE6A}"/>
+                <a16:creationId xmlns:a16="http://schemas.microsoft.com/office/drawing/2014/main" id="{CED4442F-D96D-4D6A-AE17-7777365801DE}"/>
               </a:ext>
             </a:extLst>
           </p:cNvPr>
@@ -9766,7 +9766,7 @@
                 <a:ea typeface="IBM Plex Sans KR"/>
                 <a:cs typeface="IBM Plex Sans KR"/>
               </a:rPr>
-              <a:t>• 현재 90 / 목표 계획 123 분리</a:t>
+              <a:t>• 수진 디자인 + 실제 계산 연결</a:t>
             </a:r>
             <a:endParaRPr sz="1300" b="0" i="0" u="none" strike="noStrike" cap="none">
               <a:solidFill>
@@ -9784,7 +9784,7 @@
           <p:cNvPr id="275" name="Google Shape;275;p12">
             <a:extLst xmlns:a="http://schemas.openxmlformats.org/drawingml/2006/main">
               <a:ext uri="{FF2B5EF4-FFF2-40B4-BE49-F238E27FC236}">
-                <a16:creationId xmlns:a16="http://schemas.microsoft.com/office/drawing/2014/main" id="{4BAF4F19-1BC9-4121-91AD-4798D94A9AAA}"/>
+                <a16:creationId xmlns:a16="http://schemas.microsoft.com/office/drawing/2014/main" id="{47060FD3-F050-4380-9097-24ED287011F3}"/>
               </a:ext>
             </a:extLst>
           </p:cNvPr>
@@ -9947,7 +9947,7 @@
                 <a:ea typeface="IBM Plex Sans KR"/>
                 <a:cs typeface="IBM Plex Sans KR"/>
               </a:rPr>
-              <a:t>• 448청크 토큰 잘림 0건</a:t>
+              <a:t>• 현재 90 / 목표 계획 123 분리</a:t>
             </a:r>
             <a:endParaRPr sz="1300" b="0" i="0" u="none" strike="noStrike" cap="none">
               <a:solidFill>
@@ -9965,7 +9965,7 @@
           <p:cNvPr id="276" name="Google Shape;276;p12">
             <a:extLst xmlns:a="http://schemas.openxmlformats.org/drawingml/2006/main">
               <a:ext uri="{FF2B5EF4-FFF2-40B4-BE49-F238E27FC236}">
-                <a16:creationId xmlns:a16="http://schemas.microsoft.com/office/drawing/2014/main" id="{32A6E8B4-DC2A-44AF-B6BE-16FF0A7A390C}"/>
+                <a16:creationId xmlns:a16="http://schemas.microsoft.com/office/drawing/2014/main" id="{99057695-26FD-4AFF-AA6C-C15C3C64A405}"/>
               </a:ext>
             </a:extLst>
           </p:cNvPr>
@@ -10018,7 +10018,7 @@
           <p:cNvPr id="277" name="Google Shape;277;p12">
             <a:extLst xmlns:a="http://schemas.openxmlformats.org/drawingml/2006/main">
               <a:ext uri="{FF2B5EF4-FFF2-40B4-BE49-F238E27FC236}">
-                <a16:creationId xmlns:a16="http://schemas.microsoft.com/office/drawing/2014/main" id="{40D91B6F-5FE1-46A5-BD22-CD915AD2483E}"/>
+                <a16:creationId xmlns:a16="http://schemas.microsoft.com/office/drawing/2014/main" id="{7323ED95-1CCB-45E7-97A3-1BEE3D162D0A}"/>
               </a:ext>
             </a:extLst>
           </p:cNvPr>
@@ -10090,7 +10090,7 @@
           <p:cNvPr id="278" name="Google Shape;278;p12">
             <a:extLst xmlns:a="http://schemas.openxmlformats.org/drawingml/2006/main">
               <a:ext uri="{FF2B5EF4-FFF2-40B4-BE49-F238E27FC236}">
-                <a16:creationId xmlns:a16="http://schemas.microsoft.com/office/drawing/2014/main" id="{72AC186F-98C5-49CA-896E-2D9DE3C2CA23}"/>
+                <a16:creationId xmlns:a16="http://schemas.microsoft.com/office/drawing/2014/main" id="{E89D9A21-0304-4BCD-A86E-D2FFAC2D2BCD}"/>
               </a:ext>
             </a:extLst>
           </p:cNvPr>
@@ -10253,7 +10253,7 @@
                 <a:ea typeface="IBM Plex Sans KR"/>
                 <a:cs typeface="IBM Plex Sans KR"/>
               </a:rPr>
-              <a:t>• 자료 누락을 단순 부족으로 답함</a:t>
+              <a:t>• NFD 한글 질문의 검색 누락</a:t>
             </a:r>
             <a:endParaRPr sz="1300" b="0" i="0" u="none" strike="noStrike" cap="none">
               <a:solidFill>
@@ -10271,7 +10271,7 @@
           <p:cNvPr id="279" name="Google Shape;279;p12">
             <a:extLst xmlns:a="http://schemas.openxmlformats.org/drawingml/2006/main">
               <a:ext uri="{FF2B5EF4-FFF2-40B4-BE49-F238E27FC236}">
-                <a16:creationId xmlns:a16="http://schemas.microsoft.com/office/drawing/2014/main" id="{911AD46F-2BC6-4557-A461-CEF67B666C16}"/>
+                <a16:creationId xmlns:a16="http://schemas.microsoft.com/office/drawing/2014/main" id="{027B1FD5-653A-4793-8E09-E7271602EC54}"/>
               </a:ext>
             </a:extLst>
           </p:cNvPr>
@@ -10434,7 +10434,7 @@
                 <a:ea typeface="IBM Plex Sans KR"/>
                 <a:cs typeface="IBM Plex Sans KR"/>
               </a:rPr>
-              <a:t>• 누락 우선 규칙 수정 후 재시험</a:t>
+              <a:t>• NFC 비교·범위 검사 후 재시험</a:t>
             </a:r>
             <a:endParaRPr sz="1300" b="0" i="0" u="none" strike="noStrike" cap="none">
               <a:solidFill>
@@ -10452,7 +10452,7 @@
           <p:cNvPr id="280" name="Google Shape;280;p12">
             <a:extLst xmlns:a="http://schemas.openxmlformats.org/drawingml/2006/main">
               <a:ext uri="{FF2B5EF4-FFF2-40B4-BE49-F238E27FC236}">
-                <a16:creationId xmlns:a16="http://schemas.microsoft.com/office/drawing/2014/main" id="{101667F1-E106-45E6-BF57-77B6048A7945}"/>
+                <a16:creationId xmlns:a16="http://schemas.microsoft.com/office/drawing/2014/main" id="{D036F727-0542-40A0-AA94-9823374D6C58}"/>
               </a:ext>
             </a:extLst>
           </p:cNvPr>
@@ -10505,7 +10505,7 @@
           <p:cNvPr id="281" name="Google Shape;281;p12">
             <a:extLst xmlns:a="http://schemas.openxmlformats.org/drawingml/2006/main">
               <a:ext uri="{FF2B5EF4-FFF2-40B4-BE49-F238E27FC236}">
-                <a16:creationId xmlns:a16="http://schemas.microsoft.com/office/drawing/2014/main" id="{2F75F080-82C1-4BAD-BFEA-0336D9996E4B}"/>
+                <a16:creationId xmlns:a16="http://schemas.microsoft.com/office/drawing/2014/main" id="{5368AD52-CA53-4EDE-97A3-77632FCD0BAD}"/>
               </a:ext>
             </a:extLst>
           </p:cNvPr>
@@ -10577,7 +10577,7 @@
           <p:cNvPr id="282" name="Google Shape;282;p12">
             <a:extLst xmlns:a="http://schemas.openxmlformats.org/drawingml/2006/main">
               <a:ext uri="{FF2B5EF4-FFF2-40B4-BE49-F238E27FC236}">
-                <a16:creationId xmlns:a16="http://schemas.microsoft.com/office/drawing/2014/main" id="{A64675D4-864B-40B6-A0D7-D1A414418E43}"/>
+                <a16:creationId xmlns:a16="http://schemas.microsoft.com/office/drawing/2014/main" id="{140F245D-B32B-4EFD-9C96-444754F8ECB7}"/>
               </a:ext>
             </a:extLst>
           </p:cNvPr>
@@ -10740,7 +10740,7 @@
                 <a:ea typeface="IBM Plex Sans KR"/>
                 <a:cs typeface="IBM Plex Sans KR"/>
               </a:rPr>
-              <a:t>• 검색 평가와 답변 평가는 별개</a:t>
+              <a:t>• 원본 보존과 제품 적용 구분</a:t>
             </a:r>
             <a:endParaRPr sz="1300" b="0" i="0" u="none" strike="noStrike" cap="none">
               <a:solidFill>
@@ -10758,7 +10758,7 @@
           <p:cNvPr id="283" name="Google Shape;283;p12">
             <a:extLst xmlns:a="http://schemas.openxmlformats.org/drawingml/2006/main">
               <a:ext uri="{FF2B5EF4-FFF2-40B4-BE49-F238E27FC236}">
-                <a16:creationId xmlns:a16="http://schemas.microsoft.com/office/drawing/2014/main" id="{D36D92CF-7DB0-4591-88FA-BFEF4F2A54F3}"/>
+                <a16:creationId xmlns:a16="http://schemas.microsoft.com/office/drawing/2014/main" id="{8ADF9EFC-F65E-476B-BEF0-C4F7D35D9B34}"/>
               </a:ext>
             </a:extLst>
           </p:cNvPr>
@@ -10921,7 +10921,7 @@
                 <a:ea typeface="IBM Plex Sans KR"/>
                 <a:cs typeface="IBM Plex Sans KR"/>
               </a:rPr>
-              <a:t>• 공통 계약·정답표로 로컬 통합</a:t>
+              <a:t>• 출처 명세가 실제 결함을 발견</a:t>
             </a:r>
             <a:endParaRPr sz="1300" b="0" i="0" u="none" strike="noStrike" cap="none">
               <a:solidFill>
@@ -10939,7 +10939,7 @@
           <p:cNvPr id="284" name="Google Shape;284;p12">
             <a:extLst xmlns:a="http://schemas.openxmlformats.org/drawingml/2006/main">
               <a:ext uri="{FF2B5EF4-FFF2-40B4-BE49-F238E27FC236}">
-                <a16:creationId xmlns:a16="http://schemas.microsoft.com/office/drawing/2014/main" id="{0F813650-22E8-4025-9BEC-3C9BD64F386B}"/>
+                <a16:creationId xmlns:a16="http://schemas.microsoft.com/office/drawing/2014/main" id="{91B17B19-8FE8-4E86-A7A0-F678BA0F8C36}"/>
               </a:ext>
             </a:extLst>
           </p:cNvPr>
@@ -11011,7 +11011,7 @@
           <p:cNvPr id="285" name="Google Shape;285;p12">
             <a:extLst xmlns:a="http://schemas.openxmlformats.org/drawingml/2006/main">
               <a:ext uri="{FF2B5EF4-FFF2-40B4-BE49-F238E27FC236}">
-                <a16:creationId xmlns:a16="http://schemas.microsoft.com/office/drawing/2014/main" id="{21202B30-0AEC-4C11-8B2E-78FB0091D104}"/>
+                <a16:creationId xmlns:a16="http://schemas.microsoft.com/office/drawing/2014/main" id="{72E0E2FD-34D1-4241-990A-ADC41C6B3099}"/>
               </a:ext>
             </a:extLst>
           </p:cNvPr>
@@ -11083,7 +11083,7 @@
           <p:cNvPr id="286" name="limits-detail">
             <a:extLst xmlns:a="http://schemas.openxmlformats.org/drawingml/2006/main">
               <a:ext uri="{FF2B5EF4-FFF2-40B4-BE49-F238E27FC236}">
-                <a16:creationId xmlns:a16="http://schemas.microsoft.com/office/drawing/2014/main" id="{9502FFD2-470D-4220-88AC-BA81639DDB01}"/>
+                <a16:creationId xmlns:a16="http://schemas.microsoft.com/office/drawing/2014/main" id="{32E5AF4C-01BA-45C9-99DA-86E69A6DD3CF}"/>
               </a:ext>
             </a:extLst>
           </p:cNvPr>
@@ -11233,7 +11233,7 @@
                 <a:ea typeface="IBM Plex Sans KR"/>
                 <a:cs typeface="IBM Plex Sans KR"/>
               </a:rPr>
-              <a:t>개선 기록: 과거 F 재수강·수강 중 이수 혼동·자료 누락 판정을 회귀 테스트로 고쳤다.</a:t>
+              <a:t>주미의 시험 명세로 한글 저장 방식에 따른 검색 누락을 재현하고 수정했다.</a:t>
             </a:r>
           </a:p>
           <a:p xmlns:a="http://schemas.openxmlformats.org/drawingml/2006/main">
@@ -11260,7 +11260,7 @@
                 <a:ea typeface="IBM Plex Sans KR"/>
                 <a:cs typeface="IBM Plex Sans KR"/>
               </a:rPr>
-              <a:t>이번 수업 대조에서는 복합 질문 누락과 최근 결과 재사용을 보완했다.</a:t>
+              <a:t>수진의 시안은 월간 달력·D-day·관심 과목까지 실제 자료에 연결했다.</a:t>
             </a:r>
           </a:p>
           <a:p xmlns:a="http://schemas.openxmlformats.org/drawingml/2006/main">
@@ -11287,7 +11287,7 @@
                 <a:ea typeface="IBM Plex Sans KR"/>
                 <a:cs typeface="IBM Plex Sans KR"/>
               </a:rPr>
-              <a:t>전체 개발이 처음부터 TDD였다고 소급하지 않는다. 실제 Red→Green 보완 기록과 학습용 재현을 구분한다.</a:t>
+              <a:t>누락된 rag 구현은 재현하지 못했다. 시험 의도는 재구현하고 원본과 선택 이유를 보존했다.</a:t>
             </a:r>
           </a:p>
         </p:txBody>
@@ -11295,7 +11295,7 @@
     </p:spTree>
     <p:extLst>
       <p:ext uri="{BB962C8B-B14F-4D97-AF65-F5344CB8AC3E}">
-        <p14:creationId xmlns:p14="http://schemas.microsoft.com/office/powerpoint/2010/main" val="2119572130"/>
+        <p14:creationId xmlns:p14="http://schemas.microsoft.com/office/powerpoint/2010/main" val="1511815560"/>
       </p:ext>
     </p:extLst>
   </p:cSld>
@@ -11326,7 +11326,7 @@
           <p:cNvPr id="291" name="Google Shape;291;p13">
             <a:extLst xmlns:a="http://schemas.openxmlformats.org/drawingml/2006/main">
               <a:ext uri="{FF2B5EF4-FFF2-40B4-BE49-F238E27FC236}">
-                <a16:creationId xmlns:a16="http://schemas.microsoft.com/office/drawing/2014/main" id="{D924B55F-2187-4AD5-AD9D-DBEE2D942EF3}"/>
+                <a16:creationId xmlns:a16="http://schemas.microsoft.com/office/drawing/2014/main" id="{8856E2AC-DDF5-4C58-828C-02B648622AC8}"/>
               </a:ext>
             </a:extLst>
           </p:cNvPr>
@@ -11398,7 +11398,7 @@
           <p:cNvPr id="292" name="Google Shape;292;p13">
             <a:extLst xmlns:a="http://schemas.openxmlformats.org/drawingml/2006/main">
               <a:ext uri="{FF2B5EF4-FFF2-40B4-BE49-F238E27FC236}">
-                <a16:creationId xmlns:a16="http://schemas.microsoft.com/office/drawing/2014/main" id="{697E6960-C48B-4704-B656-CE6BD304650D}"/>
+                <a16:creationId xmlns:a16="http://schemas.microsoft.com/office/drawing/2014/main" id="{627B509C-52F5-41A7-8A01-15B98101B5C1}"/>
               </a:ext>
             </a:extLst>
           </p:cNvPr>
@@ -11465,7 +11465,7 @@
           <p:cNvPr id="293" name="Google Shape;293;p13">
             <a:extLst xmlns:a="http://schemas.openxmlformats.org/drawingml/2006/main">
               <a:ext uri="{FF2B5EF4-FFF2-40B4-BE49-F238E27FC236}">
-                <a16:creationId xmlns:a16="http://schemas.microsoft.com/office/drawing/2014/main" id="{33EC7379-6B00-470F-9C12-1C090CA9C3BD}"/>
+                <a16:creationId xmlns:a16="http://schemas.microsoft.com/office/drawing/2014/main" id="{E3DDCF83-468B-4E3D-A191-54E0B241ED67}"/>
               </a:ext>
             </a:extLst>
           </p:cNvPr>
@@ -11496,7 +11496,7 @@
           <p:cNvPr id="294" name="Google Shape;294;p13">
             <a:extLst xmlns:a="http://schemas.openxmlformats.org/drawingml/2006/main">
               <a:ext uri="{FF2B5EF4-FFF2-40B4-BE49-F238E27FC236}">
-                <a16:creationId xmlns:a16="http://schemas.microsoft.com/office/drawing/2014/main" id="{9B4B010E-410B-4BE8-B4D4-854718A08D95}"/>
+                <a16:creationId xmlns:a16="http://schemas.microsoft.com/office/drawing/2014/main" id="{7AA6824F-18BC-47CE-9D3A-AE09D2F1D780}"/>
               </a:ext>
             </a:extLst>
           </p:cNvPr>
@@ -11527,7 +11527,7 @@
           <p:cNvPr id="295" name="Google Shape;295;p13">
             <a:extLst xmlns:a="http://schemas.openxmlformats.org/drawingml/2006/main">
               <a:ext uri="{FF2B5EF4-FFF2-40B4-BE49-F238E27FC236}">
-                <a16:creationId xmlns:a16="http://schemas.microsoft.com/office/drawing/2014/main" id="{C07A90AA-11AB-4070-AFB7-0716BA153A79}"/>
+                <a16:creationId xmlns:a16="http://schemas.microsoft.com/office/drawing/2014/main" id="{D9D24C5B-E41D-4723-B607-5A9BACA38E80}"/>
               </a:ext>
             </a:extLst>
           </p:cNvPr>
@@ -11864,7 +11864,7 @@
                           <a:ea typeface="IBM Plex Sans KR"/>
                           <a:cs typeface="IBM Plex Sans KR"/>
                         </a:rPr>
-                        <a:t>팀원 파일 통합·교차검토</a:t>
+                        <a:t>누락 rag 구현·다른 입력 형식</a:t>
                       </a:r>
                       <a:endParaRPr sz="1200" u="none" strike="noStrike" cap="none">
                         <a:latin typeface="IBM Plex Sans KR"/>
@@ -11931,7 +11931,7 @@
                           <a:ea typeface="IBM Plex Sans KR"/>
                           <a:cs typeface="IBM Plex Sans KR"/>
                         </a:rPr>
-                        <a:t>최종 담당별 결과·충돌 확인</a:t>
+                        <a:t>추가 비교·PDF/XLSX 파서 검증</a:t>
                       </a:r>
                       <a:endParaRPr sz="1200" u="none" strike="noStrike" cap="none">
                         <a:latin typeface="IBM Plex Sans KR"/>
@@ -11998,7 +11998,7 @@
                           <a:ea typeface="IBM Plex Sans KR"/>
                           <a:cs typeface="IBM Plex Sans KR"/>
                         </a:rPr>
-                        <a:t>상</a:t>
+                        <a:t>중</a:t>
                       </a:r>
                       <a:endParaRPr sz="1200" u="none" strike="noStrike" cap="none">
                         <a:latin typeface="IBM Plex Sans KR"/>
@@ -12065,7 +12065,7 @@
                           <a:ea typeface="IBM Plex Sans KR"/>
                           <a:cs typeface="IBM Plex Sans KR"/>
                         </a:rPr>
-                        <a:t>발표 전 가능한 범위</a:t>
+                        <a:t>추가 자료·요구 확보 후</a:t>
                       </a:r>
                       <a:endParaRPr sz="1200" u="none" strike="noStrike" cap="none">
                         <a:latin typeface="IBM Plex Sans KR"/>
@@ -12134,7 +12134,7 @@
                           <a:ea typeface="IBM Plex Sans KR"/>
                           <a:cs typeface="IBM Plex Sans KR"/>
                         </a:rPr>
-                        <a:t>Sonar 잔여 지적·Docker 검증</a:t>
+                        <a:t>Sonar 재분석·Docker 검증</a:t>
                       </a:r>
                       <a:endParaRPr sz="1200" u="none" strike="noStrike" cap="none">
                         <a:latin typeface="IBM Plex Sans KR"/>
@@ -12201,7 +12201,7 @@
                           <a:ea typeface="IBM Plex Sans KR"/>
                           <a:cs typeface="IBM Plex Sans KR"/>
                         </a:rPr>
-                        <a:t>품질문 개선·배포 재현</a:t>
+                        <a:t>통합본 품질·배포 재현</a:t>
                       </a:r>
                       <a:endParaRPr sz="1200" u="none" strike="noStrike" cap="none">
                         <a:latin typeface="IBM Plex Sans KR"/>
@@ -12335,7 +12335,7 @@
                           <a:ea typeface="IBM Plex Sans KR"/>
                           <a:cs typeface="IBM Plex Sans KR"/>
                         </a:rPr>
-                        <a:t>후속 정리·엔진 응답 회복 후</a:t>
+                        <a:t>엔진 응답 회복 후</a:t>
                       </a:r>
                       <a:endParaRPr sz="1200" u="none" strike="noStrike" cap="none">
                         <a:latin typeface="IBM Plex Sans KR"/>
@@ -12651,7 +12651,7 @@
           <p:cNvPr id="296" name="Google Shape;296;p13">
             <a:extLst xmlns:a="http://schemas.openxmlformats.org/drawingml/2006/main">
               <a:ext uri="{FF2B5EF4-FFF2-40B4-BE49-F238E27FC236}">
-                <a16:creationId xmlns:a16="http://schemas.microsoft.com/office/drawing/2014/main" id="{DDEB33DB-97D3-4C47-8FE1-6D1FC62CA090}"/>
+                <a16:creationId xmlns:a16="http://schemas.microsoft.com/office/drawing/2014/main" id="{55D55C5A-EAC4-4B1B-8BB7-F0FFE6F471E0}"/>
               </a:ext>
             </a:extLst>
           </p:cNvPr>
@@ -12704,7 +12704,7 @@
           <p:cNvPr id="297" name="Google Shape;297;p13">
             <a:extLst xmlns:a="http://schemas.openxmlformats.org/drawingml/2006/main">
               <a:ext uri="{FF2B5EF4-FFF2-40B4-BE49-F238E27FC236}">
-                <a16:creationId xmlns:a16="http://schemas.microsoft.com/office/drawing/2014/main" id="{FFE84666-8F79-4022-A04A-AB31735C388B}"/>
+                <a16:creationId xmlns:a16="http://schemas.microsoft.com/office/drawing/2014/main" id="{6A68FC25-7DEC-4E4C-A04F-799E9BC245CA}"/>
               </a:ext>
             </a:extLst>
           </p:cNvPr>
@@ -12885,7 +12885,7 @@
           <p:cNvPr id="298" name="Google Shape;298;p13">
             <a:extLst xmlns:a="http://schemas.openxmlformats.org/drawingml/2006/main">
               <a:ext uri="{FF2B5EF4-FFF2-40B4-BE49-F238E27FC236}">
-                <a16:creationId xmlns:a16="http://schemas.microsoft.com/office/drawing/2014/main" id="{5D3A5BE3-C55C-45E6-AE78-2FFFD9D399C2}"/>
+                <a16:creationId xmlns:a16="http://schemas.microsoft.com/office/drawing/2014/main" id="{B4DC8379-C17F-41F7-B46D-ADCB8D44DE25}"/>
               </a:ext>
             </a:extLst>
           </p:cNvPr>
@@ -13112,7 +13112,7 @@
           <p:cNvPr id="299" name="Google Shape;299;p13">
             <a:extLst xmlns:a="http://schemas.openxmlformats.org/drawingml/2006/main">
               <a:ext uri="{FF2B5EF4-FFF2-40B4-BE49-F238E27FC236}">
-                <a16:creationId xmlns:a16="http://schemas.microsoft.com/office/drawing/2014/main" id="{50C73DD2-6DA1-4F45-A51B-164C0F058D60}"/>
+                <a16:creationId xmlns:a16="http://schemas.microsoft.com/office/drawing/2014/main" id="{BCE4B0DE-4FDA-4656-85FB-C28B408BAD2F}"/>
               </a:ext>
             </a:extLst>
           </p:cNvPr>
@@ -13184,7 +13184,7 @@
           <p:cNvPr id="300" name="Google Shape;300;p13">
             <a:extLst xmlns:a="http://schemas.openxmlformats.org/drawingml/2006/main">
               <a:ext uri="{FF2B5EF4-FFF2-40B4-BE49-F238E27FC236}">
-                <a16:creationId xmlns:a16="http://schemas.microsoft.com/office/drawing/2014/main" id="{CEB54AB0-3E59-49B1-BF4D-184B10094C92}"/>
+                <a16:creationId xmlns:a16="http://schemas.microsoft.com/office/drawing/2014/main" id="{D5A7DA34-4233-4C9D-8526-D3693A4C7FF9}"/>
               </a:ext>
             </a:extLst>
           </p:cNvPr>
@@ -13254,7 +13254,7 @@
     </p:spTree>
     <p:extLst>
       <p:ext uri="{BB962C8B-B14F-4D97-AF65-F5344CB8AC3E}">
-        <p14:creationId xmlns:p14="http://schemas.microsoft.com/office/powerpoint/2010/main" val="1304948283"/>
+        <p14:creationId xmlns:p14="http://schemas.microsoft.com/office/powerpoint/2010/main" val="1329317387"/>
       </p:ext>
     </p:extLst>
   </p:cSld>
@@ -13285,7 +13285,7 @@
           <p:cNvPr id="306" name="Google Shape;306;p14">
             <a:extLst xmlns:a="http://schemas.openxmlformats.org/drawingml/2006/main">
               <a:ext uri="{FF2B5EF4-FFF2-40B4-BE49-F238E27FC236}">
-                <a16:creationId xmlns:a16="http://schemas.microsoft.com/office/drawing/2014/main" id="{4A410736-9828-440B-9D48-83E020B4C0BF}"/>
+                <a16:creationId xmlns:a16="http://schemas.microsoft.com/office/drawing/2014/main" id="{9A5DF946-2200-41AF-92CC-48B12F66CDEB}"/>
               </a:ext>
             </a:extLst>
           </p:cNvPr>
@@ -13338,7 +13338,7 @@
           <p:cNvPr id="307" name="Google Shape;307;p14">
             <a:extLst xmlns:a="http://schemas.openxmlformats.org/drawingml/2006/main">
               <a:ext uri="{FF2B5EF4-FFF2-40B4-BE49-F238E27FC236}">
-                <a16:creationId xmlns:a16="http://schemas.microsoft.com/office/drawing/2014/main" id="{E02A93C1-0B2B-435A-94AB-BBE99A01997D}"/>
+                <a16:creationId xmlns:a16="http://schemas.microsoft.com/office/drawing/2014/main" id="{19ABDC33-1A98-4982-AEE0-0EBEDFD2D0C4}"/>
               </a:ext>
             </a:extLst>
           </p:cNvPr>
@@ -13391,7 +13391,7 @@
           <p:cNvPr id="308" name="Google Shape;308;p14">
             <a:extLst xmlns:a="http://schemas.openxmlformats.org/drawingml/2006/main">
               <a:ext uri="{FF2B5EF4-FFF2-40B4-BE49-F238E27FC236}">
-                <a16:creationId xmlns:a16="http://schemas.microsoft.com/office/drawing/2014/main" id="{F070EFD8-733D-417A-942D-7B5E03788F2E}"/>
+                <a16:creationId xmlns:a16="http://schemas.microsoft.com/office/drawing/2014/main" id="{CDB16EBE-DE4D-49D6-8DC3-E1744637FBDA}"/>
               </a:ext>
             </a:extLst>
           </p:cNvPr>
@@ -13458,7 +13458,7 @@
           <p:cNvPr id="309" name="Google Shape;309;p14">
             <a:extLst xmlns:a="http://schemas.openxmlformats.org/drawingml/2006/main">
               <a:ext uri="{FF2B5EF4-FFF2-40B4-BE49-F238E27FC236}">
-                <a16:creationId xmlns:a16="http://schemas.microsoft.com/office/drawing/2014/main" id="{7156581C-E7B5-45A3-B575-A8E3A996FE86}"/>
+                <a16:creationId xmlns:a16="http://schemas.microsoft.com/office/drawing/2014/main" id="{E4DFFD4F-BFD7-429D-A101-98D3B8E5D623}"/>
               </a:ext>
             </a:extLst>
           </p:cNvPr>
@@ -13530,7 +13530,7 @@
           <p:cNvPr id="310" name="Google Shape;310;p14">
             <a:extLst xmlns:a="http://schemas.openxmlformats.org/drawingml/2006/main">
               <a:ext uri="{FF2B5EF4-FFF2-40B4-BE49-F238E27FC236}">
-                <a16:creationId xmlns:a16="http://schemas.microsoft.com/office/drawing/2014/main" id="{F0ADBC94-5F62-4CA9-9995-C9FFB3AA51A5}"/>
+                <a16:creationId xmlns:a16="http://schemas.microsoft.com/office/drawing/2014/main" id="{B8C3E11A-7297-4F8E-9E52-6D27ACC23157}"/>
               </a:ext>
             </a:extLst>
           </p:cNvPr>
@@ -13693,7 +13693,7 @@
                 <a:ea typeface="IBM Plex Sans KR"/>
                 <a:cs typeface="IBM Plex Sans KR"/>
               </a:rPr>
-              <a:t>5조 졸업각 · 프로젝트 코드·실행법·수업 대조표: 팀 공유 ZIP의 README</a:t>
+              <a:t>코드·실행법·팀원 원본·발표자료: github.com/on21life-google/jolup-graduation-agent</a:t>
             </a:r>
             <a:endParaRPr sz="1300" b="0" i="0" u="none" strike="noStrike" cap="none">
               <a:solidFill>
@@ -13711,7 +13711,7 @@
           <p:cNvPr id="311" name="Google Shape;311;p14">
             <a:extLst xmlns:a="http://schemas.openxmlformats.org/drawingml/2006/main">
               <a:ext uri="{FF2B5EF4-FFF2-40B4-BE49-F238E27FC236}">
-                <a16:creationId xmlns:a16="http://schemas.microsoft.com/office/drawing/2014/main" id="{57CFC6CB-AF18-4499-9A62-357CA6A31F2F}"/>
+                <a16:creationId xmlns:a16="http://schemas.microsoft.com/office/drawing/2014/main" id="{C301F775-F4FB-4B48-AEE9-135AC3C38989}"/>
               </a:ext>
             </a:extLst>
           </p:cNvPr>
@@ -13783,7 +13783,7 @@
           <p:cNvPr id="312" name="Google Shape;312;p14">
             <a:extLst xmlns:a="http://schemas.openxmlformats.org/drawingml/2006/main">
               <a:ext uri="{FF2B5EF4-FFF2-40B4-BE49-F238E27FC236}">
-                <a16:creationId xmlns:a16="http://schemas.microsoft.com/office/drawing/2014/main" id="{2006C31F-E5B4-44B1-8346-D3EA754D93CD}"/>
+                <a16:creationId xmlns:a16="http://schemas.microsoft.com/office/drawing/2014/main" id="{809AFFCB-ABF3-446F-9634-7A3FA0973530}"/>
               </a:ext>
             </a:extLst>
           </p:cNvPr>
@@ -13853,7 +13853,7 @@
     </p:spTree>
     <p:extLst>
       <p:ext uri="{BB962C8B-B14F-4D97-AF65-F5344CB8AC3E}">
-        <p14:creationId xmlns:p14="http://schemas.microsoft.com/office/powerpoint/2010/main" val="143508854"/>
+        <p14:creationId xmlns:p14="http://schemas.microsoft.com/office/powerpoint/2010/main" val="1394883979"/>
       </p:ext>
     </p:extLst>
   </p:cSld>
@@ -13884,7 +13884,7 @@
           <p:cNvPr id="34" name="Google Shape;34;p2">
             <a:extLst xmlns:a="http://schemas.openxmlformats.org/drawingml/2006/main">
               <a:ext uri="{FF2B5EF4-FFF2-40B4-BE49-F238E27FC236}">
-                <a16:creationId xmlns:a16="http://schemas.microsoft.com/office/drawing/2014/main" id="{793B0766-A16A-4C2F-87DA-9A7344130907}"/>
+                <a16:creationId xmlns:a16="http://schemas.microsoft.com/office/drawing/2014/main" id="{2ABA35A4-116E-47EF-9F76-B41A682B54EE}"/>
               </a:ext>
             </a:extLst>
           </p:cNvPr>
@@ -13956,7 +13956,7 @@
           <p:cNvPr id="35" name="Google Shape;35;p2">
             <a:extLst xmlns:a="http://schemas.openxmlformats.org/drawingml/2006/main">
               <a:ext uri="{FF2B5EF4-FFF2-40B4-BE49-F238E27FC236}">
-                <a16:creationId xmlns:a16="http://schemas.microsoft.com/office/drawing/2014/main" id="{8C11AE70-36DB-47D7-9400-0760AED9DB0C}"/>
+                <a16:creationId xmlns:a16="http://schemas.microsoft.com/office/drawing/2014/main" id="{6998138C-BE68-4A47-B946-258F67B9FAE4}"/>
               </a:ext>
             </a:extLst>
           </p:cNvPr>
@@ -14023,7 +14023,7 @@
           <p:cNvPr id="36" name="Google Shape;36;p2">
             <a:extLst xmlns:a="http://schemas.openxmlformats.org/drawingml/2006/main">
               <a:ext uri="{FF2B5EF4-FFF2-40B4-BE49-F238E27FC236}">
-                <a16:creationId xmlns:a16="http://schemas.microsoft.com/office/drawing/2014/main" id="{4D40BE49-AE43-42F3-8E9F-C55570AF37E3}"/>
+                <a16:creationId xmlns:a16="http://schemas.microsoft.com/office/drawing/2014/main" id="{4A674C62-F540-4530-98CF-699616DC9E4C}"/>
               </a:ext>
             </a:extLst>
           </p:cNvPr>
@@ -14076,7 +14076,7 @@
           <p:cNvPr id="37" name="Google Shape;37;p2">
             <a:extLst xmlns:a="http://schemas.openxmlformats.org/drawingml/2006/main">
               <a:ext uri="{FF2B5EF4-FFF2-40B4-BE49-F238E27FC236}">
-                <a16:creationId xmlns:a16="http://schemas.microsoft.com/office/drawing/2014/main" id="{E06DF1D1-F9FD-4A6E-94E2-3A156DE71DB4}"/>
+                <a16:creationId xmlns:a16="http://schemas.microsoft.com/office/drawing/2014/main" id="{DCB48811-BC6A-4BD1-9D7A-DA0EDB2ECFFC}"/>
               </a:ext>
             </a:extLst>
           </p:cNvPr>
@@ -14148,7 +14148,7 @@
           <p:cNvPr id="38" name="Google Shape;38;p2">
             <a:extLst xmlns:a="http://schemas.openxmlformats.org/drawingml/2006/main">
               <a:ext uri="{FF2B5EF4-FFF2-40B4-BE49-F238E27FC236}">
-                <a16:creationId xmlns:a16="http://schemas.microsoft.com/office/drawing/2014/main" id="{325B1844-FDF5-48DF-A929-7A83C0463544}"/>
+                <a16:creationId xmlns:a16="http://schemas.microsoft.com/office/drawing/2014/main" id="{23ACCE2B-92E3-4A3A-8560-55F17FFB325F}"/>
               </a:ext>
             </a:extLst>
           </p:cNvPr>
@@ -14329,7 +14329,7 @@
           <p:cNvPr id="39" name="Google Shape;39;p2">
             <a:extLst xmlns:a="http://schemas.openxmlformats.org/drawingml/2006/main">
               <a:ext uri="{FF2B5EF4-FFF2-40B4-BE49-F238E27FC236}">
-                <a16:creationId xmlns:a16="http://schemas.microsoft.com/office/drawing/2014/main" id="{87778493-6BC1-43B3-BE89-6A1A58404319}"/>
+                <a16:creationId xmlns:a16="http://schemas.microsoft.com/office/drawing/2014/main" id="{D6215DC8-FFFF-4ECC-8109-18C1A9A122F2}"/>
               </a:ext>
             </a:extLst>
           </p:cNvPr>
@@ -14360,7 +14360,7 @@
           <p:cNvPr id="40" name="Google Shape;40;p2">
             <a:extLst xmlns:a="http://schemas.openxmlformats.org/drawingml/2006/main">
               <a:ext uri="{FF2B5EF4-FFF2-40B4-BE49-F238E27FC236}">
-                <a16:creationId xmlns:a16="http://schemas.microsoft.com/office/drawing/2014/main" id="{EFD772BD-8F3E-4499-96BE-13E33227DBB5}"/>
+                <a16:creationId xmlns:a16="http://schemas.microsoft.com/office/drawing/2014/main" id="{B2C2388C-185B-4149-A454-21EBE270A5A4}"/>
               </a:ext>
             </a:extLst>
           </p:cNvPr>
@@ -14391,7 +14391,7 @@
           <p:cNvPr id="41" name="Google Shape;41;p2">
             <a:extLst xmlns:a="http://schemas.openxmlformats.org/drawingml/2006/main">
               <a:ext uri="{FF2B5EF4-FFF2-40B4-BE49-F238E27FC236}">
-                <a16:creationId xmlns:a16="http://schemas.microsoft.com/office/drawing/2014/main" id="{7F364CFA-AEC9-44D8-9AC1-4A518BDA6D81}"/>
+                <a16:creationId xmlns:a16="http://schemas.microsoft.com/office/drawing/2014/main" id="{9C686C83-B4D9-47CF-857B-B511227F5790}"/>
               </a:ext>
             </a:extLst>
           </p:cNvPr>
@@ -14516,7 +14516,7 @@
                           <a:ea typeface="IBM Plex Sans KR"/>
                           <a:cs typeface="IBM Plex Sans KR"/>
                         </a:rPr>
-                        <a:t>담당 역할</a:t>
+                        <a:t>담당 범위</a:t>
                       </a:r>
                       <a:endParaRPr sz="1200" u="none" strike="noStrike" cap="none">
                         <a:latin typeface="IBM Plex Sans KR"/>
@@ -14586,7 +14586,7 @@
                           <a:ea typeface="IBM Plex Sans KR"/>
                           <a:cs typeface="IBM Plex Sans KR"/>
                         </a:rPr>
-                        <a:t>구성요소</a:t>
+                        <a:t>제출·기존 산출물</a:t>
                       </a:r>
                       <a:endParaRPr sz="1200" u="none" strike="noStrike" cap="none">
                         <a:latin typeface="IBM Plex Sans KR"/>
@@ -14656,7 +14656,7 @@
                           <a:ea typeface="IBM Plex Sans KR"/>
                           <a:cs typeface="IBM Plex Sans KR"/>
                         </a:rPr>
-                        <a:t>검토·통합 대상</a:t>
+                        <a:t>이번 통합 결과</a:t>
                       </a:r>
                       <a:endParaRPr sz="1200" u="none" strike="noStrike" cap="none">
                         <a:latin typeface="IBM Plex Sans KR"/>
@@ -14862,7 +14862,7 @@
                           <a:ea typeface="IBM Plex Sans KR"/>
                           <a:cs typeface="IBM Plex Sans KR"/>
                         </a:rPr>
-                        <a:t>RAG / 청크 / 출처</a:t>
+                        <a:t>RAG 시험·색인 명세</a:t>
                       </a:r>
                       <a:endParaRPr sz="1200" u="none" strike="noStrike" cap="none">
                         <a:latin typeface="IBM Plex Sans KR"/>
@@ -14929,7 +14929,7 @@
                           <a:ea typeface="IBM Plex Sans KR"/>
                           <a:cs typeface="IBM Plex Sans KR"/>
                         </a:rPr>
-                        <a:t>원문·페이지·회수 결과</a:t>
+                        <a:t>NFC·조문·출처 메타 강화</a:t>
                       </a:r>
                       <a:endParaRPr sz="1200" u="none" strike="noStrike" cap="none">
                         <a:latin typeface="IBM Plex Sans KR"/>
@@ -15132,7 +15132,7 @@
                           <a:ea typeface="IBM Plex Sans KR"/>
                           <a:cs typeface="IBM Plex Sans KR"/>
                         </a:rPr>
-                        <a:t>CSV / 학점 계산 / 후보 계획</a:t>
+                        <a:t>기존 학사 계산·후보 계획</a:t>
                       </a:r>
                       <a:endParaRPr sz="1200" u="none" strike="noStrike" cap="none">
                         <a:latin typeface="IBM Plex Sans KR"/>
@@ -15199,7 +15199,7 @@
                           <a:ea typeface="IBM Plex Sans KR"/>
                           <a:cs typeface="IBM Plex Sans KR"/>
                         </a:rPr>
-                        <a:t>영역별 정답·경계 사례</a:t>
+                        <a:t>정답 규칙 유지·전체 통합</a:t>
                       </a:r>
                       <a:endParaRPr sz="1200" u="none" strike="noStrike" cap="none">
                         <a:latin typeface="IBM Plex Sans KR"/>
@@ -15335,7 +15335,7 @@
                           <a:ea typeface="IBM Plex Sans KR"/>
                           <a:cs typeface="IBM Plex Sans KR"/>
                         </a:rPr>
-                        <a:t>Agent·화면·일정</a:t>
+                        <a:t>화면 디자인·일정</a:t>
                       </a:r>
                       <a:endParaRPr sz="1200" u="none" strike="noStrike" cap="none">
                         <a:latin typeface="IBM Plex Sans KR"/>
@@ -15402,7 +15402,7 @@
                           <a:ea typeface="IBM Plex Sans KR"/>
                           <a:cs typeface="IBM Plex Sans KR"/>
                         </a:rPr>
-                        <a:t>라우팅 / UI / 승인 ICS</a:t>
+                        <a:t>HTML 시안·달력·과목 담기</a:t>
                       </a:r>
                       <a:endParaRPr sz="1200" u="none" strike="noStrike" cap="none">
                         <a:latin typeface="IBM Plex Sans KR"/>
@@ -15469,7 +15469,7 @@
                           <a:ea typeface="IBM Plex Sans KR"/>
                           <a:cs typeface="IBM Plex Sans KR"/>
                         </a:rPr>
-                        <a:t>실행 연결·예외·일정 승인</a:t>
+                        <a:t>디자인·월간 달력·관심 목록</a:t>
                       </a:r>
                       <a:endParaRPr sz="1200" u="none" strike="noStrike" cap="none">
                         <a:latin typeface="IBM Plex Sans KR"/>
@@ -15515,7 +15515,7 @@
           <p:cNvPr id="42" name="Google Shape;42;p2">
             <a:extLst xmlns:a="http://schemas.openxmlformats.org/drawingml/2006/main">
               <a:ext uri="{FF2B5EF4-FFF2-40B4-BE49-F238E27FC236}">
-                <a16:creationId xmlns:a16="http://schemas.microsoft.com/office/drawing/2014/main" id="{2EAA40B4-5CB2-4F5C-9779-D37A260037A7}"/>
+                <a16:creationId xmlns:a16="http://schemas.microsoft.com/office/drawing/2014/main" id="{E293550C-51FA-469F-9844-AC34C67C6565}"/>
               </a:ext>
             </a:extLst>
           </p:cNvPr>
@@ -15587,7 +15587,7 @@
           <p:cNvPr id="43" name="Google Shape;43;p2">
             <a:extLst xmlns:a="http://schemas.openxmlformats.org/drawingml/2006/main">
               <a:ext uri="{FF2B5EF4-FFF2-40B4-BE49-F238E27FC236}">
-                <a16:creationId xmlns:a16="http://schemas.microsoft.com/office/drawing/2014/main" id="{AD2C22D6-8F09-49A6-9F3B-43DCBB81E595}"/>
+                <a16:creationId xmlns:a16="http://schemas.microsoft.com/office/drawing/2014/main" id="{C8423367-3D65-425E-9250-392086AF723E}"/>
               </a:ext>
             </a:extLst>
           </p:cNvPr>
@@ -15659,7 +15659,7 @@
           <p:cNvPr id="44" name="team-disclosure">
             <a:extLst xmlns:a="http://schemas.openxmlformats.org/drawingml/2006/main">
               <a:ext uri="{FF2B5EF4-FFF2-40B4-BE49-F238E27FC236}">
-                <a16:creationId xmlns:a16="http://schemas.microsoft.com/office/drawing/2014/main" id="{471ED139-CFA1-4E51-958A-22CE561DE9F9}"/>
+                <a16:creationId xmlns:a16="http://schemas.microsoft.com/office/drawing/2014/main" id="{AC27BEDB-FA96-4BDC-B6FB-3C49C8CEC4EA}"/>
               </a:ext>
             </a:extLst>
           </p:cNvPr>
@@ -15809,7 +15809,7 @@
                 <a:ea typeface="IBM Plex Sans KR"/>
                 <a:cs typeface="IBM Plex Sans KR"/>
               </a:rPr>
-              <a:t>담당 구분은 합의한 역할이다. AI로 작성한 통합본을 검토 중이며, 팀원별 최종 파일은 수령 후 병합한다.</a:t>
+              <a:t>수진의 디자인·상호작용, 주미의 RAG 시험 명세를 기존 계산 엔진에 연결했다. 통합 재구현·검증은 AI로 수행했다.</a:t>
             </a:r>
           </a:p>
         </p:txBody>
@@ -15817,7 +15817,7 @@
     </p:spTree>
     <p:extLst>
       <p:ext uri="{BB962C8B-B14F-4D97-AF65-F5344CB8AC3E}">
-        <p14:creationId xmlns:p14="http://schemas.microsoft.com/office/powerpoint/2010/main" val="568837843"/>
+        <p14:creationId xmlns:p14="http://schemas.microsoft.com/office/powerpoint/2010/main" val="417183885"/>
       </p:ext>
     </p:extLst>
   </p:cSld>
@@ -15848,7 +15848,7 @@
           <p:cNvPr id="49" name="Google Shape;49;p3">
             <a:extLst xmlns:a="http://schemas.openxmlformats.org/drawingml/2006/main">
               <a:ext uri="{FF2B5EF4-FFF2-40B4-BE49-F238E27FC236}">
-                <a16:creationId xmlns:a16="http://schemas.microsoft.com/office/drawing/2014/main" id="{10C1FCA2-942B-4CDE-AFA7-747828A3DCD3}"/>
+                <a16:creationId xmlns:a16="http://schemas.microsoft.com/office/drawing/2014/main" id="{3461B454-2BC1-411C-A225-B06961DA508C}"/>
               </a:ext>
             </a:extLst>
           </p:cNvPr>
@@ -15920,7 +15920,7 @@
           <p:cNvPr id="50" name="Google Shape;50;p3">
             <a:extLst xmlns:a="http://schemas.openxmlformats.org/drawingml/2006/main">
               <a:ext uri="{FF2B5EF4-FFF2-40B4-BE49-F238E27FC236}">
-                <a16:creationId xmlns:a16="http://schemas.microsoft.com/office/drawing/2014/main" id="{FBA37B67-F82E-4421-8539-2B3DBB21FC79}"/>
+                <a16:creationId xmlns:a16="http://schemas.microsoft.com/office/drawing/2014/main" id="{7D9D8131-C4CA-4FF7-8DEB-2FA9E8B12688}"/>
               </a:ext>
             </a:extLst>
           </p:cNvPr>
@@ -15987,7 +15987,7 @@
           <p:cNvPr id="51" name="Google Shape;51;p3">
             <a:extLst xmlns:a="http://schemas.openxmlformats.org/drawingml/2006/main">
               <a:ext uri="{FF2B5EF4-FFF2-40B4-BE49-F238E27FC236}">
-                <a16:creationId xmlns:a16="http://schemas.microsoft.com/office/drawing/2014/main" id="{E7B93BD1-06FD-4B23-BAED-EB6A4A0D2188}"/>
+                <a16:creationId xmlns:a16="http://schemas.microsoft.com/office/drawing/2014/main" id="{D8F79A55-6D0B-4A35-8D69-F8870B9162E2}"/>
               </a:ext>
             </a:extLst>
           </p:cNvPr>
@@ -16040,7 +16040,7 @@
           <p:cNvPr id="52" name="Google Shape;52;p3">
             <a:extLst xmlns:a="http://schemas.openxmlformats.org/drawingml/2006/main">
               <a:ext uri="{FF2B5EF4-FFF2-40B4-BE49-F238E27FC236}">
-                <a16:creationId xmlns:a16="http://schemas.microsoft.com/office/drawing/2014/main" id="{B0BBDBF2-C9BF-43A4-AE61-9DB27302AD25}"/>
+                <a16:creationId xmlns:a16="http://schemas.microsoft.com/office/drawing/2014/main" id="{96DF2FDE-57C9-4089-B3F5-26B19206DE3D}"/>
               </a:ext>
             </a:extLst>
           </p:cNvPr>
@@ -16112,7 +16112,7 @@
           <p:cNvPr id="53" name="Google Shape;53;p3">
             <a:extLst xmlns:a="http://schemas.openxmlformats.org/drawingml/2006/main">
               <a:ext uri="{FF2B5EF4-FFF2-40B4-BE49-F238E27FC236}">
-                <a16:creationId xmlns:a16="http://schemas.microsoft.com/office/drawing/2014/main" id="{E73E2B05-8E4C-49CA-9B54-B51168E78350}"/>
+                <a16:creationId xmlns:a16="http://schemas.microsoft.com/office/drawing/2014/main" id="{439EAC16-72A4-434A-939A-01C96D604413}"/>
               </a:ext>
             </a:extLst>
           </p:cNvPr>
@@ -16293,7 +16293,7 @@
           <p:cNvPr id="54" name="Google Shape;54;p3">
             <a:extLst xmlns:a="http://schemas.openxmlformats.org/drawingml/2006/main">
               <a:ext uri="{FF2B5EF4-FFF2-40B4-BE49-F238E27FC236}">
-                <a16:creationId xmlns:a16="http://schemas.microsoft.com/office/drawing/2014/main" id="{C57EE437-00C8-436E-8F17-24DD248A6410}"/>
+                <a16:creationId xmlns:a16="http://schemas.microsoft.com/office/drawing/2014/main" id="{462A21EB-58DE-4148-9C57-EF1264653818}"/>
               </a:ext>
             </a:extLst>
           </p:cNvPr>
@@ -16474,7 +16474,7 @@
           <p:cNvPr id="55" name="Google Shape;55;p3">
             <a:extLst xmlns:a="http://schemas.openxmlformats.org/drawingml/2006/main">
               <a:ext uri="{FF2B5EF4-FFF2-40B4-BE49-F238E27FC236}">
-                <a16:creationId xmlns:a16="http://schemas.microsoft.com/office/drawing/2014/main" id="{DEA2E02A-B389-4455-A8B5-6E789516707E}"/>
+                <a16:creationId xmlns:a16="http://schemas.microsoft.com/office/drawing/2014/main" id="{E46603CB-0077-479E-9DD6-B557685376FC}"/>
               </a:ext>
             </a:extLst>
           </p:cNvPr>
@@ -16655,7 +16655,7 @@
           <p:cNvPr id="56" name="Google Shape;56;p3">
             <a:extLst xmlns:a="http://schemas.openxmlformats.org/drawingml/2006/main">
               <a:ext uri="{FF2B5EF4-FFF2-40B4-BE49-F238E27FC236}">
-                <a16:creationId xmlns:a16="http://schemas.microsoft.com/office/drawing/2014/main" id="{E15016C5-EF8F-4366-A541-7BD7FCDACE41}"/>
+                <a16:creationId xmlns:a16="http://schemas.microsoft.com/office/drawing/2014/main" id="{30ED784B-C6CB-43B8-AF88-EB44A5EC43C8}"/>
               </a:ext>
             </a:extLst>
           </p:cNvPr>
@@ -16714,7 +16714,7 @@
           <p:cNvPr id="57" name="Google Shape;57;p3">
             <a:extLst xmlns:a="http://schemas.openxmlformats.org/drawingml/2006/main">
               <a:ext uri="{FF2B5EF4-FFF2-40B4-BE49-F238E27FC236}">
-                <a16:creationId xmlns:a16="http://schemas.microsoft.com/office/drawing/2014/main" id="{1EA1CCFA-0EDA-4FE8-A763-02A670D11A4A}"/>
+                <a16:creationId xmlns:a16="http://schemas.microsoft.com/office/drawing/2014/main" id="{876A2F27-C589-4FB2-B621-A75DB5E2D45A}"/>
               </a:ext>
             </a:extLst>
           </p:cNvPr>
@@ -16786,7 +16786,7 @@
           <p:cNvPr id="58" name="Google Shape;58;p3">
             <a:extLst xmlns:a="http://schemas.openxmlformats.org/drawingml/2006/main">
               <a:ext uri="{FF2B5EF4-FFF2-40B4-BE49-F238E27FC236}">
-                <a16:creationId xmlns:a16="http://schemas.microsoft.com/office/drawing/2014/main" id="{0142091D-2D02-44F3-A978-0E6DAE121923}"/>
+                <a16:creationId xmlns:a16="http://schemas.microsoft.com/office/drawing/2014/main" id="{37A58532-8301-4FE7-B41B-77B2479CCC8A}"/>
               </a:ext>
             </a:extLst>
           </p:cNvPr>
@@ -16967,7 +16967,7 @@
           <p:cNvPr id="59" name="Google Shape;59;p3">
             <a:extLst xmlns:a="http://schemas.openxmlformats.org/drawingml/2006/main">
               <a:ext uri="{FF2B5EF4-FFF2-40B4-BE49-F238E27FC236}">
-                <a16:creationId xmlns:a16="http://schemas.microsoft.com/office/drawing/2014/main" id="{245E6064-EF18-4DC7-AD74-8A312C5C7D4A}"/>
+                <a16:creationId xmlns:a16="http://schemas.microsoft.com/office/drawing/2014/main" id="{8187C626-FA27-41BA-BE56-916EB9D4FB00}"/>
               </a:ext>
             </a:extLst>
           </p:cNvPr>
@@ -17148,7 +17148,7 @@
           <p:cNvPr id="60" name="Google Shape;60;p3">
             <a:extLst xmlns:a="http://schemas.openxmlformats.org/drawingml/2006/main">
               <a:ext uri="{FF2B5EF4-FFF2-40B4-BE49-F238E27FC236}">
-                <a16:creationId xmlns:a16="http://schemas.microsoft.com/office/drawing/2014/main" id="{BC18421A-BAF5-4912-AE3A-5ECAFC539774}"/>
+                <a16:creationId xmlns:a16="http://schemas.microsoft.com/office/drawing/2014/main" id="{18EA52D3-3A30-4A10-91DE-5D22FA1019CD}"/>
               </a:ext>
             </a:extLst>
           </p:cNvPr>
@@ -17329,7 +17329,7 @@
           <p:cNvPr id="61" name="Google Shape;61;p3">
             <a:extLst xmlns:a="http://schemas.openxmlformats.org/drawingml/2006/main">
               <a:ext uri="{FF2B5EF4-FFF2-40B4-BE49-F238E27FC236}">
-                <a16:creationId xmlns:a16="http://schemas.microsoft.com/office/drawing/2014/main" id="{AEE5656D-4A86-4B45-9895-354E1DB5E105}"/>
+                <a16:creationId xmlns:a16="http://schemas.microsoft.com/office/drawing/2014/main" id="{E14D6558-7AC3-462A-8135-61669B0D19AC}"/>
               </a:ext>
             </a:extLst>
           </p:cNvPr>
@@ -17401,7 +17401,7 @@
           <p:cNvPr id="62" name="Google Shape;62;p3">
             <a:extLst xmlns:a="http://schemas.openxmlformats.org/drawingml/2006/main">
               <a:ext uri="{FF2B5EF4-FFF2-40B4-BE49-F238E27FC236}">
-                <a16:creationId xmlns:a16="http://schemas.microsoft.com/office/drawing/2014/main" id="{9597DC33-E101-4C60-9545-658AA86F1CB3}"/>
+                <a16:creationId xmlns:a16="http://schemas.microsoft.com/office/drawing/2014/main" id="{606DE2E4-3F94-4AF5-A20A-AA3D1DE4BB26}"/>
               </a:ext>
             </a:extLst>
           </p:cNvPr>
@@ -17473,7 +17473,7 @@
           <p:cNvPr id="63" name="scope">
             <a:extLst xmlns:a="http://schemas.openxmlformats.org/drawingml/2006/main">
               <a:ext uri="{FF2B5EF4-FFF2-40B4-BE49-F238E27FC236}">
-                <a16:creationId xmlns:a16="http://schemas.microsoft.com/office/drawing/2014/main" id="{833B50A4-D2E5-403A-9CEC-3138E13BC079}"/>
+                <a16:creationId xmlns:a16="http://schemas.microsoft.com/office/drawing/2014/main" id="{63333095-0D70-4459-AB26-0F2252FEE3A5}"/>
               </a:ext>
             </a:extLst>
           </p:cNvPr>
@@ -17631,7 +17631,7 @@
     </p:spTree>
     <p:extLst>
       <p:ext uri="{BB962C8B-B14F-4D97-AF65-F5344CB8AC3E}">
-        <p14:creationId xmlns:p14="http://schemas.microsoft.com/office/powerpoint/2010/main" val="2121215111"/>
+        <p14:creationId xmlns:p14="http://schemas.microsoft.com/office/powerpoint/2010/main" val="881290157"/>
       </p:ext>
     </p:extLst>
   </p:cSld>
@@ -17662,7 +17662,7 @@
           <p:cNvPr id="68" name="Google Shape;68;p4">
             <a:extLst xmlns:a="http://schemas.openxmlformats.org/drawingml/2006/main">
               <a:ext uri="{FF2B5EF4-FFF2-40B4-BE49-F238E27FC236}">
-                <a16:creationId xmlns:a16="http://schemas.microsoft.com/office/drawing/2014/main" id="{75F3FBDF-5298-488F-A9EA-B84EF18930C8}"/>
+                <a16:creationId xmlns:a16="http://schemas.microsoft.com/office/drawing/2014/main" id="{BBDF2318-EC7F-4FAA-B4FB-481248B292B6}"/>
               </a:ext>
             </a:extLst>
           </p:cNvPr>
@@ -17734,7 +17734,7 @@
           <p:cNvPr id="69" name="Google Shape;69;p4">
             <a:extLst xmlns:a="http://schemas.openxmlformats.org/drawingml/2006/main">
               <a:ext uri="{FF2B5EF4-FFF2-40B4-BE49-F238E27FC236}">
-                <a16:creationId xmlns:a16="http://schemas.microsoft.com/office/drawing/2014/main" id="{AFE9126E-E01B-4D6A-A3ED-5E8012195DBA}"/>
+                <a16:creationId xmlns:a16="http://schemas.microsoft.com/office/drawing/2014/main" id="{7B905E27-2A18-4F73-8527-DD8FB71974AB}"/>
               </a:ext>
             </a:extLst>
           </p:cNvPr>
@@ -17801,7 +17801,7 @@
           <p:cNvPr id="70" name="Google Shape;70;p4">
             <a:extLst xmlns:a="http://schemas.openxmlformats.org/drawingml/2006/main">
               <a:ext uri="{FF2B5EF4-FFF2-40B4-BE49-F238E27FC236}">
-                <a16:creationId xmlns:a16="http://schemas.microsoft.com/office/drawing/2014/main" id="{2B1D751A-47FC-4ECA-8055-711ABD130DB5}"/>
+                <a16:creationId xmlns:a16="http://schemas.microsoft.com/office/drawing/2014/main" id="{58FCC526-A7F4-4BEB-A31B-A754B03C35DA}"/>
               </a:ext>
             </a:extLst>
           </p:cNvPr>
@@ -17854,7 +17854,7 @@
           <p:cNvPr id="71" name="Google Shape;71;p4">
             <a:extLst xmlns:a="http://schemas.openxmlformats.org/drawingml/2006/main">
               <a:ext uri="{FF2B5EF4-FFF2-40B4-BE49-F238E27FC236}">
-                <a16:creationId xmlns:a16="http://schemas.microsoft.com/office/drawing/2014/main" id="{7B8959B4-0504-48D2-8632-ACE650C23E20}"/>
+                <a16:creationId xmlns:a16="http://schemas.microsoft.com/office/drawing/2014/main" id="{3488D915-D83B-4866-88DF-D637328E1853}"/>
               </a:ext>
             </a:extLst>
           </p:cNvPr>
@@ -17926,7 +17926,7 @@
           <p:cNvPr id="72" name="Google Shape;72;p4">
             <a:extLst xmlns:a="http://schemas.openxmlformats.org/drawingml/2006/main">
               <a:ext uri="{FF2B5EF4-FFF2-40B4-BE49-F238E27FC236}">
-                <a16:creationId xmlns:a16="http://schemas.microsoft.com/office/drawing/2014/main" id="{8086BC30-B9B1-4A0A-BE91-8725AAF341B0}"/>
+                <a16:creationId xmlns:a16="http://schemas.microsoft.com/office/drawing/2014/main" id="{F651EA05-CD28-4AD0-B857-84EACD7A3DFB}"/>
               </a:ext>
             </a:extLst>
           </p:cNvPr>
@@ -18153,7 +18153,7 @@
           <p:cNvPr id="73" name="Google Shape;73;p4">
             <a:extLst xmlns:a="http://schemas.openxmlformats.org/drawingml/2006/main">
               <a:ext uri="{FF2B5EF4-FFF2-40B4-BE49-F238E27FC236}">
-                <a16:creationId xmlns:a16="http://schemas.microsoft.com/office/drawing/2014/main" id="{CC2F35B9-620F-44EB-AF84-E86049C452DD}"/>
+                <a16:creationId xmlns:a16="http://schemas.microsoft.com/office/drawing/2014/main" id="{B7FCDD6C-B8CC-4517-914E-1CC5A9A5FB71}"/>
               </a:ext>
             </a:extLst>
           </p:cNvPr>
@@ -18212,7 +18212,7 @@
           <p:cNvPr id="74" name="Google Shape;74;p4">
             <a:extLst xmlns:a="http://schemas.openxmlformats.org/drawingml/2006/main">
               <a:ext uri="{FF2B5EF4-FFF2-40B4-BE49-F238E27FC236}">
-                <a16:creationId xmlns:a16="http://schemas.microsoft.com/office/drawing/2014/main" id="{7D445977-7F9C-4827-BA9B-21C0EAA9DEB0}"/>
+                <a16:creationId xmlns:a16="http://schemas.microsoft.com/office/drawing/2014/main" id="{4ED397FF-FE02-46A4-AA69-25A3FF9B0858}"/>
               </a:ext>
             </a:extLst>
           </p:cNvPr>
@@ -18284,7 +18284,7 @@
           <p:cNvPr id="75" name="Google Shape;75;p4">
             <a:extLst xmlns:a="http://schemas.openxmlformats.org/drawingml/2006/main">
               <a:ext uri="{FF2B5EF4-FFF2-40B4-BE49-F238E27FC236}">
-                <a16:creationId xmlns:a16="http://schemas.microsoft.com/office/drawing/2014/main" id="{D3A3566D-3F51-4FBF-90D2-6C0041B54DC1}"/>
+                <a16:creationId xmlns:a16="http://schemas.microsoft.com/office/drawing/2014/main" id="{1B0C878C-E987-47A3-9A44-DCDA7FF41A8D}"/>
               </a:ext>
             </a:extLst>
           </p:cNvPr>
@@ -18465,7 +18465,7 @@
           <p:cNvPr id="76" name="Google Shape;76;p4">
             <a:extLst xmlns:a="http://schemas.openxmlformats.org/drawingml/2006/main">
               <a:ext uri="{FF2B5EF4-FFF2-40B4-BE49-F238E27FC236}">
-                <a16:creationId xmlns:a16="http://schemas.microsoft.com/office/drawing/2014/main" id="{AD7595EC-1DAC-4214-BE3E-7F81B4C28670}"/>
+                <a16:creationId xmlns:a16="http://schemas.microsoft.com/office/drawing/2014/main" id="{FAC1138D-93D6-46B0-B29B-E0AFBEE0B2C0}"/>
               </a:ext>
             </a:extLst>
           </p:cNvPr>
@@ -18646,7 +18646,7 @@
           <p:cNvPr id="77" name="Google Shape;77;p4">
             <a:extLst xmlns:a="http://schemas.openxmlformats.org/drawingml/2006/main">
               <a:ext uri="{FF2B5EF4-FFF2-40B4-BE49-F238E27FC236}">
-                <a16:creationId xmlns:a16="http://schemas.microsoft.com/office/drawing/2014/main" id="{0EB93BEA-5856-44C1-9185-BEAE7F9EC50E}"/>
+                <a16:creationId xmlns:a16="http://schemas.microsoft.com/office/drawing/2014/main" id="{E2D4B9BA-8576-4DBB-90B8-EBA31447E2D7}"/>
               </a:ext>
             </a:extLst>
           </p:cNvPr>
@@ -18705,7 +18705,7 @@
           <p:cNvPr id="78" name="Google Shape;78;p4">
             <a:extLst xmlns:a="http://schemas.openxmlformats.org/drawingml/2006/main">
               <a:ext uri="{FF2B5EF4-FFF2-40B4-BE49-F238E27FC236}">
-                <a16:creationId xmlns:a16="http://schemas.microsoft.com/office/drawing/2014/main" id="{E22E2248-BF6C-4234-A60C-3DFB4CBE2253}"/>
+                <a16:creationId xmlns:a16="http://schemas.microsoft.com/office/drawing/2014/main" id="{A559A614-EA31-474E-A79A-ABE18DEA5C9F}"/>
               </a:ext>
             </a:extLst>
           </p:cNvPr>
@@ -18777,7 +18777,7 @@
           <p:cNvPr id="79" name="Google Shape;79;p4">
             <a:extLst xmlns:a="http://schemas.openxmlformats.org/drawingml/2006/main">
               <a:ext uri="{FF2B5EF4-FFF2-40B4-BE49-F238E27FC236}">
-                <a16:creationId xmlns:a16="http://schemas.microsoft.com/office/drawing/2014/main" id="{73E37DA2-3B8F-4C2F-A15D-BE379F0592A9}"/>
+                <a16:creationId xmlns:a16="http://schemas.microsoft.com/office/drawing/2014/main" id="{3BEDD47C-D4D1-4944-A1AA-E250098FB096}"/>
               </a:ext>
             </a:extLst>
           </p:cNvPr>
@@ -18958,7 +18958,7 @@
           <p:cNvPr id="80" name="Google Shape;80;p4">
             <a:extLst xmlns:a="http://schemas.openxmlformats.org/drawingml/2006/main">
               <a:ext uri="{FF2B5EF4-FFF2-40B4-BE49-F238E27FC236}">
-                <a16:creationId xmlns:a16="http://schemas.microsoft.com/office/drawing/2014/main" id="{F51528B2-6004-46A6-BF40-28C18F95EEE3}"/>
+                <a16:creationId xmlns:a16="http://schemas.microsoft.com/office/drawing/2014/main" id="{D6525829-BD7B-4BB4-9564-8783AFD92DDA}"/>
               </a:ext>
             </a:extLst>
           </p:cNvPr>
@@ -19139,7 +19139,7 @@
           <p:cNvPr id="81" name="Google Shape;81;p4">
             <a:extLst xmlns:a="http://schemas.openxmlformats.org/drawingml/2006/main">
               <a:ext uri="{FF2B5EF4-FFF2-40B4-BE49-F238E27FC236}">
-                <a16:creationId xmlns:a16="http://schemas.microsoft.com/office/drawing/2014/main" id="{C8812CAB-2A89-4C5F-A91B-A0F2A04478EF}"/>
+                <a16:creationId xmlns:a16="http://schemas.microsoft.com/office/drawing/2014/main" id="{84EBE2A2-17EE-4257-8E89-D3BC1D684C3F}"/>
               </a:ext>
             </a:extLst>
           </p:cNvPr>
@@ -19320,7 +19320,7 @@
           <p:cNvPr id="82" name="Google Shape;82;p4">
             <a:extLst xmlns:a="http://schemas.openxmlformats.org/drawingml/2006/main">
               <a:ext uri="{FF2B5EF4-FFF2-40B4-BE49-F238E27FC236}">
-                <a16:creationId xmlns:a16="http://schemas.microsoft.com/office/drawing/2014/main" id="{B671F954-1103-4B87-8E48-78892CCA6F68}"/>
+                <a16:creationId xmlns:a16="http://schemas.microsoft.com/office/drawing/2014/main" id="{CE16B9E5-48BC-4F9D-8B27-A5FE7D8FAD56}"/>
               </a:ext>
             </a:extLst>
           </p:cNvPr>
@@ -19373,7 +19373,7 @@
           <p:cNvPr id="83" name="Google Shape;83;p4">
             <a:extLst xmlns:a="http://schemas.openxmlformats.org/drawingml/2006/main">
               <a:ext uri="{FF2B5EF4-FFF2-40B4-BE49-F238E27FC236}">
-                <a16:creationId xmlns:a16="http://schemas.microsoft.com/office/drawing/2014/main" id="{24FC2E92-B55D-4575-8081-0DE5984606D7}"/>
+                <a16:creationId xmlns:a16="http://schemas.microsoft.com/office/drawing/2014/main" id="{9EA62E22-7306-4B4E-8673-41B60288A618}"/>
               </a:ext>
             </a:extLst>
           </p:cNvPr>
@@ -19554,7 +19554,7 @@
           <p:cNvPr id="84" name="Google Shape;84;p4">
             <a:extLst xmlns:a="http://schemas.openxmlformats.org/drawingml/2006/main">
               <a:ext uri="{FF2B5EF4-FFF2-40B4-BE49-F238E27FC236}">
-                <a16:creationId xmlns:a16="http://schemas.microsoft.com/office/drawing/2014/main" id="{AE48D223-16FC-40B5-9B06-E21C6A8C1163}"/>
+                <a16:creationId xmlns:a16="http://schemas.microsoft.com/office/drawing/2014/main" id="{778D86B1-29C9-4460-9907-D57AC1B22D5C}"/>
               </a:ext>
             </a:extLst>
           </p:cNvPr>
@@ -19735,7 +19735,7 @@
           <p:cNvPr id="85" name="Google Shape;85;p4">
             <a:extLst xmlns:a="http://schemas.openxmlformats.org/drawingml/2006/main">
               <a:ext uri="{FF2B5EF4-FFF2-40B4-BE49-F238E27FC236}">
-                <a16:creationId xmlns:a16="http://schemas.microsoft.com/office/drawing/2014/main" id="{4B36F220-5BA2-4051-A079-167060027A50}"/>
+                <a16:creationId xmlns:a16="http://schemas.microsoft.com/office/drawing/2014/main" id="{85AFA74D-0646-403C-B8EE-1F25E6F0E61F}"/>
               </a:ext>
             </a:extLst>
           </p:cNvPr>
@@ -19788,7 +19788,7 @@
           <p:cNvPr id="86" name="Google Shape;86;p4">
             <a:extLst xmlns:a="http://schemas.openxmlformats.org/drawingml/2006/main">
               <a:ext uri="{FF2B5EF4-FFF2-40B4-BE49-F238E27FC236}">
-                <a16:creationId xmlns:a16="http://schemas.microsoft.com/office/drawing/2014/main" id="{1CDC6330-A1BB-4906-A141-407A2E286B22}"/>
+                <a16:creationId xmlns:a16="http://schemas.microsoft.com/office/drawing/2014/main" id="{E1F7808D-0738-402B-8546-563C007A57F7}"/>
               </a:ext>
             </a:extLst>
           </p:cNvPr>
@@ -19969,7 +19969,7 @@
           <p:cNvPr id="87" name="Google Shape;87;p4">
             <a:extLst xmlns:a="http://schemas.openxmlformats.org/drawingml/2006/main">
               <a:ext uri="{FF2B5EF4-FFF2-40B4-BE49-F238E27FC236}">
-                <a16:creationId xmlns:a16="http://schemas.microsoft.com/office/drawing/2014/main" id="{831024F0-A0AE-436E-95DB-6B6F59657330}"/>
+                <a16:creationId xmlns:a16="http://schemas.microsoft.com/office/drawing/2014/main" id="{2B1B1DA1-ECED-4923-9F9B-86810FEA1986}"/>
               </a:ext>
             </a:extLst>
           </p:cNvPr>
@@ -20150,7 +20150,7 @@
           <p:cNvPr id="88" name="Google Shape;88;p4">
             <a:extLst xmlns:a="http://schemas.openxmlformats.org/drawingml/2006/main">
               <a:ext uri="{FF2B5EF4-FFF2-40B4-BE49-F238E27FC236}">
-                <a16:creationId xmlns:a16="http://schemas.microsoft.com/office/drawing/2014/main" id="{D66B93E5-F66C-429B-B3F9-1625C740DC6D}"/>
+                <a16:creationId xmlns:a16="http://schemas.microsoft.com/office/drawing/2014/main" id="{BFDB4D8D-4A45-4E39-821A-7E7884662996}"/>
               </a:ext>
             </a:extLst>
           </p:cNvPr>
@@ -20203,7 +20203,7 @@
           <p:cNvPr id="89" name="Google Shape;89;p4">
             <a:extLst xmlns:a="http://schemas.openxmlformats.org/drawingml/2006/main">
               <a:ext uri="{FF2B5EF4-FFF2-40B4-BE49-F238E27FC236}">
-                <a16:creationId xmlns:a16="http://schemas.microsoft.com/office/drawing/2014/main" id="{828A0312-DE2A-47C3-8B97-AF188EF4BEAE}"/>
+                <a16:creationId xmlns:a16="http://schemas.microsoft.com/office/drawing/2014/main" id="{F7C228E2-7C8C-4D07-90DC-7E7CAD15F8D6}"/>
               </a:ext>
             </a:extLst>
           </p:cNvPr>
@@ -20384,7 +20384,7 @@
           <p:cNvPr id="90" name="Google Shape;90;p4">
             <a:extLst xmlns:a="http://schemas.openxmlformats.org/drawingml/2006/main">
               <a:ext uri="{FF2B5EF4-FFF2-40B4-BE49-F238E27FC236}">
-                <a16:creationId xmlns:a16="http://schemas.microsoft.com/office/drawing/2014/main" id="{C47023E1-D327-49AD-9508-925A22B0C593}"/>
+                <a16:creationId xmlns:a16="http://schemas.microsoft.com/office/drawing/2014/main" id="{82C92B83-2FF6-416D-BB53-B2CA12300E5A}"/>
               </a:ext>
             </a:extLst>
           </p:cNvPr>
@@ -20565,7 +20565,7 @@
           <p:cNvPr id="91" name="Google Shape;91;p4">
             <a:extLst xmlns:a="http://schemas.openxmlformats.org/drawingml/2006/main">
               <a:ext uri="{FF2B5EF4-FFF2-40B4-BE49-F238E27FC236}">
-                <a16:creationId xmlns:a16="http://schemas.microsoft.com/office/drawing/2014/main" id="{8868E669-8DC0-48DC-BDD6-F6BBD1DF19CE}"/>
+                <a16:creationId xmlns:a16="http://schemas.microsoft.com/office/drawing/2014/main" id="{6B1ECBDC-FE43-49F8-A788-AAB136392B18}"/>
               </a:ext>
             </a:extLst>
           </p:cNvPr>
@@ -20624,7 +20624,7 @@
           <p:cNvPr id="92" name="Google Shape;92;p4">
             <a:extLst xmlns:a="http://schemas.openxmlformats.org/drawingml/2006/main">
               <a:ext uri="{FF2B5EF4-FFF2-40B4-BE49-F238E27FC236}">
-                <a16:creationId xmlns:a16="http://schemas.microsoft.com/office/drawing/2014/main" id="{242CC585-C83A-4008-87C4-0FAAA09E83B4}"/>
+                <a16:creationId xmlns:a16="http://schemas.microsoft.com/office/drawing/2014/main" id="{2487DCBB-F9C4-4E26-8794-5A366CD014A1}"/>
               </a:ext>
             </a:extLst>
           </p:cNvPr>
@@ -20805,7 +20805,7 @@
           <p:cNvPr id="93" name="Google Shape;93;p4">
             <a:extLst xmlns:a="http://schemas.openxmlformats.org/drawingml/2006/main">
               <a:ext uri="{FF2B5EF4-FFF2-40B4-BE49-F238E27FC236}">
-                <a16:creationId xmlns:a16="http://schemas.microsoft.com/office/drawing/2014/main" id="{E430D477-E88B-40DD-AEE9-09AF100255BA}"/>
+                <a16:creationId xmlns:a16="http://schemas.microsoft.com/office/drawing/2014/main" id="{A48714B9-6860-4C18-B1B7-55F64FF93C57}"/>
               </a:ext>
             </a:extLst>
           </p:cNvPr>
@@ -20986,7 +20986,7 @@
           <p:cNvPr id="94" name="Google Shape;94;p4">
             <a:extLst xmlns:a="http://schemas.openxmlformats.org/drawingml/2006/main">
               <a:ext uri="{FF2B5EF4-FFF2-40B4-BE49-F238E27FC236}">
-                <a16:creationId xmlns:a16="http://schemas.microsoft.com/office/drawing/2014/main" id="{0D245A09-90D9-46FD-8BB9-56B5E48D4B80}"/>
+                <a16:creationId xmlns:a16="http://schemas.microsoft.com/office/drawing/2014/main" id="{7E9A070E-ABB7-49E3-A153-81E3A1E2A64F}"/>
               </a:ext>
             </a:extLst>
           </p:cNvPr>
@@ -21045,7 +21045,7 @@
           <p:cNvPr id="95" name="Google Shape;95;p4">
             <a:extLst xmlns:a="http://schemas.openxmlformats.org/drawingml/2006/main">
               <a:ext uri="{FF2B5EF4-FFF2-40B4-BE49-F238E27FC236}">
-                <a16:creationId xmlns:a16="http://schemas.microsoft.com/office/drawing/2014/main" id="{8A1B1D36-119F-4563-8D1A-838B27251A26}"/>
+                <a16:creationId xmlns:a16="http://schemas.microsoft.com/office/drawing/2014/main" id="{C597C9AE-AB77-4844-B825-03E4089CD7BE}"/>
               </a:ext>
             </a:extLst>
           </p:cNvPr>
@@ -21208,7 +21208,7 @@
                 <a:ea typeface="IBM Plex Sans KR"/>
                 <a:cs typeface="IBM Plex Sans KR"/>
               </a:rPr>
-              <a:t>10/26 · 발표 예정</a:t>
+              <a:t>10/26 · 최종 통합</a:t>
             </a:r>
             <a:endParaRPr sz="1200" b="0" i="0" u="none" strike="noStrike" cap="none">
               <a:solidFill>
@@ -21226,7 +21226,7 @@
           <p:cNvPr id="96" name="Google Shape;96;p4">
             <a:extLst xmlns:a="http://schemas.openxmlformats.org/drawingml/2006/main">
               <a:ext uri="{FF2B5EF4-FFF2-40B4-BE49-F238E27FC236}">
-                <a16:creationId xmlns:a16="http://schemas.microsoft.com/office/drawing/2014/main" id="{C07855F3-FD44-497A-87F6-8DC542F24E4D}"/>
+                <a16:creationId xmlns:a16="http://schemas.microsoft.com/office/drawing/2014/main" id="{08685747-3319-4DDA-A31C-C60EB26A692C}"/>
               </a:ext>
             </a:extLst>
           </p:cNvPr>
@@ -21389,7 +21389,7 @@
                 <a:ea typeface="IBM Plex Sans KR"/>
                 <a:cs typeface="IBM Plex Sans KR"/>
               </a:rPr>
-              <a:t>팀 검토·발표</a:t>
+              <a:t>팀원 시안·RAG 반영</a:t>
             </a:r>
             <a:endParaRPr sz="1200" b="0" i="0" u="none" strike="noStrike" cap="none">
               <a:solidFill>
@@ -21407,7 +21407,7 @@
           <p:cNvPr id="97" name="Google Shape;97;p4">
             <a:extLst xmlns:a="http://schemas.openxmlformats.org/drawingml/2006/main">
               <a:ext uri="{FF2B5EF4-FFF2-40B4-BE49-F238E27FC236}">
-                <a16:creationId xmlns:a16="http://schemas.microsoft.com/office/drawing/2014/main" id="{BC0D4282-7DBC-4CE3-8949-39C866919F3E}"/>
+                <a16:creationId xmlns:a16="http://schemas.microsoft.com/office/drawing/2014/main" id="{93E02ABB-F8FB-48A3-96F7-8942C463E497}"/>
               </a:ext>
             </a:extLst>
           </p:cNvPr>
@@ -21479,7 +21479,7 @@
           <p:cNvPr id="98" name="Google Shape;98;p4">
             <a:extLst xmlns:a="http://schemas.openxmlformats.org/drawingml/2006/main">
               <a:ext uri="{FF2B5EF4-FFF2-40B4-BE49-F238E27FC236}">
-                <a16:creationId xmlns:a16="http://schemas.microsoft.com/office/drawing/2014/main" id="{14D2AEEF-9D4B-4547-98FD-D913ABE73796}"/>
+                <a16:creationId xmlns:a16="http://schemas.microsoft.com/office/drawing/2014/main" id="{69846768-4E23-4A96-BE80-46619E848FC0}"/>
               </a:ext>
             </a:extLst>
           </p:cNvPr>
@@ -21551,7 +21551,7 @@
           <p:cNvPr id="99" name="schedule-fact">
             <a:extLst xmlns:a="http://schemas.openxmlformats.org/drawingml/2006/main">
               <a:ext uri="{FF2B5EF4-FFF2-40B4-BE49-F238E27FC236}">
-                <a16:creationId xmlns:a16="http://schemas.microsoft.com/office/drawing/2014/main" id="{46E5A10D-EC8C-4588-B049-BA844E183088}"/>
+                <a16:creationId xmlns:a16="http://schemas.microsoft.com/office/drawing/2014/main" id="{89F0505D-5884-4909-A57C-5297205B909B}"/>
               </a:ext>
             </a:extLst>
           </p:cNvPr>
@@ -21736,7 +21736,7 @@
     </p:spTree>
     <p:extLst>
       <p:ext uri="{BB962C8B-B14F-4D97-AF65-F5344CB8AC3E}">
-        <p14:creationId xmlns:p14="http://schemas.microsoft.com/office/powerpoint/2010/main" val="80232886"/>
+        <p14:creationId xmlns:p14="http://schemas.microsoft.com/office/powerpoint/2010/main" val="1576775138"/>
       </p:ext>
     </p:extLst>
   </p:cSld>
@@ -21767,7 +21767,7 @@
           <p:cNvPr id="104" name="Google Shape;104;p5">
             <a:extLst xmlns:a="http://schemas.openxmlformats.org/drawingml/2006/main">
               <a:ext uri="{FF2B5EF4-FFF2-40B4-BE49-F238E27FC236}">
-                <a16:creationId xmlns:a16="http://schemas.microsoft.com/office/drawing/2014/main" id="{6511466A-52BB-44C2-BA65-34B0AA40056E}"/>
+                <a16:creationId xmlns:a16="http://schemas.microsoft.com/office/drawing/2014/main" id="{FBE4A953-6648-4B9A-84BE-D3E98FB90305}"/>
               </a:ext>
             </a:extLst>
           </p:cNvPr>
@@ -21839,7 +21839,7 @@
           <p:cNvPr id="105" name="Google Shape;105;p5">
             <a:extLst xmlns:a="http://schemas.openxmlformats.org/drawingml/2006/main">
               <a:ext uri="{FF2B5EF4-FFF2-40B4-BE49-F238E27FC236}">
-                <a16:creationId xmlns:a16="http://schemas.microsoft.com/office/drawing/2014/main" id="{6604B5BE-B3BA-404C-88DD-CE1A1B66B9C8}"/>
+                <a16:creationId xmlns:a16="http://schemas.microsoft.com/office/drawing/2014/main" id="{BC1C5FB1-6A05-4EFE-90A0-C29213136840}"/>
               </a:ext>
             </a:extLst>
           </p:cNvPr>
@@ -21906,7 +21906,7 @@
           <p:cNvPr id="106" name="Google Shape;106;p5">
             <a:extLst xmlns:a="http://schemas.openxmlformats.org/drawingml/2006/main">
               <a:ext uri="{FF2B5EF4-FFF2-40B4-BE49-F238E27FC236}">
-                <a16:creationId xmlns:a16="http://schemas.microsoft.com/office/drawing/2014/main" id="{7B1AA4FB-5512-497F-9711-5785956FC416}"/>
+                <a16:creationId xmlns:a16="http://schemas.microsoft.com/office/drawing/2014/main" id="{6221ECB6-39A2-4614-83FD-4E941F239FF6}"/>
               </a:ext>
             </a:extLst>
           </p:cNvPr>
@@ -21959,7 +21959,7 @@
           <p:cNvPr id="107" name="Google Shape;107;p5">
             <a:extLst xmlns:a="http://schemas.openxmlformats.org/drawingml/2006/main">
               <a:ext uri="{FF2B5EF4-FFF2-40B4-BE49-F238E27FC236}">
-                <a16:creationId xmlns:a16="http://schemas.microsoft.com/office/drawing/2014/main" id="{D0AC9CFF-12E0-4F1B-994D-9E47DBD3048B}"/>
+                <a16:creationId xmlns:a16="http://schemas.microsoft.com/office/drawing/2014/main" id="{0DF818AB-1F92-4D83-BE9C-0C4086D4FBBF}"/>
               </a:ext>
             </a:extLst>
           </p:cNvPr>
@@ -22031,7 +22031,7 @@
           <p:cNvPr id="108" name="Google Shape;108;p5">
             <a:extLst xmlns:a="http://schemas.openxmlformats.org/drawingml/2006/main">
               <a:ext uri="{FF2B5EF4-FFF2-40B4-BE49-F238E27FC236}">
-                <a16:creationId xmlns:a16="http://schemas.microsoft.com/office/drawing/2014/main" id="{E1015EBD-10B5-417D-B218-B3CED198BF7E}"/>
+                <a16:creationId xmlns:a16="http://schemas.microsoft.com/office/drawing/2014/main" id="{770A7B0F-1429-4EE4-8D5C-5EEB95BC3D1F}"/>
               </a:ext>
             </a:extLst>
           </p:cNvPr>
@@ -22212,7 +22212,7 @@
           <p:cNvPr id="109" name="Google Shape;109;p5">
             <a:extLst xmlns:a="http://schemas.openxmlformats.org/drawingml/2006/main">
               <a:ext uri="{FF2B5EF4-FFF2-40B4-BE49-F238E27FC236}">
-                <a16:creationId xmlns:a16="http://schemas.microsoft.com/office/drawing/2014/main" id="{14ECB93D-BE5E-4B9C-9375-9C62F32331F9}"/>
+                <a16:creationId xmlns:a16="http://schemas.microsoft.com/office/drawing/2014/main" id="{F400FEE8-0F30-4075-8D6C-969D98E803C0}"/>
               </a:ext>
             </a:extLst>
           </p:cNvPr>
@@ -22265,7 +22265,7 @@
           <p:cNvPr id="110" name="Google Shape;110;p5">
             <a:extLst xmlns:a="http://schemas.openxmlformats.org/drawingml/2006/main">
               <a:ext uri="{FF2B5EF4-FFF2-40B4-BE49-F238E27FC236}">
-                <a16:creationId xmlns:a16="http://schemas.microsoft.com/office/drawing/2014/main" id="{A13EF12E-AFB5-4C77-B80C-C891A00EEEB9}"/>
+                <a16:creationId xmlns:a16="http://schemas.microsoft.com/office/drawing/2014/main" id="{ECE5E6BF-E52A-4BDE-BD9B-135411AA466B}"/>
               </a:ext>
             </a:extLst>
           </p:cNvPr>
@@ -22337,7 +22337,7 @@
           <p:cNvPr id="111" name="Google Shape;111;p5">
             <a:extLst xmlns:a="http://schemas.openxmlformats.org/drawingml/2006/main">
               <a:ext uri="{FF2B5EF4-FFF2-40B4-BE49-F238E27FC236}">
-                <a16:creationId xmlns:a16="http://schemas.microsoft.com/office/drawing/2014/main" id="{637B0A68-E6A2-4955-8CE8-6800975BFEC8}"/>
+                <a16:creationId xmlns:a16="http://schemas.microsoft.com/office/drawing/2014/main" id="{7195E2DF-D44B-4132-9397-E31C3BE40FE4}"/>
               </a:ext>
             </a:extLst>
           </p:cNvPr>
@@ -22518,7 +22518,7 @@
           <p:cNvPr id="112" name="Google Shape;112;p5">
             <a:extLst xmlns:a="http://schemas.openxmlformats.org/drawingml/2006/main">
               <a:ext uri="{FF2B5EF4-FFF2-40B4-BE49-F238E27FC236}">
-                <a16:creationId xmlns:a16="http://schemas.microsoft.com/office/drawing/2014/main" id="{4CC38D9D-1018-4998-A461-7E6577125B82}"/>
+                <a16:creationId xmlns:a16="http://schemas.microsoft.com/office/drawing/2014/main" id="{27AE8FC3-7913-460D-90F9-7C17F2CDCA89}"/>
               </a:ext>
             </a:extLst>
           </p:cNvPr>
@@ -22571,7 +22571,7 @@
           <p:cNvPr id="113" name="Google Shape;113;p5">
             <a:extLst xmlns:a="http://schemas.openxmlformats.org/drawingml/2006/main">
               <a:ext uri="{FF2B5EF4-FFF2-40B4-BE49-F238E27FC236}">
-                <a16:creationId xmlns:a16="http://schemas.microsoft.com/office/drawing/2014/main" id="{FDCE43B8-A64F-41E2-979B-0336C6DD6E84}"/>
+                <a16:creationId xmlns:a16="http://schemas.microsoft.com/office/drawing/2014/main" id="{D0898F07-13EF-45E5-9608-F39B29F57C82}"/>
               </a:ext>
             </a:extLst>
           </p:cNvPr>
@@ -22643,7 +22643,7 @@
           <p:cNvPr id="114" name="Google Shape;114;p5">
             <a:extLst xmlns:a="http://schemas.openxmlformats.org/drawingml/2006/main">
               <a:ext uri="{FF2B5EF4-FFF2-40B4-BE49-F238E27FC236}">
-                <a16:creationId xmlns:a16="http://schemas.microsoft.com/office/drawing/2014/main" id="{251B16E8-6AE6-4011-BD7A-649F0623465A}"/>
+                <a16:creationId xmlns:a16="http://schemas.microsoft.com/office/drawing/2014/main" id="{A8C622BE-85A4-4B8E-9264-61234FDF3AAD}"/>
               </a:ext>
             </a:extLst>
           </p:cNvPr>
@@ -22824,7 +22824,7 @@
           <p:cNvPr id="115" name="Google Shape;115;p5">
             <a:extLst xmlns:a="http://schemas.openxmlformats.org/drawingml/2006/main">
               <a:ext uri="{FF2B5EF4-FFF2-40B4-BE49-F238E27FC236}">
-                <a16:creationId xmlns:a16="http://schemas.microsoft.com/office/drawing/2014/main" id="{B2CFFD34-260B-470A-8794-75B14933D813}"/>
+                <a16:creationId xmlns:a16="http://schemas.microsoft.com/office/drawing/2014/main" id="{6697B434-C2BE-4F53-8C10-5107AAB835CB}"/>
               </a:ext>
             </a:extLst>
           </p:cNvPr>
@@ -22877,7 +22877,7 @@
           <p:cNvPr id="116" name="Google Shape;116;p5">
             <a:extLst xmlns:a="http://schemas.openxmlformats.org/drawingml/2006/main">
               <a:ext uri="{FF2B5EF4-FFF2-40B4-BE49-F238E27FC236}">
-                <a16:creationId xmlns:a16="http://schemas.microsoft.com/office/drawing/2014/main" id="{2236C38F-BABB-4E65-A513-F45064D31F3A}"/>
+                <a16:creationId xmlns:a16="http://schemas.microsoft.com/office/drawing/2014/main" id="{08A2D2CC-9991-4AB1-9428-FE53987B3253}"/>
               </a:ext>
             </a:extLst>
           </p:cNvPr>
@@ -22949,7 +22949,7 @@
           <p:cNvPr id="117" name="Google Shape;117;p5">
             <a:extLst xmlns:a="http://schemas.openxmlformats.org/drawingml/2006/main">
               <a:ext uri="{FF2B5EF4-FFF2-40B4-BE49-F238E27FC236}">
-                <a16:creationId xmlns:a16="http://schemas.microsoft.com/office/drawing/2014/main" id="{56961298-1F6E-4812-9BEC-1A0E4466BB44}"/>
+                <a16:creationId xmlns:a16="http://schemas.microsoft.com/office/drawing/2014/main" id="{FC326104-3314-4DD3-BC77-BEF7768D0EFD}"/>
               </a:ext>
             </a:extLst>
           </p:cNvPr>
@@ -23130,7 +23130,7 @@
           <p:cNvPr id="118" name="Google Shape;118;p5">
             <a:extLst xmlns:a="http://schemas.openxmlformats.org/drawingml/2006/main">
               <a:ext uri="{FF2B5EF4-FFF2-40B4-BE49-F238E27FC236}">
-                <a16:creationId xmlns:a16="http://schemas.microsoft.com/office/drawing/2014/main" id="{C40B6EC3-DE68-444A-AD8B-68562B26388E}"/>
+                <a16:creationId xmlns:a16="http://schemas.microsoft.com/office/drawing/2014/main" id="{473D952B-68BE-4673-8929-BCAE1B053778}"/>
               </a:ext>
             </a:extLst>
           </p:cNvPr>
@@ -23183,7 +23183,7 @@
           <p:cNvPr id="119" name="Google Shape;119;p5">
             <a:extLst xmlns:a="http://schemas.openxmlformats.org/drawingml/2006/main">
               <a:ext uri="{FF2B5EF4-FFF2-40B4-BE49-F238E27FC236}">
-                <a16:creationId xmlns:a16="http://schemas.microsoft.com/office/drawing/2014/main" id="{58A3D762-E580-40B9-9DB3-977528EABB94}"/>
+                <a16:creationId xmlns:a16="http://schemas.microsoft.com/office/drawing/2014/main" id="{FF06713A-C149-446D-B4F1-EBA320E057A6}"/>
               </a:ext>
             </a:extLst>
           </p:cNvPr>
@@ -23255,7 +23255,7 @@
           <p:cNvPr id="120" name="Google Shape;120;p5">
             <a:extLst xmlns:a="http://schemas.openxmlformats.org/drawingml/2006/main">
               <a:ext uri="{FF2B5EF4-FFF2-40B4-BE49-F238E27FC236}">
-                <a16:creationId xmlns:a16="http://schemas.microsoft.com/office/drawing/2014/main" id="{7616AF97-AC50-4BF6-94D7-92375FB7F54D}"/>
+                <a16:creationId xmlns:a16="http://schemas.microsoft.com/office/drawing/2014/main" id="{CD07F0E5-3CF5-4725-93BB-51F1757604FA}"/>
               </a:ext>
             </a:extLst>
           </p:cNvPr>
@@ -23436,7 +23436,7 @@
           <p:cNvPr id="121" name="Google Shape;121;p5">
             <a:extLst xmlns:a="http://schemas.openxmlformats.org/drawingml/2006/main">
               <a:ext uri="{FF2B5EF4-FFF2-40B4-BE49-F238E27FC236}">
-                <a16:creationId xmlns:a16="http://schemas.microsoft.com/office/drawing/2014/main" id="{94E00BB5-F320-49A4-A0F8-1842557A4969}"/>
+                <a16:creationId xmlns:a16="http://schemas.microsoft.com/office/drawing/2014/main" id="{005BE38A-22A8-4B65-BC5D-2868C75CEDE7}"/>
               </a:ext>
             </a:extLst>
           </p:cNvPr>
@@ -23508,7 +23508,7 @@
           <p:cNvPr id="122" name="Google Shape;122;p5">
             <a:extLst xmlns:a="http://schemas.openxmlformats.org/drawingml/2006/main">
               <a:ext uri="{FF2B5EF4-FFF2-40B4-BE49-F238E27FC236}">
-                <a16:creationId xmlns:a16="http://schemas.microsoft.com/office/drawing/2014/main" id="{801BE55D-08CB-4A3C-B31B-E8B393A27FA5}"/>
+                <a16:creationId xmlns:a16="http://schemas.microsoft.com/office/drawing/2014/main" id="{625AB750-3977-473F-9EF6-24E8095ED9BF}"/>
               </a:ext>
             </a:extLst>
           </p:cNvPr>
@@ -23580,7 +23580,7 @@
           <p:cNvPr id="123" name="scenario-results">
             <a:extLst xmlns:a="http://schemas.openxmlformats.org/drawingml/2006/main">
               <a:ext uri="{FF2B5EF4-FFF2-40B4-BE49-F238E27FC236}">
-                <a16:creationId xmlns:a16="http://schemas.microsoft.com/office/drawing/2014/main" id="{428B159C-E716-4CC5-A452-45762379CB07}"/>
+                <a16:creationId xmlns:a16="http://schemas.microsoft.com/office/drawing/2014/main" id="{8FEDF12B-3B34-4A18-A7E9-8BE2527574C2}"/>
               </a:ext>
             </a:extLst>
           </p:cNvPr>
@@ -23819,7 +23819,7 @@
     </p:spTree>
     <p:extLst>
       <p:ext uri="{BB962C8B-B14F-4D97-AF65-F5344CB8AC3E}">
-        <p14:creationId xmlns:p14="http://schemas.microsoft.com/office/powerpoint/2010/main" val="1648199984"/>
+        <p14:creationId xmlns:p14="http://schemas.microsoft.com/office/powerpoint/2010/main" val="330821109"/>
       </p:ext>
     </p:extLst>
   </p:cSld>
@@ -23850,7 +23850,7 @@
           <p:cNvPr id="128" name="Google Shape;128;p6">
             <a:extLst xmlns:a="http://schemas.openxmlformats.org/drawingml/2006/main">
               <a:ext uri="{FF2B5EF4-FFF2-40B4-BE49-F238E27FC236}">
-                <a16:creationId xmlns:a16="http://schemas.microsoft.com/office/drawing/2014/main" id="{ECD7A34D-13D8-4ABC-A8D9-9761B0B7E68D}"/>
+                <a16:creationId xmlns:a16="http://schemas.microsoft.com/office/drawing/2014/main" id="{DC607B1A-B795-4BB7-88F8-A830849DB6A8}"/>
               </a:ext>
             </a:extLst>
           </p:cNvPr>
@@ -23922,7 +23922,7 @@
           <p:cNvPr id="129" name="Google Shape;129;p6">
             <a:extLst xmlns:a="http://schemas.openxmlformats.org/drawingml/2006/main">
               <a:ext uri="{FF2B5EF4-FFF2-40B4-BE49-F238E27FC236}">
-                <a16:creationId xmlns:a16="http://schemas.microsoft.com/office/drawing/2014/main" id="{84ADAEA6-C9C7-4B9C-9D76-B790D8F5A0EC}"/>
+                <a16:creationId xmlns:a16="http://schemas.microsoft.com/office/drawing/2014/main" id="{09BD687A-D94B-4A91-88E9-9C3EE2622FE4}"/>
               </a:ext>
             </a:extLst>
           </p:cNvPr>
@@ -23989,7 +23989,7 @@
           <p:cNvPr id="130" name="Google Shape;130;p6">
             <a:extLst xmlns:a="http://schemas.openxmlformats.org/drawingml/2006/main">
               <a:ext uri="{FF2B5EF4-FFF2-40B4-BE49-F238E27FC236}">
-                <a16:creationId xmlns:a16="http://schemas.microsoft.com/office/drawing/2014/main" id="{4E337006-1804-41FF-8B57-C13BC840A5E5}"/>
+                <a16:creationId xmlns:a16="http://schemas.microsoft.com/office/drawing/2014/main" id="{EE39364E-7DD4-4B7C-AC8B-0251D376D84A}"/>
               </a:ext>
             </a:extLst>
           </p:cNvPr>
@@ -24048,7 +24048,7 @@
           <p:cNvPr id="131" name="Google Shape;131;p6">
             <a:extLst xmlns:a="http://schemas.openxmlformats.org/drawingml/2006/main">
               <a:ext uri="{FF2B5EF4-FFF2-40B4-BE49-F238E27FC236}">
-                <a16:creationId xmlns:a16="http://schemas.microsoft.com/office/drawing/2014/main" id="{78B9116F-4704-4778-AF9B-925775899D2F}"/>
+                <a16:creationId xmlns:a16="http://schemas.microsoft.com/office/drawing/2014/main" id="{7CEA567C-1A36-4CD7-8CAE-61B505414680}"/>
               </a:ext>
             </a:extLst>
           </p:cNvPr>
@@ -24120,7 +24120,7 @@
           <p:cNvPr id="132" name="Google Shape;132;p6">
             <a:extLst xmlns:a="http://schemas.openxmlformats.org/drawingml/2006/main">
               <a:ext uri="{FF2B5EF4-FFF2-40B4-BE49-F238E27FC236}">
-                <a16:creationId xmlns:a16="http://schemas.microsoft.com/office/drawing/2014/main" id="{D1DC097F-4E01-4A37-A736-E7FAD5E63008}"/>
+                <a16:creationId xmlns:a16="http://schemas.microsoft.com/office/drawing/2014/main" id="{F9EFC6A0-7D59-4D0F-9A12-BA8B68F534ED}"/>
               </a:ext>
             </a:extLst>
           </p:cNvPr>
@@ -24301,7 +24301,7 @@
           <p:cNvPr id="133" name="Google Shape;133;p6">
             <a:extLst xmlns:a="http://schemas.openxmlformats.org/drawingml/2006/main">
               <a:ext uri="{FF2B5EF4-FFF2-40B4-BE49-F238E27FC236}">
-                <a16:creationId xmlns:a16="http://schemas.microsoft.com/office/drawing/2014/main" id="{08935524-78F6-4DC1-8D09-EE53F5357D94}"/>
+                <a16:creationId xmlns:a16="http://schemas.microsoft.com/office/drawing/2014/main" id="{2FCA8979-F7D3-4BDE-88A5-5945CD7E220D}"/>
               </a:ext>
             </a:extLst>
           </p:cNvPr>
@@ -24311,7 +24311,7 @@
           <p:nvPr/>
         </p:nvPicPr>
         <p:blipFill rotWithShape="1">
-          <a:blip xmlns:r="http://schemas.openxmlformats.org/officeDocument/2006/relationships" xmlns:a="http://schemas.openxmlformats.org/drawingml/2006/main" r:embed="Rd10a8cd17b4f4c30">
+          <a:blip xmlns:r="http://schemas.openxmlformats.org/officeDocument/2006/relationships" xmlns:a="http://schemas.openxmlformats.org/drawingml/2006/main" r:embed="R4f1c9c4dddb74589">
             <a:alphaModFix/>
           </a:blip>
           <a:srcRect xmlns:a="http://schemas.openxmlformats.org/drawingml/2006/main" l="-8" t="0" r="-8" b="0"/>
@@ -24335,7 +24335,7 @@
           <p:cNvPr id="134" name="Google Shape;134;p6">
             <a:extLst xmlns:a="http://schemas.openxmlformats.org/drawingml/2006/main">
               <a:ext uri="{FF2B5EF4-FFF2-40B4-BE49-F238E27FC236}">
-                <a16:creationId xmlns:a16="http://schemas.microsoft.com/office/drawing/2014/main" id="{5DB1E3E4-50FB-4A47-A089-B2CC68D4F530}"/>
+                <a16:creationId xmlns:a16="http://schemas.microsoft.com/office/drawing/2014/main" id="{EC35FC6E-D117-4A38-B9CE-DC0C9DEF5F4F}"/>
               </a:ext>
             </a:extLst>
           </p:cNvPr>
@@ -24345,7 +24345,7 @@
           <p:nvPr/>
         </p:nvPicPr>
         <p:blipFill rotWithShape="1">
-          <a:blip xmlns:r="http://schemas.openxmlformats.org/officeDocument/2006/relationships" xmlns:a="http://schemas.openxmlformats.org/drawingml/2006/main" r:embed="R1569ba174c9249c1">
+          <a:blip xmlns:r="http://schemas.openxmlformats.org/officeDocument/2006/relationships" xmlns:a="http://schemas.openxmlformats.org/drawingml/2006/main" r:embed="R9205eee7e1454b96">
             <a:alphaModFix/>
           </a:blip>
           <a:srcRect xmlns:a="http://schemas.openxmlformats.org/drawingml/2006/main" l="-8" t="0" r="-8" b="0"/>
@@ -24369,7 +24369,7 @@
           <p:cNvPr id="135" name="Google Shape;135;p6">
             <a:extLst xmlns:a="http://schemas.openxmlformats.org/drawingml/2006/main">
               <a:ext uri="{FF2B5EF4-FFF2-40B4-BE49-F238E27FC236}">
-                <a16:creationId xmlns:a16="http://schemas.microsoft.com/office/drawing/2014/main" id="{FCC69233-519D-4566-AE29-0F288DC7AD38}"/>
+                <a16:creationId xmlns:a16="http://schemas.microsoft.com/office/drawing/2014/main" id="{8CAA6D02-69A2-4017-8FED-442F1EB14A06}"/>
               </a:ext>
             </a:extLst>
           </p:cNvPr>
@@ -24428,7 +24428,7 @@
           <p:cNvPr id="136" name="Google Shape;136;p6">
             <a:extLst xmlns:a="http://schemas.openxmlformats.org/drawingml/2006/main">
               <a:ext uri="{FF2B5EF4-FFF2-40B4-BE49-F238E27FC236}">
-                <a16:creationId xmlns:a16="http://schemas.microsoft.com/office/drawing/2014/main" id="{FBBFAA9E-09BC-456F-A595-2A7FDC645AE9}"/>
+                <a16:creationId xmlns:a16="http://schemas.microsoft.com/office/drawing/2014/main" id="{8C9B8C0F-38EA-4699-AC67-563E975BAF52}"/>
               </a:ext>
             </a:extLst>
           </p:cNvPr>
@@ -24500,7 +24500,7 @@
           <p:cNvPr id="137" name="Google Shape;137;p6">
             <a:extLst xmlns:a="http://schemas.openxmlformats.org/drawingml/2006/main">
               <a:ext uri="{FF2B5EF4-FFF2-40B4-BE49-F238E27FC236}">
-                <a16:creationId xmlns:a16="http://schemas.microsoft.com/office/drawing/2014/main" id="{28CF9714-88F6-4CF2-B86E-AB6854D51541}"/>
+                <a16:creationId xmlns:a16="http://schemas.microsoft.com/office/drawing/2014/main" id="{8DCB0BAC-631F-409F-A3E4-5C68C5C30091}"/>
               </a:ext>
             </a:extLst>
           </p:cNvPr>
@@ -24681,7 +24681,7 @@
           <p:cNvPr id="138" name="Google Shape;138;p6">
             <a:extLst xmlns:a="http://schemas.openxmlformats.org/drawingml/2006/main">
               <a:ext uri="{FF2B5EF4-FFF2-40B4-BE49-F238E27FC236}">
-                <a16:creationId xmlns:a16="http://schemas.microsoft.com/office/drawing/2014/main" id="{BA1C0FE1-A9B9-4ADB-ABF5-F3120511B9F9}"/>
+                <a16:creationId xmlns:a16="http://schemas.microsoft.com/office/drawing/2014/main" id="{E53826F1-70FB-4143-8126-95004A0861C3}"/>
               </a:ext>
             </a:extLst>
           </p:cNvPr>
@@ -24862,7 +24862,7 @@
           <p:cNvPr id="139" name="Google Shape;139;p6">
             <a:extLst xmlns:a="http://schemas.openxmlformats.org/drawingml/2006/main">
               <a:ext uri="{FF2B5EF4-FFF2-40B4-BE49-F238E27FC236}">
-                <a16:creationId xmlns:a16="http://schemas.microsoft.com/office/drawing/2014/main" id="{4A68CD37-EB1A-48C1-95FC-830A7B91989E}"/>
+                <a16:creationId xmlns:a16="http://schemas.microsoft.com/office/drawing/2014/main" id="{5A9A467F-8A84-4B7A-9171-21406074EAC1}"/>
               </a:ext>
             </a:extLst>
           </p:cNvPr>
@@ -25043,7 +25043,7 @@
           <p:cNvPr id="140" name="Google Shape;140;p6">
             <a:extLst xmlns:a="http://schemas.openxmlformats.org/drawingml/2006/main">
               <a:ext uri="{FF2B5EF4-FFF2-40B4-BE49-F238E27FC236}">
-                <a16:creationId xmlns:a16="http://schemas.microsoft.com/office/drawing/2014/main" id="{A490CA4D-46D5-4381-8640-5768F1AB2D71}"/>
+                <a16:creationId xmlns:a16="http://schemas.microsoft.com/office/drawing/2014/main" id="{319F9002-3B4B-4D1C-94A1-3A5379D858F1}"/>
               </a:ext>
             </a:extLst>
           </p:cNvPr>
@@ -25053,7 +25053,7 @@
           <p:nvPr/>
         </p:nvPicPr>
         <p:blipFill rotWithShape="1">
-          <a:blip xmlns:r="http://schemas.openxmlformats.org/officeDocument/2006/relationships" xmlns:a="http://schemas.openxmlformats.org/drawingml/2006/main" r:embed="Rd10a8cd17b4f4c30">
+          <a:blip xmlns:r="http://schemas.openxmlformats.org/officeDocument/2006/relationships" xmlns:a="http://schemas.openxmlformats.org/drawingml/2006/main" r:embed="R4f1c9c4dddb74589">
             <a:alphaModFix/>
           </a:blip>
           <a:srcRect xmlns:a="http://schemas.openxmlformats.org/drawingml/2006/main" l="-8" t="0" r="-8" b="0"/>
@@ -25077,7 +25077,7 @@
           <p:cNvPr id="141" name="Google Shape;141;p6">
             <a:extLst xmlns:a="http://schemas.openxmlformats.org/drawingml/2006/main">
               <a:ext uri="{FF2B5EF4-FFF2-40B4-BE49-F238E27FC236}">
-                <a16:creationId xmlns:a16="http://schemas.microsoft.com/office/drawing/2014/main" id="{07E6DCC2-F2EA-4B1B-BEB9-C6F9DA035D2A}"/>
+                <a16:creationId xmlns:a16="http://schemas.microsoft.com/office/drawing/2014/main" id="{3D7E3485-2A13-43CD-AD52-C29C1E4D2D5D}"/>
               </a:ext>
             </a:extLst>
           </p:cNvPr>
@@ -25087,7 +25087,7 @@
           <p:nvPr/>
         </p:nvPicPr>
         <p:blipFill rotWithShape="1">
-          <a:blip xmlns:r="http://schemas.openxmlformats.org/officeDocument/2006/relationships" xmlns:a="http://schemas.openxmlformats.org/drawingml/2006/main" r:embed="R1569ba174c9249c1">
+          <a:blip xmlns:r="http://schemas.openxmlformats.org/officeDocument/2006/relationships" xmlns:a="http://schemas.openxmlformats.org/drawingml/2006/main" r:embed="R9205eee7e1454b96">
             <a:alphaModFix/>
           </a:blip>
           <a:srcRect xmlns:a="http://schemas.openxmlformats.org/drawingml/2006/main" l="-8" t="0" r="-8" b="0"/>
@@ -25111,7 +25111,7 @@
           <p:cNvPr id="142" name="Google Shape;142;p6">
             <a:extLst xmlns:a="http://schemas.openxmlformats.org/drawingml/2006/main">
               <a:ext uri="{FF2B5EF4-FFF2-40B4-BE49-F238E27FC236}">
-                <a16:creationId xmlns:a16="http://schemas.microsoft.com/office/drawing/2014/main" id="{1EC7531F-D170-4442-B9B5-820040A4456B}"/>
+                <a16:creationId xmlns:a16="http://schemas.microsoft.com/office/drawing/2014/main" id="{3201403D-50DD-4E21-88F1-B778809FF6E5}"/>
               </a:ext>
             </a:extLst>
           </p:cNvPr>
@@ -25170,7 +25170,7 @@
           <p:cNvPr id="143" name="Google Shape;143;p6">
             <a:extLst xmlns:a="http://schemas.openxmlformats.org/drawingml/2006/main">
               <a:ext uri="{FF2B5EF4-FFF2-40B4-BE49-F238E27FC236}">
-                <a16:creationId xmlns:a16="http://schemas.microsoft.com/office/drawing/2014/main" id="{7736F1F8-382A-4704-9938-7D2AEEDD76EA}"/>
+                <a16:creationId xmlns:a16="http://schemas.microsoft.com/office/drawing/2014/main" id="{13C03EFF-A20F-4C6E-BF78-6D2563233B27}"/>
               </a:ext>
             </a:extLst>
           </p:cNvPr>
@@ -25242,7 +25242,7 @@
           <p:cNvPr id="144" name="Google Shape;144;p6">
             <a:extLst xmlns:a="http://schemas.openxmlformats.org/drawingml/2006/main">
               <a:ext uri="{FF2B5EF4-FFF2-40B4-BE49-F238E27FC236}">
-                <a16:creationId xmlns:a16="http://schemas.microsoft.com/office/drawing/2014/main" id="{D3920170-EA2B-4BA8-A90A-7CE22FC369C2}"/>
+                <a16:creationId xmlns:a16="http://schemas.microsoft.com/office/drawing/2014/main" id="{20D7FC3D-510B-4DA6-BDD9-E879588EE7FA}"/>
               </a:ext>
             </a:extLst>
           </p:cNvPr>
@@ -25423,7 +25423,7 @@
           <p:cNvPr id="145" name="Google Shape;145;p6">
             <a:extLst xmlns:a="http://schemas.openxmlformats.org/drawingml/2006/main">
               <a:ext uri="{FF2B5EF4-FFF2-40B4-BE49-F238E27FC236}">
-                <a16:creationId xmlns:a16="http://schemas.microsoft.com/office/drawing/2014/main" id="{51632176-A7A8-4260-B669-7CFEAE20BC72}"/>
+                <a16:creationId xmlns:a16="http://schemas.microsoft.com/office/drawing/2014/main" id="{E5B53302-A35D-4E70-B9A6-6880BB82C608}"/>
               </a:ext>
             </a:extLst>
           </p:cNvPr>
@@ -25482,7 +25482,7 @@
           <p:cNvPr id="146" name="Google Shape;146;p6">
             <a:extLst xmlns:a="http://schemas.openxmlformats.org/drawingml/2006/main">
               <a:ext uri="{FF2B5EF4-FFF2-40B4-BE49-F238E27FC236}">
-                <a16:creationId xmlns:a16="http://schemas.microsoft.com/office/drawing/2014/main" id="{11E502C9-F2A8-4CE1-9F56-4275827EBE6E}"/>
+                <a16:creationId xmlns:a16="http://schemas.microsoft.com/office/drawing/2014/main" id="{9E6BEE7A-981A-4A89-882A-A33B60893A72}"/>
               </a:ext>
             </a:extLst>
           </p:cNvPr>
@@ -25554,7 +25554,7 @@
           <p:cNvPr id="147" name="Google Shape;147;p6">
             <a:extLst xmlns:a="http://schemas.openxmlformats.org/drawingml/2006/main">
               <a:ext uri="{FF2B5EF4-FFF2-40B4-BE49-F238E27FC236}">
-                <a16:creationId xmlns:a16="http://schemas.microsoft.com/office/drawing/2014/main" id="{651B561A-8E1B-4F0E-8051-FB4BE5819658}"/>
+                <a16:creationId xmlns:a16="http://schemas.microsoft.com/office/drawing/2014/main" id="{1D38EE03-0224-4132-8DCE-B0174045E363}"/>
               </a:ext>
             </a:extLst>
           </p:cNvPr>
@@ -25735,7 +25735,7 @@
           <p:cNvPr id="148" name="Google Shape;148;p6">
             <a:extLst xmlns:a="http://schemas.openxmlformats.org/drawingml/2006/main">
               <a:ext uri="{FF2B5EF4-FFF2-40B4-BE49-F238E27FC236}">
-                <a16:creationId xmlns:a16="http://schemas.microsoft.com/office/drawing/2014/main" id="{2232739E-2ABF-42CF-843C-C4B53D41879C}"/>
+                <a16:creationId xmlns:a16="http://schemas.microsoft.com/office/drawing/2014/main" id="{DA4B6472-439C-4ADA-9772-BC4EF02737D4}"/>
               </a:ext>
             </a:extLst>
           </p:cNvPr>
@@ -25794,7 +25794,7 @@
           <p:cNvPr id="149" name="Google Shape;149;p6">
             <a:extLst xmlns:a="http://schemas.openxmlformats.org/drawingml/2006/main">
               <a:ext uri="{FF2B5EF4-FFF2-40B4-BE49-F238E27FC236}">
-                <a16:creationId xmlns:a16="http://schemas.microsoft.com/office/drawing/2014/main" id="{F32CB61F-71B1-4884-9981-882633C13238}"/>
+                <a16:creationId xmlns:a16="http://schemas.microsoft.com/office/drawing/2014/main" id="{A5310B5C-797F-4748-94D2-B685C82AEC48}"/>
               </a:ext>
             </a:extLst>
           </p:cNvPr>
@@ -25866,7 +25866,7 @@
           <p:cNvPr id="150" name="Google Shape;150;p6">
             <a:extLst xmlns:a="http://schemas.openxmlformats.org/drawingml/2006/main">
               <a:ext uri="{FF2B5EF4-FFF2-40B4-BE49-F238E27FC236}">
-                <a16:creationId xmlns:a16="http://schemas.microsoft.com/office/drawing/2014/main" id="{B5D032BA-D9EC-4214-A397-030266DA3A1B}"/>
+                <a16:creationId xmlns:a16="http://schemas.microsoft.com/office/drawing/2014/main" id="{F9BE1C09-5D38-4314-8CC0-CDF431BF0DF7}"/>
               </a:ext>
             </a:extLst>
           </p:cNvPr>
@@ -26047,7 +26047,7 @@
           <p:cNvPr id="151" name="Google Shape;151;p6">
             <a:extLst xmlns:a="http://schemas.openxmlformats.org/drawingml/2006/main">
               <a:ext uri="{FF2B5EF4-FFF2-40B4-BE49-F238E27FC236}">
-                <a16:creationId xmlns:a16="http://schemas.microsoft.com/office/drawing/2014/main" id="{2005F8F7-B07D-49D0-8D8D-4D951BF9861E}"/>
+                <a16:creationId xmlns:a16="http://schemas.microsoft.com/office/drawing/2014/main" id="{D7B7533E-0CCA-4532-80AA-A2E042588008}"/>
               </a:ext>
             </a:extLst>
           </p:cNvPr>
@@ -26100,7 +26100,7 @@
           <p:cNvPr id="152" name="Google Shape;152;p6">
             <a:extLst xmlns:a="http://schemas.openxmlformats.org/drawingml/2006/main">
               <a:ext uri="{FF2B5EF4-FFF2-40B4-BE49-F238E27FC236}">
-                <a16:creationId xmlns:a16="http://schemas.microsoft.com/office/drawing/2014/main" id="{1DC6F493-8605-4D6A-A566-FE152B1120E6}"/>
+                <a16:creationId xmlns:a16="http://schemas.microsoft.com/office/drawing/2014/main" id="{C707B4D7-55B6-4402-8F2D-9D5AE5D2A669}"/>
               </a:ext>
             </a:extLst>
           </p:cNvPr>
@@ -26172,7 +26172,7 @@
           <p:cNvPr id="153" name="Google Shape;153;p6">
             <a:extLst xmlns:a="http://schemas.openxmlformats.org/drawingml/2006/main">
               <a:ext uri="{FF2B5EF4-FFF2-40B4-BE49-F238E27FC236}">
-                <a16:creationId xmlns:a16="http://schemas.microsoft.com/office/drawing/2014/main" id="{34E7E4C3-FE7C-4BBB-AFF3-E1BA3FF64D5C}"/>
+                <a16:creationId xmlns:a16="http://schemas.microsoft.com/office/drawing/2014/main" id="{FA078599-54DC-45BC-96FD-03ECDC87ACAD}"/>
               </a:ext>
             </a:extLst>
           </p:cNvPr>
@@ -26353,7 +26353,7 @@
           <p:cNvPr id="154" name="Google Shape;154;p6">
             <a:extLst xmlns:a="http://schemas.openxmlformats.org/drawingml/2006/main">
               <a:ext uri="{FF2B5EF4-FFF2-40B4-BE49-F238E27FC236}">
-                <a16:creationId xmlns:a16="http://schemas.microsoft.com/office/drawing/2014/main" id="{0FB2170D-55AC-46D5-BC3D-88C5A0C0E0C8}"/>
+                <a16:creationId xmlns:a16="http://schemas.microsoft.com/office/drawing/2014/main" id="{2C246694-F874-4203-B5FF-C4B7615B569D}"/>
               </a:ext>
             </a:extLst>
           </p:cNvPr>
@@ -26425,7 +26425,7 @@
           <p:cNvPr id="155" name="Google Shape;155;p6">
             <a:extLst xmlns:a="http://schemas.openxmlformats.org/drawingml/2006/main">
               <a:ext uri="{FF2B5EF4-FFF2-40B4-BE49-F238E27FC236}">
-                <a16:creationId xmlns:a16="http://schemas.microsoft.com/office/drawing/2014/main" id="{B8DD6E64-963F-4CBE-B1D3-006DFEE51EC4}"/>
+                <a16:creationId xmlns:a16="http://schemas.microsoft.com/office/drawing/2014/main" id="{FB3B9816-1DCC-482C-AAAF-035ACD10030A}"/>
               </a:ext>
             </a:extLst>
           </p:cNvPr>
@@ -26497,7 +26497,7 @@
           <p:cNvPr id="156" name="deployment-fact">
             <a:extLst xmlns:a="http://schemas.openxmlformats.org/drawingml/2006/main">
               <a:ext uri="{FF2B5EF4-FFF2-40B4-BE49-F238E27FC236}">
-                <a16:creationId xmlns:a16="http://schemas.microsoft.com/office/drawing/2014/main" id="{6B63300B-1E6D-42EF-80B3-9FFD7BA3DD92}"/>
+                <a16:creationId xmlns:a16="http://schemas.microsoft.com/office/drawing/2014/main" id="{FC011A45-3FD9-41C0-A95C-17D478C94290}"/>
               </a:ext>
             </a:extLst>
           </p:cNvPr>
@@ -26682,7 +26682,7 @@
     </p:spTree>
     <p:extLst>
       <p:ext uri="{BB962C8B-B14F-4D97-AF65-F5344CB8AC3E}">
-        <p14:creationId xmlns:p14="http://schemas.microsoft.com/office/powerpoint/2010/main" val="172764889"/>
+        <p14:creationId xmlns:p14="http://schemas.microsoft.com/office/powerpoint/2010/main" val="1925652600"/>
       </p:ext>
     </p:extLst>
   </p:cSld>
@@ -26713,7 +26713,7 @@
           <p:cNvPr id="161" name="Google Shape;161;p7">
             <a:extLst xmlns:a="http://schemas.openxmlformats.org/drawingml/2006/main">
               <a:ext uri="{FF2B5EF4-FFF2-40B4-BE49-F238E27FC236}">
-                <a16:creationId xmlns:a16="http://schemas.microsoft.com/office/drawing/2014/main" id="{D3810115-52F2-4F09-B658-3840876E2625}"/>
+                <a16:creationId xmlns:a16="http://schemas.microsoft.com/office/drawing/2014/main" id="{8D764A33-AE51-4E6E-8EAC-65AE3337B73A}"/>
               </a:ext>
             </a:extLst>
           </p:cNvPr>
@@ -26785,7 +26785,7 @@
           <p:cNvPr id="162" name="Google Shape;162;p7">
             <a:extLst xmlns:a="http://schemas.openxmlformats.org/drawingml/2006/main">
               <a:ext uri="{FF2B5EF4-FFF2-40B4-BE49-F238E27FC236}">
-                <a16:creationId xmlns:a16="http://schemas.microsoft.com/office/drawing/2014/main" id="{C6AD95F0-28FB-4FEC-845A-AA4E00CFD911}"/>
+                <a16:creationId xmlns:a16="http://schemas.microsoft.com/office/drawing/2014/main" id="{5866B220-C37D-4134-9C5F-995F7B1647F7}"/>
               </a:ext>
             </a:extLst>
           </p:cNvPr>
@@ -26852,7 +26852,7 @@
           <p:cNvPr id="163" name="Google Shape;163;p7">
             <a:extLst xmlns:a="http://schemas.openxmlformats.org/drawingml/2006/main">
               <a:ext uri="{FF2B5EF4-FFF2-40B4-BE49-F238E27FC236}">
-                <a16:creationId xmlns:a16="http://schemas.microsoft.com/office/drawing/2014/main" id="{8F6EA5D2-2544-48F2-A1AE-EC4A1770CCF7}"/>
+                <a16:creationId xmlns:a16="http://schemas.microsoft.com/office/drawing/2014/main" id="{2E4EDBC4-EFEF-4F92-98AF-F2C8D4EEFBC7}"/>
               </a:ext>
             </a:extLst>
           </p:cNvPr>
@@ -26911,7 +26911,7 @@
           <p:cNvPr id="164" name="Google Shape;164;p7">
             <a:extLst xmlns:a="http://schemas.openxmlformats.org/drawingml/2006/main">
               <a:ext uri="{FF2B5EF4-FFF2-40B4-BE49-F238E27FC236}">
-                <a16:creationId xmlns:a16="http://schemas.microsoft.com/office/drawing/2014/main" id="{9193BAC6-E40D-4B71-80F3-7A41D9BBFB11}"/>
+                <a16:creationId xmlns:a16="http://schemas.microsoft.com/office/drawing/2014/main" id="{D9018D51-4F0D-4F4C-A351-A27B73CCD31E}"/>
               </a:ext>
             </a:extLst>
           </p:cNvPr>
@@ -26983,7 +26983,7 @@
           <p:cNvPr id="165" name="Google Shape;165;p7">
             <a:extLst xmlns:a="http://schemas.openxmlformats.org/drawingml/2006/main">
               <a:ext uri="{FF2B5EF4-FFF2-40B4-BE49-F238E27FC236}">
-                <a16:creationId xmlns:a16="http://schemas.microsoft.com/office/drawing/2014/main" id="{D8CE0284-1E73-44EA-B37D-ACA269CAFED6}"/>
+                <a16:creationId xmlns:a16="http://schemas.microsoft.com/office/drawing/2014/main" id="{B6B0B11D-2AE2-458A-8E59-C976B5048BA5}"/>
               </a:ext>
             </a:extLst>
           </p:cNvPr>
@@ -27164,7 +27164,7 @@
           <p:cNvPr id="166" name="Google Shape;166;p7">
             <a:extLst xmlns:a="http://schemas.openxmlformats.org/drawingml/2006/main">
               <a:ext uri="{FF2B5EF4-FFF2-40B4-BE49-F238E27FC236}">
-                <a16:creationId xmlns:a16="http://schemas.microsoft.com/office/drawing/2014/main" id="{42E04509-905F-4375-A49F-CB9F7EC610EB}"/>
+                <a16:creationId xmlns:a16="http://schemas.microsoft.com/office/drawing/2014/main" id="{460D53B4-36B9-4772-A37A-2AB41A00DED8}"/>
               </a:ext>
             </a:extLst>
           </p:cNvPr>
@@ -27174,7 +27174,7 @@
           <p:nvPr/>
         </p:nvPicPr>
         <p:blipFill rotWithShape="1">
-          <a:blip xmlns:r="http://schemas.openxmlformats.org/officeDocument/2006/relationships" xmlns:a="http://schemas.openxmlformats.org/drawingml/2006/main" r:embed="R286e9efaf445434d">
+          <a:blip xmlns:r="http://schemas.openxmlformats.org/officeDocument/2006/relationships" xmlns:a="http://schemas.openxmlformats.org/drawingml/2006/main" r:embed="R2ec40096465a48e6">
             <a:alphaModFix/>
           </a:blip>
           <a:srcRect xmlns:a="http://schemas.openxmlformats.org/drawingml/2006/main" l="-3" t="0" r="-3" b="0"/>
@@ -27198,7 +27198,7 @@
           <p:cNvPr id="167" name="Google Shape;167;p7">
             <a:extLst xmlns:a="http://schemas.openxmlformats.org/drawingml/2006/main">
               <a:ext uri="{FF2B5EF4-FFF2-40B4-BE49-F238E27FC236}">
-                <a16:creationId xmlns:a16="http://schemas.microsoft.com/office/drawing/2014/main" id="{62CBDAE1-6646-4462-9AFB-4DE872F087DE}"/>
+                <a16:creationId xmlns:a16="http://schemas.microsoft.com/office/drawing/2014/main" id="{23F6100D-9735-4BFA-9C03-990BE2306FB6}"/>
               </a:ext>
             </a:extLst>
           </p:cNvPr>
@@ -27257,7 +27257,7 @@
           <p:cNvPr id="168" name="Google Shape;168;p7">
             <a:extLst xmlns:a="http://schemas.openxmlformats.org/drawingml/2006/main">
               <a:ext uri="{FF2B5EF4-FFF2-40B4-BE49-F238E27FC236}">
-                <a16:creationId xmlns:a16="http://schemas.microsoft.com/office/drawing/2014/main" id="{E2B5B6C5-EAC0-41A0-B001-6F352285CE21}"/>
+                <a16:creationId xmlns:a16="http://schemas.microsoft.com/office/drawing/2014/main" id="{219A438F-705C-4767-AC2B-208FF3354249}"/>
               </a:ext>
             </a:extLst>
           </p:cNvPr>
@@ -27329,7 +27329,7 @@
           <p:cNvPr id="169" name="Google Shape;169;p7">
             <a:extLst xmlns:a="http://schemas.openxmlformats.org/drawingml/2006/main">
               <a:ext uri="{FF2B5EF4-FFF2-40B4-BE49-F238E27FC236}">
-                <a16:creationId xmlns:a16="http://schemas.microsoft.com/office/drawing/2014/main" id="{13239D3E-2FD7-4D66-AB87-27E518CFC558}"/>
+                <a16:creationId xmlns:a16="http://schemas.microsoft.com/office/drawing/2014/main" id="{ABAD2901-49C4-481F-91DC-911558396071}"/>
               </a:ext>
             </a:extLst>
           </p:cNvPr>
@@ -27510,7 +27510,7 @@
           <p:cNvPr id="170" name="Google Shape;170;p7">
             <a:extLst xmlns:a="http://schemas.openxmlformats.org/drawingml/2006/main">
               <a:ext uri="{FF2B5EF4-FFF2-40B4-BE49-F238E27FC236}">
-                <a16:creationId xmlns:a16="http://schemas.microsoft.com/office/drawing/2014/main" id="{6B6905BC-8BC1-4EEE-9E41-196AC1F8A40F}"/>
+                <a16:creationId xmlns:a16="http://schemas.microsoft.com/office/drawing/2014/main" id="{537B44EA-CE10-4F49-B339-BF3AB1B3D508}"/>
               </a:ext>
             </a:extLst>
           </p:cNvPr>
@@ -27520,7 +27520,7 @@
           <p:nvPr/>
         </p:nvPicPr>
         <p:blipFill rotWithShape="1">
-          <a:blip xmlns:r="http://schemas.openxmlformats.org/officeDocument/2006/relationships" xmlns:a="http://schemas.openxmlformats.org/drawingml/2006/main" r:embed="R286e9efaf445434d">
+          <a:blip xmlns:r="http://schemas.openxmlformats.org/officeDocument/2006/relationships" xmlns:a="http://schemas.openxmlformats.org/drawingml/2006/main" r:embed="R2ec40096465a48e6">
             <a:alphaModFix/>
           </a:blip>
           <a:srcRect xmlns:a="http://schemas.openxmlformats.org/drawingml/2006/main" l="-3" t="0" r="-3" b="0"/>
@@ -27544,7 +27544,7 @@
           <p:cNvPr id="171" name="Google Shape;171;p7">
             <a:extLst xmlns:a="http://schemas.openxmlformats.org/drawingml/2006/main">
               <a:ext uri="{FF2B5EF4-FFF2-40B4-BE49-F238E27FC236}">
-                <a16:creationId xmlns:a16="http://schemas.microsoft.com/office/drawing/2014/main" id="{50BBA9D4-26F6-4603-B66D-3BCB7C038B68}"/>
+                <a16:creationId xmlns:a16="http://schemas.microsoft.com/office/drawing/2014/main" id="{4C37767D-771C-4AE4-BE39-3B2B9FDFBA3E}"/>
               </a:ext>
             </a:extLst>
           </p:cNvPr>
@@ -27735,7 +27735,7 @@
           <p:cNvPr id="172" name="Google Shape;172;p7">
             <a:extLst xmlns:a="http://schemas.openxmlformats.org/drawingml/2006/main">
               <a:ext uri="{FF2B5EF4-FFF2-40B4-BE49-F238E27FC236}">
-                <a16:creationId xmlns:a16="http://schemas.microsoft.com/office/drawing/2014/main" id="{8AD60570-E722-4EE4-BCA6-F07609B2E658}"/>
+                <a16:creationId xmlns:a16="http://schemas.microsoft.com/office/drawing/2014/main" id="{08A1888C-0AB5-49C3-A8F9-CAC1A789B018}"/>
               </a:ext>
             </a:extLst>
           </p:cNvPr>
@@ -27926,7 +27926,7 @@
           <p:cNvPr id="173" name="Google Shape;173;p7">
             <a:extLst xmlns:a="http://schemas.openxmlformats.org/drawingml/2006/main">
               <a:ext uri="{FF2B5EF4-FFF2-40B4-BE49-F238E27FC236}">
-                <a16:creationId xmlns:a16="http://schemas.microsoft.com/office/drawing/2014/main" id="{38F31A84-46EA-4F9B-BEFE-CC57DD01065C}"/>
+                <a16:creationId xmlns:a16="http://schemas.microsoft.com/office/drawing/2014/main" id="{70E2981F-D2A5-4993-A9EC-4F8BDDAA689A}"/>
               </a:ext>
             </a:extLst>
           </p:cNvPr>
@@ -28117,7 +28117,7 @@
           <p:cNvPr id="174" name="Google Shape;174;p7">
             <a:extLst xmlns:a="http://schemas.openxmlformats.org/drawingml/2006/main">
               <a:ext uri="{FF2B5EF4-FFF2-40B4-BE49-F238E27FC236}">
-                <a16:creationId xmlns:a16="http://schemas.microsoft.com/office/drawing/2014/main" id="{FA45D6BC-4A01-4271-BBC0-F4BAF270D224}"/>
+                <a16:creationId xmlns:a16="http://schemas.microsoft.com/office/drawing/2014/main" id="{7017979F-41AD-498E-87F0-811C08113E68}"/>
               </a:ext>
             </a:extLst>
           </p:cNvPr>
@@ -28127,7 +28127,7 @@
           <p:nvPr/>
         </p:nvPicPr>
         <p:blipFill rotWithShape="1">
-          <a:blip xmlns:r="http://schemas.openxmlformats.org/officeDocument/2006/relationships" xmlns:a="http://schemas.openxmlformats.org/drawingml/2006/main" r:embed="R286e9efaf445434d">
+          <a:blip xmlns:r="http://schemas.openxmlformats.org/officeDocument/2006/relationships" xmlns:a="http://schemas.openxmlformats.org/drawingml/2006/main" r:embed="R2ec40096465a48e6">
             <a:alphaModFix/>
           </a:blip>
           <a:srcRect xmlns:a="http://schemas.openxmlformats.org/drawingml/2006/main" l="-3" t="0" r="-3" b="0"/>
@@ -28151,7 +28151,7 @@
           <p:cNvPr id="175" name="Google Shape;175;p7">
             <a:extLst xmlns:a="http://schemas.openxmlformats.org/drawingml/2006/main">
               <a:ext uri="{FF2B5EF4-FFF2-40B4-BE49-F238E27FC236}">
-                <a16:creationId xmlns:a16="http://schemas.microsoft.com/office/drawing/2014/main" id="{1F6E3E95-1C8E-478F-80B2-9C5E530A02F8}"/>
+                <a16:creationId xmlns:a16="http://schemas.microsoft.com/office/drawing/2014/main" id="{9254F965-8256-45DF-A9BA-988266C61C9B}"/>
               </a:ext>
             </a:extLst>
           </p:cNvPr>
@@ -28210,7 +28210,7 @@
           <p:cNvPr id="176" name="Google Shape;176;p7">
             <a:extLst xmlns:a="http://schemas.openxmlformats.org/drawingml/2006/main">
               <a:ext uri="{FF2B5EF4-FFF2-40B4-BE49-F238E27FC236}">
-                <a16:creationId xmlns:a16="http://schemas.microsoft.com/office/drawing/2014/main" id="{06633744-7234-4453-A88A-D5A07DD1679C}"/>
+                <a16:creationId xmlns:a16="http://schemas.microsoft.com/office/drawing/2014/main" id="{1B7AEA40-2F99-4E02-B385-9780B270C89E}"/>
               </a:ext>
             </a:extLst>
           </p:cNvPr>
@@ -28282,7 +28282,7 @@
           <p:cNvPr id="177" name="Google Shape;177;p7">
             <a:extLst xmlns:a="http://schemas.openxmlformats.org/drawingml/2006/main">
               <a:ext uri="{FF2B5EF4-FFF2-40B4-BE49-F238E27FC236}">
-                <a16:creationId xmlns:a16="http://schemas.microsoft.com/office/drawing/2014/main" id="{990840E6-0811-4235-A50C-709C634F15E0}"/>
+                <a16:creationId xmlns:a16="http://schemas.microsoft.com/office/drawing/2014/main" id="{5F952375-A20D-4918-A890-01A6A78B2B5C}"/>
               </a:ext>
             </a:extLst>
           </p:cNvPr>
@@ -28463,7 +28463,7 @@
           <p:cNvPr id="178" name="Google Shape;178;p7">
             <a:extLst xmlns:a="http://schemas.openxmlformats.org/drawingml/2006/main">
               <a:ext uri="{FF2B5EF4-FFF2-40B4-BE49-F238E27FC236}">
-                <a16:creationId xmlns:a16="http://schemas.microsoft.com/office/drawing/2014/main" id="{267C55E5-0E9D-4C69-A05E-2FBB99CAB142}"/>
+                <a16:creationId xmlns:a16="http://schemas.microsoft.com/office/drawing/2014/main" id="{4C403A29-3BCA-493D-90DE-C8901496724A}"/>
               </a:ext>
             </a:extLst>
           </p:cNvPr>
@@ -28473,7 +28473,7 @@
           <p:nvPr/>
         </p:nvPicPr>
         <p:blipFill rotWithShape="1">
-          <a:blip xmlns:r="http://schemas.openxmlformats.org/officeDocument/2006/relationships" xmlns:a="http://schemas.openxmlformats.org/drawingml/2006/main" r:embed="R286e9efaf445434d">
+          <a:blip xmlns:r="http://schemas.openxmlformats.org/officeDocument/2006/relationships" xmlns:a="http://schemas.openxmlformats.org/drawingml/2006/main" r:embed="R2ec40096465a48e6">
             <a:alphaModFix/>
           </a:blip>
           <a:srcRect xmlns:a="http://schemas.openxmlformats.org/drawingml/2006/main" l="-3" t="0" r="-3" b="0"/>
@@ -28497,7 +28497,7 @@
           <p:cNvPr id="179" name="Google Shape;179;p7">
             <a:extLst xmlns:a="http://schemas.openxmlformats.org/drawingml/2006/main">
               <a:ext uri="{FF2B5EF4-FFF2-40B4-BE49-F238E27FC236}">
-                <a16:creationId xmlns:a16="http://schemas.microsoft.com/office/drawing/2014/main" id="{2CEB8EEC-CF95-4294-B69F-2E13B8819FE7}"/>
+                <a16:creationId xmlns:a16="http://schemas.microsoft.com/office/drawing/2014/main" id="{CA663535-E600-4DB5-A9AE-BC4D339FDF93}"/>
               </a:ext>
             </a:extLst>
           </p:cNvPr>
@@ -28556,7 +28556,7 @@
           <p:cNvPr id="180" name="Google Shape;180;p7">
             <a:extLst xmlns:a="http://schemas.openxmlformats.org/drawingml/2006/main">
               <a:ext uri="{FF2B5EF4-FFF2-40B4-BE49-F238E27FC236}">
-                <a16:creationId xmlns:a16="http://schemas.microsoft.com/office/drawing/2014/main" id="{86124C7C-60BB-45E3-9376-4E879D2456D3}"/>
+                <a16:creationId xmlns:a16="http://schemas.microsoft.com/office/drawing/2014/main" id="{07DD35F3-AB1F-4C97-B15B-ADA0C3615927}"/>
               </a:ext>
             </a:extLst>
           </p:cNvPr>
@@ -28628,7 +28628,7 @@
           <p:cNvPr id="181" name="Google Shape;181;p7">
             <a:extLst xmlns:a="http://schemas.openxmlformats.org/drawingml/2006/main">
               <a:ext uri="{FF2B5EF4-FFF2-40B4-BE49-F238E27FC236}">
-                <a16:creationId xmlns:a16="http://schemas.microsoft.com/office/drawing/2014/main" id="{88BCCD9F-1AB1-4F90-8EF2-5DCB43717AFE}"/>
+                <a16:creationId xmlns:a16="http://schemas.microsoft.com/office/drawing/2014/main" id="{B278B6D7-6F2F-4881-9BAF-FE2E43A2D0F5}"/>
               </a:ext>
             </a:extLst>
           </p:cNvPr>
@@ -28809,7 +28809,7 @@
           <p:cNvPr id="182" name="Google Shape;182;p7">
             <a:extLst xmlns:a="http://schemas.openxmlformats.org/drawingml/2006/main">
               <a:ext uri="{FF2B5EF4-FFF2-40B4-BE49-F238E27FC236}">
-                <a16:creationId xmlns:a16="http://schemas.microsoft.com/office/drawing/2014/main" id="{99BF1AD5-339E-4A91-80FA-79B1601454D5}"/>
+                <a16:creationId xmlns:a16="http://schemas.microsoft.com/office/drawing/2014/main" id="{DEC5297A-384A-4830-9D43-DCA04B9EE41A}"/>
               </a:ext>
             </a:extLst>
           </p:cNvPr>
@@ -28862,7 +28862,7 @@
           <p:cNvPr id="183" name="Google Shape;183;p7">
             <a:extLst xmlns:a="http://schemas.openxmlformats.org/drawingml/2006/main">
               <a:ext uri="{FF2B5EF4-FFF2-40B4-BE49-F238E27FC236}">
-                <a16:creationId xmlns:a16="http://schemas.microsoft.com/office/drawing/2014/main" id="{3E53AB69-FAE2-478E-AAFB-8E124C37AE40}"/>
+                <a16:creationId xmlns:a16="http://schemas.microsoft.com/office/drawing/2014/main" id="{024E60C0-D4A1-489E-B839-1100F1AA9C3A}"/>
               </a:ext>
             </a:extLst>
           </p:cNvPr>
@@ -28934,7 +28934,7 @@
           <p:cNvPr id="184" name="Google Shape;184;p7">
             <a:extLst xmlns:a="http://schemas.openxmlformats.org/drawingml/2006/main">
               <a:ext uri="{FF2B5EF4-FFF2-40B4-BE49-F238E27FC236}">
-                <a16:creationId xmlns:a16="http://schemas.microsoft.com/office/drawing/2014/main" id="{4A4DE337-8920-4707-A30A-595E5328827A}"/>
+                <a16:creationId xmlns:a16="http://schemas.microsoft.com/office/drawing/2014/main" id="{9AD5ED4E-0887-43A6-8B96-3103F7885EA5}"/>
               </a:ext>
             </a:extLst>
           </p:cNvPr>
@@ -29161,7 +29161,7 @@
           <p:cNvPr id="185" name="Google Shape;185;p7">
             <a:extLst xmlns:a="http://schemas.openxmlformats.org/drawingml/2006/main">
               <a:ext uri="{FF2B5EF4-FFF2-40B4-BE49-F238E27FC236}">
-                <a16:creationId xmlns:a16="http://schemas.microsoft.com/office/drawing/2014/main" id="{C0AB3FC4-19EE-4D50-86CF-720DD6151747}"/>
+                <a16:creationId xmlns:a16="http://schemas.microsoft.com/office/drawing/2014/main" id="{6777EB3E-70C4-41E1-914B-F15F0A48383C}"/>
               </a:ext>
             </a:extLst>
           </p:cNvPr>
@@ -29214,7 +29214,7 @@
           <p:cNvPr id="186" name="Google Shape;186;p7">
             <a:extLst xmlns:a="http://schemas.openxmlformats.org/drawingml/2006/main">
               <a:ext uri="{FF2B5EF4-FFF2-40B4-BE49-F238E27FC236}">
-                <a16:creationId xmlns:a16="http://schemas.microsoft.com/office/drawing/2014/main" id="{09F1C374-EAE6-4693-A16D-D179061B2848}"/>
+                <a16:creationId xmlns:a16="http://schemas.microsoft.com/office/drawing/2014/main" id="{92082EA9-8514-4B81-8350-BBFA10AE9EA9}"/>
               </a:ext>
             </a:extLst>
           </p:cNvPr>
@@ -29395,7 +29395,7 @@
           <p:cNvPr id="187" name="Google Shape;187;p7">
             <a:extLst xmlns:a="http://schemas.openxmlformats.org/drawingml/2006/main">
               <a:ext uri="{FF2B5EF4-FFF2-40B4-BE49-F238E27FC236}">
-                <a16:creationId xmlns:a16="http://schemas.microsoft.com/office/drawing/2014/main" id="{FA9598F5-6637-47EC-A611-04DECE97770A}"/>
+                <a16:creationId xmlns:a16="http://schemas.microsoft.com/office/drawing/2014/main" id="{B0141188-FD7E-48E7-A2A7-F400E453524F}"/>
               </a:ext>
             </a:extLst>
           </p:cNvPr>
@@ -29622,7 +29622,7 @@
           <p:cNvPr id="188" name="Google Shape;188;p7">
             <a:extLst xmlns:a="http://schemas.openxmlformats.org/drawingml/2006/main">
               <a:ext uri="{FF2B5EF4-FFF2-40B4-BE49-F238E27FC236}">
-                <a16:creationId xmlns:a16="http://schemas.microsoft.com/office/drawing/2014/main" id="{2E303DF1-8235-47FA-8E85-0AE2F7298420}"/>
+                <a16:creationId xmlns:a16="http://schemas.microsoft.com/office/drawing/2014/main" id="{24E31E42-A7C2-4DC9-8C02-B6BB90460107}"/>
               </a:ext>
             </a:extLst>
           </p:cNvPr>
@@ -29675,7 +29675,7 @@
           <p:cNvPr id="189" name="Google Shape;189;p7">
             <a:extLst xmlns:a="http://schemas.openxmlformats.org/drawingml/2006/main">
               <a:ext uri="{FF2B5EF4-FFF2-40B4-BE49-F238E27FC236}">
-                <a16:creationId xmlns:a16="http://schemas.microsoft.com/office/drawing/2014/main" id="{DF202B32-4856-4646-A8FD-356F7021675E}"/>
+                <a16:creationId xmlns:a16="http://schemas.microsoft.com/office/drawing/2014/main" id="{E627F20D-82E5-44F9-A836-CF1980D4F5B8}"/>
               </a:ext>
             </a:extLst>
           </p:cNvPr>
@@ -29747,7 +29747,7 @@
           <p:cNvPr id="190" name="Google Shape;190;p7">
             <a:extLst xmlns:a="http://schemas.openxmlformats.org/drawingml/2006/main">
               <a:ext uri="{FF2B5EF4-FFF2-40B4-BE49-F238E27FC236}">
-                <a16:creationId xmlns:a16="http://schemas.microsoft.com/office/drawing/2014/main" id="{4AB42E95-6C27-439A-9B10-61767AD27592}"/>
+                <a16:creationId xmlns:a16="http://schemas.microsoft.com/office/drawing/2014/main" id="{57E8F594-3671-4638-ADDB-DC83D04FDA41}"/>
               </a:ext>
             </a:extLst>
           </p:cNvPr>
@@ -29974,7 +29974,7 @@
           <p:cNvPr id="191" name="Google Shape;191;p7">
             <a:extLst xmlns:a="http://schemas.openxmlformats.org/drawingml/2006/main">
               <a:ext uri="{FF2B5EF4-FFF2-40B4-BE49-F238E27FC236}">
-                <a16:creationId xmlns:a16="http://schemas.microsoft.com/office/drawing/2014/main" id="{2467298C-272A-4551-A2FA-34C7E2921254}"/>
+                <a16:creationId xmlns:a16="http://schemas.microsoft.com/office/drawing/2014/main" id="{76F20A56-FFDD-47F4-8207-A3697F359A87}"/>
               </a:ext>
             </a:extLst>
           </p:cNvPr>
@@ -30046,7 +30046,7 @@
           <p:cNvPr id="192" name="Google Shape;192;p7">
             <a:extLst xmlns:a="http://schemas.openxmlformats.org/drawingml/2006/main">
               <a:ext uri="{FF2B5EF4-FFF2-40B4-BE49-F238E27FC236}">
-                <a16:creationId xmlns:a16="http://schemas.microsoft.com/office/drawing/2014/main" id="{C5EC3DDB-7228-42BB-8EE2-0A54D2ED6AB1}"/>
+                <a16:creationId xmlns:a16="http://schemas.microsoft.com/office/drawing/2014/main" id="{5272F009-F4ED-4BF4-ACAF-6631B53AFB83}"/>
               </a:ext>
             </a:extLst>
           </p:cNvPr>
@@ -30118,7 +30118,7 @@
           <p:cNvPr id="193" name="flow-caveat">
             <a:extLst xmlns:a="http://schemas.openxmlformats.org/drawingml/2006/main">
               <a:ext uri="{FF2B5EF4-FFF2-40B4-BE49-F238E27FC236}">
-                <a16:creationId xmlns:a16="http://schemas.microsoft.com/office/drawing/2014/main" id="{EBE99299-F522-46DB-B2D0-003EAAD5BC55}"/>
+                <a16:creationId xmlns:a16="http://schemas.microsoft.com/office/drawing/2014/main" id="{70DD1C75-A93A-4B75-A61B-39EF755C7D9F}"/>
               </a:ext>
             </a:extLst>
           </p:cNvPr>
@@ -30303,7 +30303,7 @@
     </p:spTree>
     <p:extLst>
       <p:ext uri="{BB962C8B-B14F-4D97-AF65-F5344CB8AC3E}">
-        <p14:creationId xmlns:p14="http://schemas.microsoft.com/office/powerpoint/2010/main" val="532360943"/>
+        <p14:creationId xmlns:p14="http://schemas.microsoft.com/office/powerpoint/2010/main" val="1434299239"/>
       </p:ext>
     </p:extLst>
   </p:cSld>
@@ -30334,7 +30334,7 @@
           <p:cNvPr id="198" name="Google Shape;198;p8">
             <a:extLst xmlns:a="http://schemas.openxmlformats.org/drawingml/2006/main">
               <a:ext uri="{FF2B5EF4-FFF2-40B4-BE49-F238E27FC236}">
-                <a16:creationId xmlns:a16="http://schemas.microsoft.com/office/drawing/2014/main" id="{20B7C7C9-7162-4990-B680-92DC100B00C6}"/>
+                <a16:creationId xmlns:a16="http://schemas.microsoft.com/office/drawing/2014/main" id="{C914CEF8-FB8A-45B5-8B58-99B88964149E}"/>
               </a:ext>
             </a:extLst>
           </p:cNvPr>
@@ -30406,7 +30406,7 @@
           <p:cNvPr id="199" name="Google Shape;199;p8">
             <a:extLst xmlns:a="http://schemas.openxmlformats.org/drawingml/2006/main">
               <a:ext uri="{FF2B5EF4-FFF2-40B4-BE49-F238E27FC236}">
-                <a16:creationId xmlns:a16="http://schemas.microsoft.com/office/drawing/2014/main" id="{3896CD73-4DC5-4199-A90C-128F30D8F6FE}"/>
+                <a16:creationId xmlns:a16="http://schemas.microsoft.com/office/drawing/2014/main" id="{FC6A8BDC-A7F1-4EAA-81B5-D8F786167631}"/>
               </a:ext>
             </a:extLst>
           </p:cNvPr>
@@ -30473,7 +30473,7 @@
           <p:cNvPr id="200" name="Google Shape;200;p8">
             <a:extLst xmlns:a="http://schemas.openxmlformats.org/drawingml/2006/main">
               <a:ext uri="{FF2B5EF4-FFF2-40B4-BE49-F238E27FC236}">
-                <a16:creationId xmlns:a16="http://schemas.microsoft.com/office/drawing/2014/main" id="{BDBE9072-DA45-47C3-95B2-C14CE81F6E64}"/>
+                <a16:creationId xmlns:a16="http://schemas.microsoft.com/office/drawing/2014/main" id="{69EF20FC-0662-4FD6-8C40-B8D91CA30231}"/>
               </a:ext>
             </a:extLst>
           </p:cNvPr>
@@ -30504,7 +30504,7 @@
           <p:cNvPr id="201" name="Google Shape;201;p8">
             <a:extLst xmlns:a="http://schemas.openxmlformats.org/drawingml/2006/main">
               <a:ext uri="{FF2B5EF4-FFF2-40B4-BE49-F238E27FC236}">
-                <a16:creationId xmlns:a16="http://schemas.microsoft.com/office/drawing/2014/main" id="{984057AC-A181-43B6-8DB3-D93FFD04DF76}"/>
+                <a16:creationId xmlns:a16="http://schemas.microsoft.com/office/drawing/2014/main" id="{0FA7620D-3AC0-4A0B-AD69-C1E811F399A0}"/>
               </a:ext>
             </a:extLst>
           </p:cNvPr>
@@ -30535,7 +30535,7 @@
           <p:cNvPr id="202" name="Google Shape;202;p8">
             <a:extLst xmlns:a="http://schemas.openxmlformats.org/drawingml/2006/main">
               <a:ext uri="{FF2B5EF4-FFF2-40B4-BE49-F238E27FC236}">
-                <a16:creationId xmlns:a16="http://schemas.microsoft.com/office/drawing/2014/main" id="{B59020D1-5111-46E9-A813-FE5DACD7039D}"/>
+                <a16:creationId xmlns:a16="http://schemas.microsoft.com/office/drawing/2014/main" id="{E0574BDE-9A5C-4D96-BD64-148FEF08ACFE}"/>
               </a:ext>
             </a:extLst>
           </p:cNvPr>
@@ -32366,7 +32366,7 @@
                           <a:ea typeface="IBM Plex Sans KR"/>
                           <a:cs typeface="IBM Plex Sans KR"/>
                         </a:rPr>
-                        <a:t>Streamlit / FastAPI</a:t>
+                        <a:t>수진 UI / 월 달력·관심 과목</a:t>
                       </a:r>
                       <a:endParaRPr sz="1200" u="none" strike="noStrike" cap="none">
                         <a:latin typeface="IBM Plex Sans KR"/>
@@ -32468,7 +32468,7 @@
                           <a:ea typeface="IBM Plex Sans KR"/>
                           <a:cs typeface="IBM Plex Sans KR"/>
                         </a:rPr>
-                        <a:t>화면·계약·실행 단계를 구분</a:t>
+                        <a:t>시안 데이터를 실제 계산에 연결</a:t>
                       </a:r>
                       <a:endParaRPr sz="1200" u="none" strike="noStrike" cap="none">
                         <a:latin typeface="IBM Plex Sans KR"/>
@@ -32503,7 +32503,7 @@
                           <a:ea typeface="IBM Plex Sans KR"/>
                           <a:cs typeface="IBM Plex Sans KR"/>
                         </a:rPr>
-                        <a:t>로컬 파일로 팀 통합</a:t>
+                        <a:t>원본·통합 코드를 함께 보존</a:t>
                       </a:r>
                       <a:endParaRPr sz="1200" u="none" strike="noStrike" cap="none">
                         <a:latin typeface="IBM Plex Sans KR"/>
@@ -32549,7 +32549,7 @@
           <p:cNvPr id="203" name="Google Shape;203;p8">
             <a:extLst xmlns:a="http://schemas.openxmlformats.org/drawingml/2006/main">
               <a:ext uri="{FF2B5EF4-FFF2-40B4-BE49-F238E27FC236}">
-                <a16:creationId xmlns:a16="http://schemas.microsoft.com/office/drawing/2014/main" id="{5CF92AE8-9194-4D51-95AA-7CE2D71C01A3}"/>
+                <a16:creationId xmlns:a16="http://schemas.microsoft.com/office/drawing/2014/main" id="{F52D7767-24ED-4281-8ACF-1B2F9406B9FE}"/>
               </a:ext>
             </a:extLst>
           </p:cNvPr>
@@ -32621,7 +32621,7 @@
           <p:cNvPr id="204" name="Google Shape;204;p8">
             <a:extLst xmlns:a="http://schemas.openxmlformats.org/drawingml/2006/main">
               <a:ext uri="{FF2B5EF4-FFF2-40B4-BE49-F238E27FC236}">
-                <a16:creationId xmlns:a16="http://schemas.microsoft.com/office/drawing/2014/main" id="{511FA6FE-CC19-4F7D-9A35-07553CBCD920}"/>
+                <a16:creationId xmlns:a16="http://schemas.microsoft.com/office/drawing/2014/main" id="{74A39793-CF35-4A40-B213-4E748B0C1C06}"/>
               </a:ext>
             </a:extLst>
           </p:cNvPr>
@@ -32693,7 +32693,7 @@
           <p:cNvPr id="205" name="omission-reasons">
             <a:extLst xmlns:a="http://schemas.openxmlformats.org/drawingml/2006/main">
               <a:ext uri="{FF2B5EF4-FFF2-40B4-BE49-F238E27FC236}">
-                <a16:creationId xmlns:a16="http://schemas.microsoft.com/office/drawing/2014/main" id="{9DC338A4-06EC-46A5-83AB-254B2A0F9355}"/>
+                <a16:creationId xmlns:a16="http://schemas.microsoft.com/office/drawing/2014/main" id="{62666729-2C4D-41DC-82B5-D6BF8617B8C6}"/>
               </a:ext>
             </a:extLst>
           </p:cNvPr>
@@ -32878,7 +32878,7 @@
     </p:spTree>
     <p:extLst>
       <p:ext uri="{BB962C8B-B14F-4D97-AF65-F5344CB8AC3E}">
-        <p14:creationId xmlns:p14="http://schemas.microsoft.com/office/powerpoint/2010/main" val="1333343668"/>
+        <p14:creationId xmlns:p14="http://schemas.microsoft.com/office/powerpoint/2010/main" val="1492421373"/>
       </p:ext>
     </p:extLst>
   </p:cSld>
@@ -32909,7 +32909,7 @@
           <p:cNvPr id="210" name="Google Shape;210;p9">
             <a:extLst xmlns:a="http://schemas.openxmlformats.org/drawingml/2006/main">
               <a:ext uri="{FF2B5EF4-FFF2-40B4-BE49-F238E27FC236}">
-                <a16:creationId xmlns:a16="http://schemas.microsoft.com/office/drawing/2014/main" id="{2E9F68B8-8886-471B-9616-C7242710C7F7}"/>
+                <a16:creationId xmlns:a16="http://schemas.microsoft.com/office/drawing/2014/main" id="{CFE58C72-E8A5-44E9-B858-307480436287}"/>
               </a:ext>
             </a:extLst>
           </p:cNvPr>
@@ -32981,7 +32981,7 @@
           <p:cNvPr id="211" name="Google Shape;211;p9">
             <a:extLst xmlns:a="http://schemas.openxmlformats.org/drawingml/2006/main">
               <a:ext uri="{FF2B5EF4-FFF2-40B4-BE49-F238E27FC236}">
-                <a16:creationId xmlns:a16="http://schemas.microsoft.com/office/drawing/2014/main" id="{F87D46E4-876E-464A-B66F-46683B6606E8}"/>
+                <a16:creationId xmlns:a16="http://schemas.microsoft.com/office/drawing/2014/main" id="{11E0790F-4300-47DA-BF9E-838990B1752B}"/>
               </a:ext>
             </a:extLst>
           </p:cNvPr>
@@ -33048,7 +33048,7 @@
           <p:cNvPr id="212" name="Google Shape;212;p9">
             <a:extLst xmlns:a="http://schemas.openxmlformats.org/drawingml/2006/main">
               <a:ext uri="{FF2B5EF4-FFF2-40B4-BE49-F238E27FC236}">
-                <a16:creationId xmlns:a16="http://schemas.microsoft.com/office/drawing/2014/main" id="{23BE5FB9-BE6D-4F8C-84A1-992655AC8BAE}"/>
+                <a16:creationId xmlns:a16="http://schemas.microsoft.com/office/drawing/2014/main" id="{4F5D863B-86F6-4B13-B856-8094B3F70410}"/>
               </a:ext>
             </a:extLst>
           </p:cNvPr>
@@ -33101,7 +33101,7 @@
           <p:cNvPr id="213" name="Google Shape;213;p9">
             <a:extLst xmlns:a="http://schemas.openxmlformats.org/drawingml/2006/main">
               <a:ext uri="{FF2B5EF4-FFF2-40B4-BE49-F238E27FC236}">
-                <a16:creationId xmlns:a16="http://schemas.microsoft.com/office/drawing/2014/main" id="{ABF1D397-1E59-463F-A87D-48DAAAD74B5B}"/>
+                <a16:creationId xmlns:a16="http://schemas.microsoft.com/office/drawing/2014/main" id="{0EE5D738-9CE4-4345-B59A-4F3C0563B563}"/>
               </a:ext>
             </a:extLst>
           </p:cNvPr>
@@ -33173,7 +33173,7 @@
           <p:cNvPr id="214" name="Google Shape;214;p9">
             <a:extLst xmlns:a="http://schemas.openxmlformats.org/drawingml/2006/main">
               <a:ext uri="{FF2B5EF4-FFF2-40B4-BE49-F238E27FC236}">
-                <a16:creationId xmlns:a16="http://schemas.microsoft.com/office/drawing/2014/main" id="{9A7E2D79-CA23-4FBE-8B87-54552754EC1C}"/>
+                <a16:creationId xmlns:a16="http://schemas.microsoft.com/office/drawing/2014/main" id="{ECF4A18E-CB2E-43E9-8D12-6A645982582B}"/>
               </a:ext>
             </a:extLst>
           </p:cNvPr>
@@ -33354,7 +33354,7 @@
           <p:cNvPr id="215" name="Google Shape;215;p9">
             <a:extLst xmlns:a="http://schemas.openxmlformats.org/drawingml/2006/main">
               <a:ext uri="{FF2B5EF4-FFF2-40B4-BE49-F238E27FC236}">
-                <a16:creationId xmlns:a16="http://schemas.microsoft.com/office/drawing/2014/main" id="{FA97F2E3-CC39-4FE7-9686-D610662F3037}"/>
+                <a16:creationId xmlns:a16="http://schemas.microsoft.com/office/drawing/2014/main" id="{E7444B9D-85C5-466A-B426-C0DC0EAD3474}"/>
               </a:ext>
             </a:extLst>
           </p:cNvPr>
@@ -33407,7 +33407,7 @@
           <p:cNvPr id="216" name="Google Shape;216;p9">
             <a:extLst xmlns:a="http://schemas.openxmlformats.org/drawingml/2006/main">
               <a:ext uri="{FF2B5EF4-FFF2-40B4-BE49-F238E27FC236}">
-                <a16:creationId xmlns:a16="http://schemas.microsoft.com/office/drawing/2014/main" id="{47739602-EE9B-46B1-8CC6-F69555D02299}"/>
+                <a16:creationId xmlns:a16="http://schemas.microsoft.com/office/drawing/2014/main" id="{2B14E820-D3C1-44DE-BA05-379A1219602F}"/>
               </a:ext>
             </a:extLst>
           </p:cNvPr>
@@ -33479,7 +33479,7 @@
           <p:cNvPr id="217" name="Google Shape;217;p9">
             <a:extLst xmlns:a="http://schemas.openxmlformats.org/drawingml/2006/main">
               <a:ext uri="{FF2B5EF4-FFF2-40B4-BE49-F238E27FC236}">
-                <a16:creationId xmlns:a16="http://schemas.microsoft.com/office/drawing/2014/main" id="{EA29D40C-AF67-4FAA-89D6-668B463C6A5E}"/>
+                <a16:creationId xmlns:a16="http://schemas.microsoft.com/office/drawing/2014/main" id="{FB0154BB-7BD1-40B3-8DE6-F7CACF75252A}"/>
               </a:ext>
             </a:extLst>
           </p:cNvPr>
@@ -33660,7 +33660,7 @@
           <p:cNvPr id="218" name="Google Shape;218;p9">
             <a:extLst xmlns:a="http://schemas.openxmlformats.org/drawingml/2006/main">
               <a:ext uri="{FF2B5EF4-FFF2-40B4-BE49-F238E27FC236}">
-                <a16:creationId xmlns:a16="http://schemas.microsoft.com/office/drawing/2014/main" id="{054D0B4C-21F8-4082-A6AB-284A6DE3B49E}"/>
+                <a16:creationId xmlns:a16="http://schemas.microsoft.com/office/drawing/2014/main" id="{9FEB8136-4C23-466F-953D-FFF2DB53498F}"/>
               </a:ext>
             </a:extLst>
           </p:cNvPr>
@@ -33713,7 +33713,7 @@
           <p:cNvPr id="219" name="Google Shape;219;p9">
             <a:extLst xmlns:a="http://schemas.openxmlformats.org/drawingml/2006/main">
               <a:ext uri="{FF2B5EF4-FFF2-40B4-BE49-F238E27FC236}">
-                <a16:creationId xmlns:a16="http://schemas.microsoft.com/office/drawing/2014/main" id="{2CD3CB76-06D7-44C4-864F-C53A621644B2}"/>
+                <a16:creationId xmlns:a16="http://schemas.microsoft.com/office/drawing/2014/main" id="{D3446614-264C-4219-9F20-83B0543D08CA}"/>
               </a:ext>
             </a:extLst>
           </p:cNvPr>
@@ -33785,7 +33785,7 @@
           <p:cNvPr id="220" name="Google Shape;220;p9">
             <a:extLst xmlns:a="http://schemas.openxmlformats.org/drawingml/2006/main">
               <a:ext uri="{FF2B5EF4-FFF2-40B4-BE49-F238E27FC236}">
-                <a16:creationId xmlns:a16="http://schemas.microsoft.com/office/drawing/2014/main" id="{F1D295BC-0650-487E-B448-94865B478670}"/>
+                <a16:creationId xmlns:a16="http://schemas.microsoft.com/office/drawing/2014/main" id="{1100D15F-6F86-4A1D-80FD-474300D13FC7}"/>
               </a:ext>
             </a:extLst>
           </p:cNvPr>
@@ -33966,7 +33966,7 @@
           <p:cNvPr id="221" name="Google Shape;221;p9">
             <a:extLst xmlns:a="http://schemas.openxmlformats.org/drawingml/2006/main">
               <a:ext uri="{FF2B5EF4-FFF2-40B4-BE49-F238E27FC236}">
-                <a16:creationId xmlns:a16="http://schemas.microsoft.com/office/drawing/2014/main" id="{3FB8B21F-6912-42E2-97DC-CEFCB9304263}"/>
+                <a16:creationId xmlns:a16="http://schemas.microsoft.com/office/drawing/2014/main" id="{51283401-0E2F-42F3-AD95-01A7394A49FE}"/>
               </a:ext>
             </a:extLst>
           </p:cNvPr>
@@ -34019,7 +34019,7 @@
           <p:cNvPr id="222" name="Google Shape;222;p9">
             <a:extLst xmlns:a="http://schemas.openxmlformats.org/drawingml/2006/main">
               <a:ext uri="{FF2B5EF4-FFF2-40B4-BE49-F238E27FC236}">
-                <a16:creationId xmlns:a16="http://schemas.microsoft.com/office/drawing/2014/main" id="{2B761094-69CE-489C-BF71-EDE3EFD2CE19}"/>
+                <a16:creationId xmlns:a16="http://schemas.microsoft.com/office/drawing/2014/main" id="{7C130359-709F-4D55-8B2A-37EAB91F4493}"/>
               </a:ext>
             </a:extLst>
           </p:cNvPr>
@@ -34091,7 +34091,7 @@
           <p:cNvPr id="223" name="Google Shape;223;p9">
             <a:extLst xmlns:a="http://schemas.openxmlformats.org/drawingml/2006/main">
               <a:ext uri="{FF2B5EF4-FFF2-40B4-BE49-F238E27FC236}">
-                <a16:creationId xmlns:a16="http://schemas.microsoft.com/office/drawing/2014/main" id="{E28180D0-40D9-493A-B29D-14346C1B261C}"/>
+                <a16:creationId xmlns:a16="http://schemas.microsoft.com/office/drawing/2014/main" id="{CD59F279-017C-478A-A489-EC09A4C2BF7B}"/>
               </a:ext>
             </a:extLst>
           </p:cNvPr>
@@ -34272,7 +34272,7 @@
           <p:cNvPr id="224" name="Google Shape;224;p9">
             <a:extLst xmlns:a="http://schemas.openxmlformats.org/drawingml/2006/main">
               <a:ext uri="{FF2B5EF4-FFF2-40B4-BE49-F238E27FC236}">
-                <a16:creationId xmlns:a16="http://schemas.microsoft.com/office/drawing/2014/main" id="{A5A61926-D3AC-4829-94D5-0490A2D34D3F}"/>
+                <a16:creationId xmlns:a16="http://schemas.microsoft.com/office/drawing/2014/main" id="{8444827D-AAF5-4C0A-8C6C-A9EF4FE203E9}"/>
               </a:ext>
             </a:extLst>
           </p:cNvPr>
@@ -34331,7 +34331,7 @@
           <p:cNvPr id="225" name="Google Shape;225;p9">
             <a:extLst xmlns:a="http://schemas.openxmlformats.org/drawingml/2006/main">
               <a:ext uri="{FF2B5EF4-FFF2-40B4-BE49-F238E27FC236}">
-                <a16:creationId xmlns:a16="http://schemas.microsoft.com/office/drawing/2014/main" id="{FC018C5B-2ABE-4376-9D8C-7BB9A3050CD0}"/>
+                <a16:creationId xmlns:a16="http://schemas.microsoft.com/office/drawing/2014/main" id="{FE2250D3-601A-4195-B6BA-6841FE34DFDD}"/>
               </a:ext>
             </a:extLst>
           </p:cNvPr>
@@ -34742,7 +34742,7 @@
           <p:cNvPr id="226" name="Google Shape;226;p9">
             <a:extLst xmlns:a="http://schemas.openxmlformats.org/drawingml/2006/main">
               <a:ext uri="{FF2B5EF4-FFF2-40B4-BE49-F238E27FC236}">
-                <a16:creationId xmlns:a16="http://schemas.microsoft.com/office/drawing/2014/main" id="{1B0CD3F2-3699-4914-A8D8-AECA28446EB2}"/>
+                <a16:creationId xmlns:a16="http://schemas.microsoft.com/office/drawing/2014/main" id="{10FA7FA1-67ED-43A6-9929-48A704B98057}"/>
               </a:ext>
             </a:extLst>
           </p:cNvPr>
@@ -34923,7 +34923,7 @@
           <p:cNvPr id="227" name="Google Shape;227;p9">
             <a:extLst xmlns:a="http://schemas.openxmlformats.org/drawingml/2006/main">
               <a:ext uri="{FF2B5EF4-FFF2-40B4-BE49-F238E27FC236}">
-                <a16:creationId xmlns:a16="http://schemas.microsoft.com/office/drawing/2014/main" id="{9C1DADA4-5D4E-410E-8AEB-4EED45999C10}"/>
+                <a16:creationId xmlns:a16="http://schemas.microsoft.com/office/drawing/2014/main" id="{99AE61F8-8EBE-4423-A405-87ED5E13848C}"/>
               </a:ext>
             </a:extLst>
           </p:cNvPr>
@@ -34995,7 +34995,7 @@
           <p:cNvPr id="228" name="Google Shape;228;p9">
             <a:extLst xmlns:a="http://schemas.openxmlformats.org/drawingml/2006/main">
               <a:ext uri="{FF2B5EF4-FFF2-40B4-BE49-F238E27FC236}">
-                <a16:creationId xmlns:a16="http://schemas.microsoft.com/office/drawing/2014/main" id="{FC4C0552-2216-43F4-8CDF-85FFA6D82915}"/>
+                <a16:creationId xmlns:a16="http://schemas.microsoft.com/office/drawing/2014/main" id="{0DBFAD7F-6E01-43B6-82C4-0C6C841DEAE6}"/>
               </a:ext>
             </a:extLst>
           </p:cNvPr>
@@ -35065,7 +35065,7 @@
     </p:spTree>
     <p:extLst>
       <p:ext uri="{BB962C8B-B14F-4D97-AF65-F5344CB8AC3E}">
-        <p14:creationId xmlns:p14="http://schemas.microsoft.com/office/powerpoint/2010/main" val="929267150"/>
+        <p14:creationId xmlns:p14="http://schemas.microsoft.com/office/powerpoint/2010/main" val="916374389"/>
       </p:ext>
     </p:extLst>
   </p:cSld>

</xml_diff>